<commit_message>
finished chapter Navier Stokes in SL1
</commit_message>
<xml_diff>
--- a/LaTeX B.Sc. LRT/Strömungslehre 1/images/SL1-Images.pptx
+++ b/LaTeX B.Sc. LRT/Strömungslehre 1/images/SL1-Images.pptx
@@ -14,6 +14,7 @@
     <p:sldId id="262" r:id="rId8"/>
     <p:sldId id="263" r:id="rId9"/>
     <p:sldId id="264" r:id="rId10"/>
+    <p:sldId id="265" r:id="rId11"/>
   </p:sldIdLst>
   <p:sldSz cx="3600450" cy="3600450"/>
   <p:notesSz cx="6858000" cy="9144000"/>
@@ -251,7 +252,7 @@
           <a:p>
             <a:fld id="{0F04D7A0-D8C8-4B74-9611-9A000801FA36}" type="datetimeFigureOut">
               <a:rPr lang="de-DE" smtClean="0"/>
-              <a:t>09.09.2026</a:t>
+              <a:t>18.09.2026</a:t>
             </a:fld>
             <a:endParaRPr lang="de-DE"/>
           </a:p>
@@ -421,7 +422,7 @@
           <a:p>
             <a:fld id="{0F04D7A0-D8C8-4B74-9611-9A000801FA36}" type="datetimeFigureOut">
               <a:rPr lang="de-DE" smtClean="0"/>
-              <a:t>09.09.2026</a:t>
+              <a:t>18.09.2026</a:t>
             </a:fld>
             <a:endParaRPr lang="de-DE"/>
           </a:p>
@@ -601,7 +602,7 @@
           <a:p>
             <a:fld id="{0F04D7A0-D8C8-4B74-9611-9A000801FA36}" type="datetimeFigureOut">
               <a:rPr lang="de-DE" smtClean="0"/>
-              <a:t>09.09.2026</a:t>
+              <a:t>18.09.2026</a:t>
             </a:fld>
             <a:endParaRPr lang="de-DE"/>
           </a:p>
@@ -771,7 +772,7 @@
           <a:p>
             <a:fld id="{0F04D7A0-D8C8-4B74-9611-9A000801FA36}" type="datetimeFigureOut">
               <a:rPr lang="de-DE" smtClean="0"/>
-              <a:t>09.09.2026</a:t>
+              <a:t>18.09.2026</a:t>
             </a:fld>
             <a:endParaRPr lang="de-DE"/>
           </a:p>
@@ -1017,7 +1018,7 @@
           <a:p>
             <a:fld id="{0F04D7A0-D8C8-4B74-9611-9A000801FA36}" type="datetimeFigureOut">
               <a:rPr lang="de-DE" smtClean="0"/>
-              <a:t>09.09.2026</a:t>
+              <a:t>18.09.2026</a:t>
             </a:fld>
             <a:endParaRPr lang="de-DE"/>
           </a:p>
@@ -1249,7 +1250,7 @@
           <a:p>
             <a:fld id="{0F04D7A0-D8C8-4B74-9611-9A000801FA36}" type="datetimeFigureOut">
               <a:rPr lang="de-DE" smtClean="0"/>
-              <a:t>09.09.2026</a:t>
+              <a:t>18.09.2026</a:t>
             </a:fld>
             <a:endParaRPr lang="de-DE"/>
           </a:p>
@@ -1616,7 +1617,7 @@
           <a:p>
             <a:fld id="{0F04D7A0-D8C8-4B74-9611-9A000801FA36}" type="datetimeFigureOut">
               <a:rPr lang="de-DE" smtClean="0"/>
-              <a:t>09.09.2026</a:t>
+              <a:t>18.09.2026</a:t>
             </a:fld>
             <a:endParaRPr lang="de-DE"/>
           </a:p>
@@ -1734,7 +1735,7 @@
           <a:p>
             <a:fld id="{0F04D7A0-D8C8-4B74-9611-9A000801FA36}" type="datetimeFigureOut">
               <a:rPr lang="de-DE" smtClean="0"/>
-              <a:t>09.09.2026</a:t>
+              <a:t>18.09.2026</a:t>
             </a:fld>
             <a:endParaRPr lang="de-DE"/>
           </a:p>
@@ -1829,7 +1830,7 @@
           <a:p>
             <a:fld id="{0F04D7A0-D8C8-4B74-9611-9A000801FA36}" type="datetimeFigureOut">
               <a:rPr lang="de-DE" smtClean="0"/>
-              <a:t>09.09.2026</a:t>
+              <a:t>18.09.2026</a:t>
             </a:fld>
             <a:endParaRPr lang="de-DE"/>
           </a:p>
@@ -2106,7 +2107,7 @@
           <a:p>
             <a:fld id="{0F04D7A0-D8C8-4B74-9611-9A000801FA36}" type="datetimeFigureOut">
               <a:rPr lang="de-DE" smtClean="0"/>
-              <a:t>09.09.2026</a:t>
+              <a:t>18.09.2026</a:t>
             </a:fld>
             <a:endParaRPr lang="de-DE"/>
           </a:p>
@@ -2363,7 +2364,7 @@
           <a:p>
             <a:fld id="{0F04D7A0-D8C8-4B74-9611-9A000801FA36}" type="datetimeFigureOut">
               <a:rPr lang="de-DE" smtClean="0"/>
-              <a:t>09.09.2026</a:t>
+              <a:t>18.09.2026</a:t>
             </a:fld>
             <a:endParaRPr lang="de-DE"/>
           </a:p>
@@ -2576,7 +2577,7 @@
           <a:p>
             <a:fld id="{0F04D7A0-D8C8-4B74-9611-9A000801FA36}" type="datetimeFigureOut">
               <a:rPr lang="de-DE" smtClean="0"/>
-              <a:t>09.09.2026</a:t>
+              <a:t>18.09.2026</a:t>
             </a:fld>
             <a:endParaRPr lang="de-DE"/>
           </a:p>
@@ -4037,6 +4038,42 @@
 </p:sld>
 </file>
 
+<file path=ppt/slides/slide10.xml><?xml version="1.0" encoding="utf-8"?>
+<p:sld xmlns:a="http://schemas.openxmlformats.org/drawingml/2006/main" xmlns:r="http://schemas.openxmlformats.org/officeDocument/2006/relationships" xmlns:p="http://schemas.openxmlformats.org/presentationml/2006/main">
+  <p:cSld>
+    <p:spTree>
+      <p:nvGrpSpPr>
+        <p:cNvPr id="1" name="">
+          <a:extLst>
+            <a:ext uri="{FF2B5EF4-FFF2-40B4-BE49-F238E27FC236}">
+              <a16:creationId xmlns:a16="http://schemas.microsoft.com/office/drawing/2014/main" id="{99F757FE-FA90-5ACE-877D-86AD85ADC8C2}"/>
+            </a:ext>
+          </a:extLst>
+        </p:cNvPr>
+        <p:cNvGrpSpPr/>
+        <p:nvPr/>
+      </p:nvGrpSpPr>
+      <p:grpSpPr>
+        <a:xfrm>
+          <a:off x="0" y="0"/>
+          <a:ext cx="0" cy="0"/>
+          <a:chOff x="0" y="0"/>
+          <a:chExt cx="0" cy="0"/>
+        </a:xfrm>
+      </p:grpSpPr>
+    </p:spTree>
+    <p:extLst>
+      <p:ext uri="{BB962C8B-B14F-4D97-AF65-F5344CB8AC3E}">
+        <p14:creationId xmlns:p14="http://schemas.microsoft.com/office/powerpoint/2010/main" val="2180941687"/>
+      </p:ext>
+    </p:extLst>
+  </p:cSld>
+  <p:clrMapOvr>
+    <a:masterClrMapping/>
+  </p:clrMapOvr>
+</p:sld>
+</file>
+
 <file path=ppt/slides/slide2.xml><?xml version="1.0" encoding="utf-8"?>
 <p:sld xmlns:a="http://schemas.openxmlformats.org/drawingml/2006/main" xmlns:r="http://schemas.openxmlformats.org/officeDocument/2006/relationships" xmlns:p="http://schemas.openxmlformats.org/presentationml/2006/main">
   <p:cSld>
@@ -15796,6 +15833,999 @@
           <a:chExt cx="0" cy="0"/>
         </a:xfrm>
       </p:grpSpPr>
+      <p:sp>
+        <p:nvSpPr>
+          <p:cNvPr id="4" name="Ellipse 3">
+            <a:extLst>
+              <a:ext uri="{FF2B5EF4-FFF2-40B4-BE49-F238E27FC236}">
+                <a16:creationId xmlns:a16="http://schemas.microsoft.com/office/drawing/2014/main" id="{092BD284-703D-C949-9341-2A821A7DC3DB}"/>
+              </a:ext>
+            </a:extLst>
+          </p:cNvPr>
+          <p:cNvSpPr/>
+          <p:nvPr/>
+        </p:nvSpPr>
+        <p:spPr>
+          <a:xfrm>
+            <a:off x="650080" y="650081"/>
+            <a:ext cx="2300290" cy="2300288"/>
+          </a:xfrm>
+          <a:prstGeom prst="ellipse">
+            <a:avLst/>
+          </a:prstGeom>
+          <a:solidFill>
+            <a:schemeClr val="tx2">
+              <a:lumMod val="75000"/>
+              <a:lumOff val="25000"/>
+              <a:alpha val="35000"/>
+            </a:schemeClr>
+          </a:solidFill>
+          <a:ln>
+            <a:solidFill>
+              <a:schemeClr val="tx2">
+                <a:lumMod val="75000"/>
+                <a:lumOff val="25000"/>
+              </a:schemeClr>
+            </a:solidFill>
+          </a:ln>
+        </p:spPr>
+        <p:style>
+          <a:lnRef idx="2">
+            <a:schemeClr val="accent1">
+              <a:shade val="15000"/>
+            </a:schemeClr>
+          </a:lnRef>
+          <a:fillRef idx="1">
+            <a:schemeClr val="accent1"/>
+          </a:fillRef>
+          <a:effectRef idx="0">
+            <a:schemeClr val="accent1"/>
+          </a:effectRef>
+          <a:fontRef idx="minor">
+            <a:schemeClr val="lt1"/>
+          </a:fontRef>
+        </p:style>
+        <p:txBody>
+          <a:bodyPr rtlCol="0" anchor="ctr"/>
+          <a:lstStyle/>
+          <a:p>
+            <a:pPr algn="ctr"/>
+            <a:endParaRPr lang="de-DE" dirty="0"/>
+          </a:p>
+        </p:txBody>
+      </p:sp>
+      <p:sp>
+        <p:nvSpPr>
+          <p:cNvPr id="2" name="Ellipse 1">
+            <a:extLst>
+              <a:ext uri="{FF2B5EF4-FFF2-40B4-BE49-F238E27FC236}">
+                <a16:creationId xmlns:a16="http://schemas.microsoft.com/office/drawing/2014/main" id="{1E6B04C0-3255-B23E-A6CF-F9CA9A275473}"/>
+              </a:ext>
+            </a:extLst>
+          </p:cNvPr>
+          <p:cNvSpPr/>
+          <p:nvPr/>
+        </p:nvSpPr>
+        <p:spPr>
+          <a:xfrm>
+            <a:off x="1028699" y="1028700"/>
+            <a:ext cx="1543052" cy="1543050"/>
+          </a:xfrm>
+          <a:prstGeom prst="ellipse">
+            <a:avLst/>
+          </a:prstGeom>
+          <a:solidFill>
+            <a:schemeClr val="bg1"/>
+          </a:solidFill>
+          <a:ln>
+            <a:solidFill>
+              <a:schemeClr val="tx2">
+                <a:lumMod val="75000"/>
+                <a:lumOff val="25000"/>
+              </a:schemeClr>
+            </a:solidFill>
+          </a:ln>
+        </p:spPr>
+        <p:style>
+          <a:lnRef idx="2">
+            <a:schemeClr val="accent1">
+              <a:shade val="15000"/>
+            </a:schemeClr>
+          </a:lnRef>
+          <a:fillRef idx="1">
+            <a:schemeClr val="accent1"/>
+          </a:fillRef>
+          <a:effectRef idx="0">
+            <a:schemeClr val="accent1"/>
+          </a:effectRef>
+          <a:fontRef idx="minor">
+            <a:schemeClr val="lt1"/>
+          </a:fontRef>
+        </p:style>
+        <p:txBody>
+          <a:bodyPr rtlCol="0" anchor="ctr"/>
+          <a:lstStyle/>
+          <a:p>
+            <a:pPr algn="ctr"/>
+            <a:endParaRPr lang="de-DE"/>
+          </a:p>
+        </p:txBody>
+      </p:sp>
+      <p:sp>
+        <p:nvSpPr>
+          <p:cNvPr id="5" name="Ellipse 4">
+            <a:extLst>
+              <a:ext uri="{FF2B5EF4-FFF2-40B4-BE49-F238E27FC236}">
+                <a16:creationId xmlns:a16="http://schemas.microsoft.com/office/drawing/2014/main" id="{84548968-C1B2-50B7-EA78-511C2D39DA8C}"/>
+              </a:ext>
+            </a:extLst>
+          </p:cNvPr>
+          <p:cNvSpPr/>
+          <p:nvPr/>
+        </p:nvSpPr>
+        <p:spPr>
+          <a:xfrm>
+            <a:off x="1762124" y="1762126"/>
+            <a:ext cx="76202" cy="76198"/>
+          </a:xfrm>
+          <a:prstGeom prst="ellipse">
+            <a:avLst/>
+          </a:prstGeom>
+          <a:solidFill>
+            <a:schemeClr val="tx1"/>
+          </a:solidFill>
+          <a:ln>
+            <a:noFill/>
+          </a:ln>
+        </p:spPr>
+        <p:style>
+          <a:lnRef idx="2">
+            <a:schemeClr val="accent1">
+              <a:shade val="15000"/>
+            </a:schemeClr>
+          </a:lnRef>
+          <a:fillRef idx="1">
+            <a:schemeClr val="accent1"/>
+          </a:fillRef>
+          <a:effectRef idx="0">
+            <a:schemeClr val="accent1"/>
+          </a:effectRef>
+          <a:fontRef idx="minor">
+            <a:schemeClr val="lt1"/>
+          </a:fontRef>
+        </p:style>
+        <p:txBody>
+          <a:bodyPr rtlCol="0" anchor="ctr"/>
+          <a:lstStyle/>
+          <a:p>
+            <a:pPr algn="ctr"/>
+            <a:endParaRPr lang="de-DE"/>
+          </a:p>
+        </p:txBody>
+      </p:sp>
+      <p:cxnSp>
+        <p:nvCxnSpPr>
+          <p:cNvPr id="9" name="Gerade Verbindung mit Pfeil 8">
+            <a:extLst>
+              <a:ext uri="{FF2B5EF4-FFF2-40B4-BE49-F238E27FC236}">
+                <a16:creationId xmlns:a16="http://schemas.microsoft.com/office/drawing/2014/main" id="{3CE74CBC-975A-586A-A8CD-113158C28F67}"/>
+              </a:ext>
+            </a:extLst>
+          </p:cNvPr>
+          <p:cNvCxnSpPr>
+            <a:cxnSpLocks/>
+          </p:cNvCxnSpPr>
+          <p:nvPr/>
+        </p:nvCxnSpPr>
+        <p:spPr>
+          <a:xfrm flipH="1">
+            <a:off x="1030605" y="1800225"/>
+            <a:ext cx="769620" cy="0"/>
+          </a:xfrm>
+          <a:prstGeom prst="straightConnector1">
+            <a:avLst/>
+          </a:prstGeom>
+          <a:ln w="15875" cap="rnd">
+            <a:round/>
+            <a:headEnd w="med" len="med"/>
+            <a:tailEnd type="triangle"/>
+          </a:ln>
+        </p:spPr>
+        <p:style>
+          <a:lnRef idx="2">
+            <a:schemeClr val="dk1"/>
+          </a:lnRef>
+          <a:fillRef idx="0">
+            <a:schemeClr val="dk1"/>
+          </a:fillRef>
+          <a:effectRef idx="1">
+            <a:schemeClr val="dk1"/>
+          </a:effectRef>
+          <a:fontRef idx="minor">
+            <a:schemeClr val="tx1"/>
+          </a:fontRef>
+        </p:style>
+      </p:cxnSp>
+      <p:cxnSp>
+        <p:nvCxnSpPr>
+          <p:cNvPr id="11" name="Gerade Verbindung mit Pfeil 10">
+            <a:extLst>
+              <a:ext uri="{FF2B5EF4-FFF2-40B4-BE49-F238E27FC236}">
+                <a16:creationId xmlns:a16="http://schemas.microsoft.com/office/drawing/2014/main" id="{26760A96-D8C7-39FB-B84E-2C699AB7E234}"/>
+              </a:ext>
+            </a:extLst>
+          </p:cNvPr>
+          <p:cNvCxnSpPr>
+            <a:cxnSpLocks/>
+          </p:cNvCxnSpPr>
+          <p:nvPr/>
+        </p:nvCxnSpPr>
+        <p:spPr>
+          <a:xfrm flipH="1">
+            <a:off x="649605" y="1800225"/>
+            <a:ext cx="379094" cy="0"/>
+          </a:xfrm>
+          <a:prstGeom prst="straightConnector1">
+            <a:avLst/>
+          </a:prstGeom>
+          <a:ln w="15875" cap="rnd">
+            <a:round/>
+            <a:headEnd type="triangle" w="med" len="med"/>
+            <a:tailEnd type="triangle"/>
+          </a:ln>
+        </p:spPr>
+        <p:style>
+          <a:lnRef idx="2">
+            <a:schemeClr val="dk1"/>
+          </a:lnRef>
+          <a:fillRef idx="0">
+            <a:schemeClr val="dk1"/>
+          </a:fillRef>
+          <a:effectRef idx="1">
+            <a:schemeClr val="dk1"/>
+          </a:effectRef>
+          <a:fontRef idx="minor">
+            <a:schemeClr val="tx1"/>
+          </a:fontRef>
+        </p:style>
+      </p:cxnSp>
+      <p:sp>
+        <p:nvSpPr>
+          <p:cNvPr id="16" name="Textfeld 15">
+            <a:extLst>
+              <a:ext uri="{FF2B5EF4-FFF2-40B4-BE49-F238E27FC236}">
+                <a16:creationId xmlns:a16="http://schemas.microsoft.com/office/drawing/2014/main" id="{E7D57EE9-C696-E831-9CEB-A2DFBC784AFA}"/>
+              </a:ext>
+            </a:extLst>
+          </p:cNvPr>
+          <p:cNvSpPr txBox="1"/>
+          <p:nvPr/>
+        </p:nvSpPr>
+        <p:spPr>
+          <a:xfrm>
+            <a:off x="702575" y="1541980"/>
+            <a:ext cx="288023" cy="276999"/>
+          </a:xfrm>
+          <a:prstGeom prst="rect">
+            <a:avLst/>
+          </a:prstGeom>
+          <a:noFill/>
+        </p:spPr>
+        <p:txBody>
+          <a:bodyPr wrap="square" rtlCol="0" anchor="ctr">
+            <a:spAutoFit/>
+          </a:bodyPr>
+          <a:lstStyle/>
+          <a:p>
+            <a:pPr algn="ctr"/>
+            <a:r>
+              <a:rPr lang="de-DE" sz="1200" i="1" dirty="0">
+                <a:latin typeface="CMU Serif" panose="02000603000000000000" pitchFamily="2" charset="0"/>
+                <a:ea typeface="CMU Serif" panose="02000603000000000000" pitchFamily="2" charset="0"/>
+                <a:cs typeface="CMU Serif" panose="02000603000000000000" pitchFamily="2" charset="0"/>
+              </a:rPr>
+              <a:t>h</a:t>
+            </a:r>
+            <a:endParaRPr lang="de-DE" sz="1200" baseline="-25000" dirty="0">
+              <a:latin typeface="CMU Serif" panose="02000603000000000000" pitchFamily="2" charset="0"/>
+              <a:ea typeface="CMU Serif" panose="02000603000000000000" pitchFamily="2" charset="0"/>
+              <a:cs typeface="CMU Serif" panose="02000603000000000000" pitchFamily="2" charset="0"/>
+            </a:endParaRPr>
+          </a:p>
+        </p:txBody>
+      </p:sp>
+      <p:sp>
+        <p:nvSpPr>
+          <p:cNvPr id="18" name="Textfeld 17">
+            <a:extLst>
+              <a:ext uri="{FF2B5EF4-FFF2-40B4-BE49-F238E27FC236}">
+                <a16:creationId xmlns:a16="http://schemas.microsoft.com/office/drawing/2014/main" id="{2238B7B2-AD94-33DC-128C-BEB7198A4FA7}"/>
+              </a:ext>
+            </a:extLst>
+          </p:cNvPr>
+          <p:cNvSpPr txBox="1"/>
+          <p:nvPr/>
+        </p:nvSpPr>
+        <p:spPr>
+          <a:xfrm>
+            <a:off x="1284791" y="1541979"/>
+            <a:ext cx="343349" cy="276999"/>
+          </a:xfrm>
+          <a:prstGeom prst="rect">
+            <a:avLst/>
+          </a:prstGeom>
+          <a:noFill/>
+        </p:spPr>
+        <p:txBody>
+          <a:bodyPr wrap="square" rtlCol="0" anchor="ctr">
+            <a:spAutoFit/>
+          </a:bodyPr>
+          <a:lstStyle/>
+          <a:p>
+            <a:pPr algn="ctr"/>
+            <a:r>
+              <a:rPr lang="de-DE" sz="1200" i="1" dirty="0">
+                <a:latin typeface="CMU Serif" panose="02000603000000000000" pitchFamily="2" charset="0"/>
+                <a:ea typeface="CMU Serif" panose="02000603000000000000" pitchFamily="2" charset="0"/>
+                <a:cs typeface="CMU Serif" panose="02000603000000000000" pitchFamily="2" charset="0"/>
+              </a:rPr>
+              <a:t>r</a:t>
+            </a:r>
+            <a:r>
+              <a:rPr lang="de-DE" sz="1200" baseline="-25000" dirty="0">
+                <a:latin typeface="CMU Serif" panose="02000603000000000000" pitchFamily="2" charset="0"/>
+                <a:ea typeface="CMU Serif" panose="02000603000000000000" pitchFamily="2" charset="0"/>
+                <a:cs typeface="CMU Serif" panose="02000603000000000000" pitchFamily="2" charset="0"/>
+              </a:rPr>
+              <a:t>0</a:t>
+            </a:r>
+          </a:p>
+        </p:txBody>
+      </p:sp>
+      <p:sp>
+        <p:nvSpPr>
+          <p:cNvPr id="20" name="Textfeld 19">
+            <a:extLst>
+              <a:ext uri="{FF2B5EF4-FFF2-40B4-BE49-F238E27FC236}">
+                <a16:creationId xmlns:a16="http://schemas.microsoft.com/office/drawing/2014/main" id="{030B60BF-6856-6D1B-DEFF-95BBFDEA8DC2}"/>
+              </a:ext>
+            </a:extLst>
+          </p:cNvPr>
+          <p:cNvSpPr txBox="1"/>
+          <p:nvPr/>
+        </p:nvSpPr>
+        <p:spPr>
+          <a:xfrm>
+            <a:off x="2625436" y="749638"/>
+            <a:ext cx="408249" cy="307777"/>
+          </a:xfrm>
+          <a:prstGeom prst="rect">
+            <a:avLst/>
+          </a:prstGeom>
+          <a:noFill/>
+        </p:spPr>
+        <p:txBody>
+          <a:bodyPr wrap="square" rtlCol="0" anchor="ctr">
+            <a:spAutoFit/>
+          </a:bodyPr>
+          <a:lstStyle/>
+          <a:p>
+            <a:pPr algn="ctr"/>
+            <a:r>
+              <a:rPr lang="de-DE" sz="1400" i="1" dirty="0">
+                <a:solidFill>
+                  <a:schemeClr val="accent6">
+                    <a:lumMod val="75000"/>
+                  </a:schemeClr>
+                </a:solidFill>
+                <a:latin typeface="Latin Modern Math" panose="02000503000000000000" pitchFamily="50" charset="0"/>
+                <a:ea typeface="Latin Modern Math" panose="02000503000000000000" pitchFamily="50" charset="0"/>
+                <a:cs typeface="CMU Serif" panose="02000603000000000000" pitchFamily="2" charset="0"/>
+              </a:rPr>
+              <a:t>ω</a:t>
+            </a:r>
+            <a:endParaRPr lang="de-DE" sz="1400" i="1" baseline="-25000" dirty="0">
+              <a:solidFill>
+                <a:schemeClr val="accent6">
+                  <a:lumMod val="75000"/>
+                </a:schemeClr>
+              </a:solidFill>
+              <a:latin typeface="CMU Serif" panose="02000603000000000000" pitchFamily="2" charset="0"/>
+              <a:ea typeface="CMU Serif" panose="02000603000000000000" pitchFamily="2" charset="0"/>
+              <a:cs typeface="CMU Serif" panose="02000603000000000000" pitchFamily="2" charset="0"/>
+            </a:endParaRPr>
+          </a:p>
+        </p:txBody>
+      </p:sp>
+      <p:sp>
+        <p:nvSpPr>
+          <p:cNvPr id="21" name="Bogen 20">
+            <a:extLst>
+              <a:ext uri="{FF2B5EF4-FFF2-40B4-BE49-F238E27FC236}">
+                <a16:creationId xmlns:a16="http://schemas.microsoft.com/office/drawing/2014/main" id="{B23BFAC8-960D-CC7F-A549-67BBE4F74A3A}"/>
+              </a:ext>
+            </a:extLst>
+          </p:cNvPr>
+          <p:cNvSpPr/>
+          <p:nvPr/>
+        </p:nvSpPr>
+        <p:spPr>
+          <a:xfrm>
+            <a:off x="544830" y="544830"/>
+            <a:ext cx="2510790" cy="2510790"/>
+          </a:xfrm>
+          <a:prstGeom prst="arc">
+            <a:avLst>
+              <a:gd name="adj1" fmla="val 18319024"/>
+              <a:gd name="adj2" fmla="val 19998905"/>
+            </a:avLst>
+          </a:prstGeom>
+          <a:ln cap="rnd">
+            <a:solidFill>
+              <a:schemeClr val="accent6">
+                <a:lumMod val="75000"/>
+              </a:schemeClr>
+            </a:solidFill>
+            <a:round/>
+            <a:tailEnd type="triangle"/>
+          </a:ln>
+        </p:spPr>
+        <p:style>
+          <a:lnRef idx="2">
+            <a:schemeClr val="accent1"/>
+          </a:lnRef>
+          <a:fillRef idx="0">
+            <a:schemeClr val="accent1"/>
+          </a:fillRef>
+          <a:effectRef idx="1">
+            <a:schemeClr val="accent1"/>
+          </a:effectRef>
+          <a:fontRef idx="minor">
+            <a:schemeClr val="tx1"/>
+          </a:fontRef>
+        </p:style>
+        <p:txBody>
+          <a:bodyPr rtlCol="0" anchor="ctr"/>
+          <a:lstStyle/>
+          <a:p>
+            <a:pPr algn="ctr"/>
+            <a:endParaRPr lang="de-DE"/>
+          </a:p>
+        </p:txBody>
+      </p:sp>
+      <p:sp>
+        <p:nvSpPr>
+          <p:cNvPr id="23" name="Bogen 22">
+            <a:extLst>
+              <a:ext uri="{FF2B5EF4-FFF2-40B4-BE49-F238E27FC236}">
+                <a16:creationId xmlns:a16="http://schemas.microsoft.com/office/drawing/2014/main" id="{25C8DA70-0C54-BA24-7479-EE409F6DCAB2}"/>
+              </a:ext>
+            </a:extLst>
+          </p:cNvPr>
+          <p:cNvSpPr/>
+          <p:nvPr/>
+        </p:nvSpPr>
+        <p:spPr>
+          <a:xfrm>
+            <a:off x="958850" y="958850"/>
+            <a:ext cx="1682750" cy="1682750"/>
+          </a:xfrm>
+          <a:prstGeom prst="arc">
+            <a:avLst>
+              <a:gd name="adj1" fmla="val 1303464"/>
+              <a:gd name="adj2" fmla="val 3460986"/>
+            </a:avLst>
+          </a:prstGeom>
+          <a:ln cap="rnd">
+            <a:solidFill>
+              <a:schemeClr val="accent5">
+                <a:lumMod val="75000"/>
+              </a:schemeClr>
+            </a:solidFill>
+            <a:round/>
+            <a:tailEnd type="triangle"/>
+          </a:ln>
+        </p:spPr>
+        <p:style>
+          <a:lnRef idx="2">
+            <a:schemeClr val="accent1"/>
+          </a:lnRef>
+          <a:fillRef idx="0">
+            <a:schemeClr val="accent1"/>
+          </a:fillRef>
+          <a:effectRef idx="1">
+            <a:schemeClr val="accent1"/>
+          </a:effectRef>
+          <a:fontRef idx="minor">
+            <a:schemeClr val="tx1"/>
+          </a:fontRef>
+        </p:style>
+        <p:txBody>
+          <a:bodyPr rtlCol="0" anchor="ctr"/>
+          <a:lstStyle/>
+          <a:p>
+            <a:pPr algn="ctr"/>
+            <a:endParaRPr lang="de-DE"/>
+          </a:p>
+        </p:txBody>
+      </p:sp>
+      <p:sp>
+        <p:nvSpPr>
+          <p:cNvPr id="25" name="Textfeld 24">
+            <a:extLst>
+              <a:ext uri="{FF2B5EF4-FFF2-40B4-BE49-F238E27FC236}">
+                <a16:creationId xmlns:a16="http://schemas.microsoft.com/office/drawing/2014/main" id="{56F1A1CA-E306-330D-3D60-F1C1570A35A6}"/>
+              </a:ext>
+            </a:extLst>
+          </p:cNvPr>
+          <p:cNvSpPr txBox="1"/>
+          <p:nvPr/>
+        </p:nvSpPr>
+        <p:spPr>
+          <a:xfrm>
+            <a:off x="2372921" y="2263973"/>
+            <a:ext cx="408249" cy="307777"/>
+          </a:xfrm>
+          <a:prstGeom prst="rect">
+            <a:avLst/>
+          </a:prstGeom>
+          <a:noFill/>
+        </p:spPr>
+        <p:txBody>
+          <a:bodyPr wrap="square" rtlCol="0" anchor="ctr">
+            <a:spAutoFit/>
+          </a:bodyPr>
+          <a:lstStyle/>
+          <a:p>
+            <a:pPr algn="ctr"/>
+            <a:r>
+              <a:rPr lang="de-DE" sz="1400" i="1" dirty="0" err="1">
+                <a:solidFill>
+                  <a:schemeClr val="accent5">
+                    <a:lumMod val="75000"/>
+                  </a:schemeClr>
+                </a:solidFill>
+                <a:latin typeface="Latin Modern Math" panose="02000503000000000000" pitchFamily="50" charset="0"/>
+                <a:ea typeface="Latin Modern Math" panose="02000503000000000000" pitchFamily="50" charset="0"/>
+                <a:cs typeface="CMU Serif" panose="02000603000000000000" pitchFamily="2" charset="0"/>
+              </a:rPr>
+              <a:t>τ</a:t>
+            </a:r>
+            <a:r>
+              <a:rPr lang="de-DE" sz="1400" baseline="-25000" dirty="0" err="1">
+                <a:solidFill>
+                  <a:schemeClr val="accent5">
+                    <a:lumMod val="75000"/>
+                  </a:schemeClr>
+                </a:solidFill>
+                <a:latin typeface="CMU Serif" panose="02000603000000000000" pitchFamily="2" charset="0"/>
+                <a:ea typeface="CMU Serif" panose="02000603000000000000" pitchFamily="2" charset="0"/>
+                <a:cs typeface="CMU Serif" panose="02000603000000000000" pitchFamily="2" charset="0"/>
+              </a:rPr>
+              <a:t>W</a:t>
+            </a:r>
+            <a:endParaRPr lang="de-DE" sz="1400" baseline="-25000" dirty="0">
+              <a:solidFill>
+                <a:schemeClr val="accent5">
+                  <a:lumMod val="75000"/>
+                </a:schemeClr>
+              </a:solidFill>
+              <a:latin typeface="CMU Serif" panose="02000603000000000000" pitchFamily="2" charset="0"/>
+              <a:ea typeface="CMU Serif" panose="02000603000000000000" pitchFamily="2" charset="0"/>
+              <a:cs typeface="CMU Serif" panose="02000603000000000000" pitchFamily="2" charset="0"/>
+            </a:endParaRPr>
+          </a:p>
+        </p:txBody>
+      </p:sp>
+      <p:cxnSp>
+        <p:nvCxnSpPr>
+          <p:cNvPr id="27" name="Gerader Verbinder 26">
+            <a:extLst>
+              <a:ext uri="{FF2B5EF4-FFF2-40B4-BE49-F238E27FC236}">
+                <a16:creationId xmlns:a16="http://schemas.microsoft.com/office/drawing/2014/main" id="{C9119DA7-D656-4799-4985-D6E437AD6669}"/>
+              </a:ext>
+            </a:extLst>
+          </p:cNvPr>
+          <p:cNvCxnSpPr>
+            <a:cxnSpLocks/>
+            <a:stCxn id="2" idx="0"/>
+            <a:endCxn id="4" idx="0"/>
+          </p:cNvCxnSpPr>
+          <p:nvPr/>
+        </p:nvCxnSpPr>
+        <p:spPr>
+          <a:xfrm flipV="1">
+            <a:off x="1800225" y="650081"/>
+            <a:ext cx="0" cy="378619"/>
+          </a:xfrm>
+          <a:prstGeom prst="line">
+            <a:avLst/>
+          </a:prstGeom>
+          <a:ln w="15875" cap="rnd">
+            <a:solidFill>
+              <a:schemeClr val="accent1">
+                <a:lumMod val="75000"/>
+              </a:schemeClr>
+            </a:solidFill>
+            <a:round/>
+          </a:ln>
+        </p:spPr>
+        <p:style>
+          <a:lnRef idx="2">
+            <a:schemeClr val="accent1"/>
+          </a:lnRef>
+          <a:fillRef idx="0">
+            <a:schemeClr val="accent1"/>
+          </a:fillRef>
+          <a:effectRef idx="1">
+            <a:schemeClr val="accent1"/>
+          </a:effectRef>
+          <a:fontRef idx="minor">
+            <a:schemeClr val="tx1"/>
+          </a:fontRef>
+        </p:style>
+      </p:cxnSp>
+      <p:cxnSp>
+        <p:nvCxnSpPr>
+          <p:cNvPr id="30" name="Gerader Verbinder 29">
+            <a:extLst>
+              <a:ext uri="{FF2B5EF4-FFF2-40B4-BE49-F238E27FC236}">
+                <a16:creationId xmlns:a16="http://schemas.microsoft.com/office/drawing/2014/main" id="{8C8E6AEF-BF7C-1B79-573B-30D0A9B8CB8E}"/>
+              </a:ext>
+            </a:extLst>
+          </p:cNvPr>
+          <p:cNvCxnSpPr>
+            <a:cxnSpLocks/>
+            <a:endCxn id="2" idx="0"/>
+          </p:cNvCxnSpPr>
+          <p:nvPr/>
+        </p:nvCxnSpPr>
+        <p:spPr>
+          <a:xfrm flipH="1">
+            <a:off x="1800225" y="653415"/>
+            <a:ext cx="375285" cy="375285"/>
+          </a:xfrm>
+          <a:prstGeom prst="line">
+            <a:avLst/>
+          </a:prstGeom>
+          <a:ln w="15875" cap="rnd">
+            <a:solidFill>
+              <a:schemeClr val="accent1">
+                <a:lumMod val="75000"/>
+              </a:schemeClr>
+            </a:solidFill>
+            <a:round/>
+          </a:ln>
+        </p:spPr>
+        <p:style>
+          <a:lnRef idx="2">
+            <a:schemeClr val="accent1"/>
+          </a:lnRef>
+          <a:fillRef idx="0">
+            <a:schemeClr val="accent1"/>
+          </a:fillRef>
+          <a:effectRef idx="1">
+            <a:schemeClr val="accent1"/>
+          </a:effectRef>
+          <a:fontRef idx="minor">
+            <a:schemeClr val="tx1"/>
+          </a:fontRef>
+        </p:style>
+      </p:cxnSp>
+      <p:cxnSp>
+        <p:nvCxnSpPr>
+          <p:cNvPr id="33" name="Gerader Verbinder 32">
+            <a:extLst>
+              <a:ext uri="{FF2B5EF4-FFF2-40B4-BE49-F238E27FC236}">
+                <a16:creationId xmlns:a16="http://schemas.microsoft.com/office/drawing/2014/main" id="{B9631579-6B20-E5C1-E588-9BFF3A9C3F4B}"/>
+              </a:ext>
+            </a:extLst>
+          </p:cNvPr>
+          <p:cNvCxnSpPr>
+            <a:cxnSpLocks/>
+            <a:endCxn id="4" idx="0"/>
+          </p:cNvCxnSpPr>
+          <p:nvPr/>
+        </p:nvCxnSpPr>
+        <p:spPr>
+          <a:xfrm flipH="1">
+            <a:off x="1800225" y="650081"/>
+            <a:ext cx="382905" cy="0"/>
+          </a:xfrm>
+          <a:prstGeom prst="line">
+            <a:avLst/>
+          </a:prstGeom>
+          <a:ln w="15875" cap="rnd">
+            <a:solidFill>
+              <a:schemeClr val="accent1">
+                <a:lumMod val="75000"/>
+              </a:schemeClr>
+            </a:solidFill>
+            <a:round/>
+            <a:headEnd type="triangle"/>
+            <a:tailEnd type="none"/>
+          </a:ln>
+        </p:spPr>
+        <p:style>
+          <a:lnRef idx="2">
+            <a:schemeClr val="accent1"/>
+          </a:lnRef>
+          <a:fillRef idx="0">
+            <a:schemeClr val="accent1"/>
+          </a:fillRef>
+          <a:effectRef idx="1">
+            <a:schemeClr val="accent1"/>
+          </a:effectRef>
+          <a:fontRef idx="minor">
+            <a:schemeClr val="tx1"/>
+          </a:fontRef>
+        </p:style>
+      </p:cxnSp>
+      <p:cxnSp>
+        <p:nvCxnSpPr>
+          <p:cNvPr id="37" name="Gerader Verbinder 36">
+            <a:extLst>
+              <a:ext uri="{FF2B5EF4-FFF2-40B4-BE49-F238E27FC236}">
+                <a16:creationId xmlns:a16="http://schemas.microsoft.com/office/drawing/2014/main" id="{B2B24CB7-B560-1DB8-9173-4C7DE769F3C5}"/>
+              </a:ext>
+            </a:extLst>
+          </p:cNvPr>
+          <p:cNvCxnSpPr>
+            <a:cxnSpLocks/>
+          </p:cNvCxnSpPr>
+          <p:nvPr/>
+        </p:nvCxnSpPr>
+        <p:spPr>
+          <a:xfrm flipH="1">
+            <a:off x="1800225" y="751046"/>
+            <a:ext cx="278130" cy="0"/>
+          </a:xfrm>
+          <a:prstGeom prst="line">
+            <a:avLst/>
+          </a:prstGeom>
+          <a:ln w="15875" cap="rnd">
+            <a:solidFill>
+              <a:schemeClr val="accent1">
+                <a:lumMod val="75000"/>
+              </a:schemeClr>
+            </a:solidFill>
+            <a:round/>
+            <a:headEnd type="triangle"/>
+            <a:tailEnd type="none"/>
+          </a:ln>
+        </p:spPr>
+        <p:style>
+          <a:lnRef idx="2">
+            <a:schemeClr val="accent1"/>
+          </a:lnRef>
+          <a:fillRef idx="0">
+            <a:schemeClr val="accent1"/>
+          </a:fillRef>
+          <a:effectRef idx="1">
+            <a:schemeClr val="accent1"/>
+          </a:effectRef>
+          <a:fontRef idx="minor">
+            <a:schemeClr val="tx1"/>
+          </a:fontRef>
+        </p:style>
+      </p:cxnSp>
+      <p:cxnSp>
+        <p:nvCxnSpPr>
+          <p:cNvPr id="39" name="Gerader Verbinder 38">
+            <a:extLst>
+              <a:ext uri="{FF2B5EF4-FFF2-40B4-BE49-F238E27FC236}">
+                <a16:creationId xmlns:a16="http://schemas.microsoft.com/office/drawing/2014/main" id="{9E43B868-D4F8-C53F-C13D-ABF0EAF4B517}"/>
+              </a:ext>
+            </a:extLst>
+          </p:cNvPr>
+          <p:cNvCxnSpPr>
+            <a:cxnSpLocks/>
+          </p:cNvCxnSpPr>
+          <p:nvPr/>
+        </p:nvCxnSpPr>
+        <p:spPr>
+          <a:xfrm flipH="1">
+            <a:off x="1800225" y="848201"/>
+            <a:ext cx="180975" cy="0"/>
+          </a:xfrm>
+          <a:prstGeom prst="line">
+            <a:avLst/>
+          </a:prstGeom>
+          <a:ln w="15875" cap="rnd">
+            <a:solidFill>
+              <a:schemeClr val="accent1">
+                <a:lumMod val="75000"/>
+              </a:schemeClr>
+            </a:solidFill>
+            <a:round/>
+            <a:headEnd type="triangle"/>
+            <a:tailEnd type="none"/>
+          </a:ln>
+        </p:spPr>
+        <p:style>
+          <a:lnRef idx="2">
+            <a:schemeClr val="accent1"/>
+          </a:lnRef>
+          <a:fillRef idx="0">
+            <a:schemeClr val="accent1"/>
+          </a:fillRef>
+          <a:effectRef idx="1">
+            <a:schemeClr val="accent1"/>
+          </a:effectRef>
+          <a:fontRef idx="minor">
+            <a:schemeClr val="tx1"/>
+          </a:fontRef>
+        </p:style>
+      </p:cxnSp>
+      <p:cxnSp>
+        <p:nvCxnSpPr>
+          <p:cNvPr id="41" name="Gerader Verbinder 40">
+            <a:extLst>
+              <a:ext uri="{FF2B5EF4-FFF2-40B4-BE49-F238E27FC236}">
+                <a16:creationId xmlns:a16="http://schemas.microsoft.com/office/drawing/2014/main" id="{5D712309-264B-8517-3761-24F4E65B2318}"/>
+              </a:ext>
+            </a:extLst>
+          </p:cNvPr>
+          <p:cNvCxnSpPr>
+            <a:cxnSpLocks/>
+          </p:cNvCxnSpPr>
+          <p:nvPr/>
+        </p:nvCxnSpPr>
+        <p:spPr>
+          <a:xfrm flipH="1">
+            <a:off x="1800225" y="943451"/>
+            <a:ext cx="91440" cy="0"/>
+          </a:xfrm>
+          <a:prstGeom prst="line">
+            <a:avLst/>
+          </a:prstGeom>
+          <a:ln w="15875" cap="rnd">
+            <a:solidFill>
+              <a:schemeClr val="accent1">
+                <a:lumMod val="75000"/>
+              </a:schemeClr>
+            </a:solidFill>
+            <a:round/>
+            <a:headEnd type="triangle"/>
+            <a:tailEnd type="none"/>
+          </a:ln>
+        </p:spPr>
+        <p:style>
+          <a:lnRef idx="2">
+            <a:schemeClr val="accent1"/>
+          </a:lnRef>
+          <a:fillRef idx="0">
+            <a:schemeClr val="accent1"/>
+          </a:fillRef>
+          <a:effectRef idx="1">
+            <a:schemeClr val="accent1"/>
+          </a:effectRef>
+          <a:fontRef idx="minor">
+            <a:schemeClr val="tx1"/>
+          </a:fontRef>
+        </p:style>
+      </p:cxnSp>
+      <p:sp>
+        <p:nvSpPr>
+          <p:cNvPr id="45" name="Textfeld 44">
+            <a:extLst>
+              <a:ext uri="{FF2B5EF4-FFF2-40B4-BE49-F238E27FC236}">
+                <a16:creationId xmlns:a16="http://schemas.microsoft.com/office/drawing/2014/main" id="{A69406BC-FB00-740E-92CC-EC6CD3CAE18F}"/>
+              </a:ext>
+            </a:extLst>
+          </p:cNvPr>
+          <p:cNvSpPr txBox="1"/>
+          <p:nvPr/>
+        </p:nvSpPr>
+        <p:spPr>
+          <a:xfrm>
+            <a:off x="1743075" y="344924"/>
+            <a:ext cx="440055" cy="276999"/>
+          </a:xfrm>
+          <a:prstGeom prst="rect">
+            <a:avLst/>
+          </a:prstGeom>
+          <a:noFill/>
+        </p:spPr>
+        <p:txBody>
+          <a:bodyPr wrap="square" rtlCol="0" anchor="ctr">
+            <a:spAutoFit/>
+          </a:bodyPr>
+          <a:lstStyle/>
+          <a:p>
+            <a:pPr algn="ctr"/>
+            <a:r>
+              <a:rPr lang="de-DE" sz="1200" i="1" dirty="0" err="1">
+                <a:solidFill>
+                  <a:schemeClr val="accent1">
+                    <a:lumMod val="75000"/>
+                  </a:schemeClr>
+                </a:solidFill>
+                <a:latin typeface="CMU Serif" panose="02000603000000000000" pitchFamily="2" charset="0"/>
+                <a:ea typeface="CMU Serif" panose="02000603000000000000" pitchFamily="2" charset="0"/>
+                <a:cs typeface="CMU Serif" panose="02000603000000000000" pitchFamily="2" charset="0"/>
+              </a:rPr>
+              <a:t>u</a:t>
+            </a:r>
+            <a:r>
+              <a:rPr lang="de-DE" sz="1200" baseline="-25000" dirty="0" err="1">
+                <a:solidFill>
+                  <a:schemeClr val="accent1">
+                    <a:lumMod val="75000"/>
+                  </a:schemeClr>
+                </a:solidFill>
+                <a:latin typeface="CMU Serif" panose="02000603000000000000" pitchFamily="2" charset="0"/>
+                <a:ea typeface="CMU Serif" panose="02000603000000000000" pitchFamily="2" charset="0"/>
+                <a:cs typeface="CMU Serif" panose="02000603000000000000" pitchFamily="2" charset="0"/>
+              </a:rPr>
+              <a:t>W</a:t>
+            </a:r>
+            <a:endParaRPr lang="de-DE" sz="1200" baseline="-25000" dirty="0">
+              <a:solidFill>
+                <a:schemeClr val="accent1">
+                  <a:lumMod val="75000"/>
+                </a:schemeClr>
+              </a:solidFill>
+              <a:latin typeface="CMU Serif" panose="02000603000000000000" pitchFamily="2" charset="0"/>
+              <a:ea typeface="CMU Serif" panose="02000603000000000000" pitchFamily="2" charset="0"/>
+              <a:cs typeface="CMU Serif" panose="02000603000000000000" pitchFamily="2" charset="0"/>
+            </a:endParaRPr>
+          </a:p>
+        </p:txBody>
+      </p:sp>
+      <p:sp>
+        <p:nvSpPr>
+          <p:cNvPr id="47" name="Textfeld 46">
+            <a:extLst>
+              <a:ext uri="{FF2B5EF4-FFF2-40B4-BE49-F238E27FC236}">
+                <a16:creationId xmlns:a16="http://schemas.microsoft.com/office/drawing/2014/main" id="{BF3FF2AE-28DF-567E-FADE-6A292EA82A18}"/>
+              </a:ext>
+            </a:extLst>
+          </p:cNvPr>
+          <p:cNvSpPr txBox="1"/>
+          <p:nvPr/>
+        </p:nvSpPr>
+        <p:spPr>
+          <a:xfrm>
+            <a:off x="1666241" y="1485423"/>
+            <a:ext cx="421006" cy="276999"/>
+          </a:xfrm>
+          <a:prstGeom prst="rect">
+            <a:avLst/>
+          </a:prstGeom>
+          <a:noFill/>
+        </p:spPr>
+        <p:txBody>
+          <a:bodyPr wrap="square" rtlCol="0" anchor="ctr">
+            <a:spAutoFit/>
+          </a:bodyPr>
+          <a:lstStyle/>
+          <a:p>
+            <a:pPr algn="ctr"/>
+            <a:r>
+              <a:rPr lang="de-DE" sz="1200" i="1" dirty="0" err="1">
+                <a:latin typeface="CMU Serif" panose="02000603000000000000" pitchFamily="2" charset="0"/>
+                <a:ea typeface="CMU Serif" panose="02000603000000000000" pitchFamily="2" charset="0"/>
+                <a:cs typeface="CMU Serif" panose="02000603000000000000" pitchFamily="2" charset="0"/>
+              </a:rPr>
+              <a:t>M</a:t>
+            </a:r>
+            <a:r>
+              <a:rPr lang="de-DE" sz="1200" baseline="-25000" dirty="0" err="1">
+                <a:latin typeface="CMU Serif" panose="02000603000000000000" pitchFamily="2" charset="0"/>
+                <a:ea typeface="CMU Serif" panose="02000603000000000000" pitchFamily="2" charset="0"/>
+                <a:cs typeface="CMU Serif" panose="02000603000000000000" pitchFamily="2" charset="0"/>
+              </a:rPr>
+              <a:t>h</a:t>
+            </a:r>
+            <a:endParaRPr lang="de-DE" sz="1200" baseline="-25000" dirty="0">
+              <a:latin typeface="CMU Serif" panose="02000603000000000000" pitchFamily="2" charset="0"/>
+              <a:ea typeface="CMU Serif" panose="02000603000000000000" pitchFamily="2" charset="0"/>
+              <a:cs typeface="CMU Serif" panose="02000603000000000000" pitchFamily="2" charset="0"/>
+            </a:endParaRPr>
+          </a:p>
+        </p:txBody>
+      </p:sp>
     </p:spTree>
     <p:extLst>
       <p:ext uri="{BB962C8B-B14F-4D97-AF65-F5344CB8AC3E}">

</xml_diff>

<commit_message>
finished chapter Grenzschichten in SL1
</commit_message>
<xml_diff>
--- a/LaTeX B.Sc. LRT/Strömungslehre 1/images/SL1-Images.pptx
+++ b/LaTeX B.Sc. LRT/Strömungslehre 1/images/SL1-Images.pptx
@@ -15,6 +15,8 @@
     <p:sldId id="263" r:id="rId9"/>
     <p:sldId id="264" r:id="rId10"/>
     <p:sldId id="265" r:id="rId11"/>
+    <p:sldId id="266" r:id="rId12"/>
+    <p:sldId id="267" r:id="rId13"/>
   </p:sldIdLst>
   <p:sldSz cx="3600450" cy="3600450"/>
   <p:notesSz cx="6858000" cy="9144000"/>
@@ -252,7 +254,7 @@
           <a:p>
             <a:fld id="{0F04D7A0-D8C8-4B74-9611-9A000801FA36}" type="datetimeFigureOut">
               <a:rPr lang="de-DE" smtClean="0"/>
-              <a:t>18.09.2026</a:t>
+              <a:t>22.09.2026</a:t>
             </a:fld>
             <a:endParaRPr lang="de-DE"/>
           </a:p>
@@ -422,7 +424,7 @@
           <a:p>
             <a:fld id="{0F04D7A0-D8C8-4B74-9611-9A000801FA36}" type="datetimeFigureOut">
               <a:rPr lang="de-DE" smtClean="0"/>
-              <a:t>18.09.2026</a:t>
+              <a:t>22.09.2026</a:t>
             </a:fld>
             <a:endParaRPr lang="de-DE"/>
           </a:p>
@@ -602,7 +604,7 @@
           <a:p>
             <a:fld id="{0F04D7A0-D8C8-4B74-9611-9A000801FA36}" type="datetimeFigureOut">
               <a:rPr lang="de-DE" smtClean="0"/>
-              <a:t>18.09.2026</a:t>
+              <a:t>22.09.2026</a:t>
             </a:fld>
             <a:endParaRPr lang="de-DE"/>
           </a:p>
@@ -772,7 +774,7 @@
           <a:p>
             <a:fld id="{0F04D7A0-D8C8-4B74-9611-9A000801FA36}" type="datetimeFigureOut">
               <a:rPr lang="de-DE" smtClean="0"/>
-              <a:t>18.09.2026</a:t>
+              <a:t>22.09.2026</a:t>
             </a:fld>
             <a:endParaRPr lang="de-DE"/>
           </a:p>
@@ -1018,7 +1020,7 @@
           <a:p>
             <a:fld id="{0F04D7A0-D8C8-4B74-9611-9A000801FA36}" type="datetimeFigureOut">
               <a:rPr lang="de-DE" smtClean="0"/>
-              <a:t>18.09.2026</a:t>
+              <a:t>22.09.2026</a:t>
             </a:fld>
             <a:endParaRPr lang="de-DE"/>
           </a:p>
@@ -1250,7 +1252,7 @@
           <a:p>
             <a:fld id="{0F04D7A0-D8C8-4B74-9611-9A000801FA36}" type="datetimeFigureOut">
               <a:rPr lang="de-DE" smtClean="0"/>
-              <a:t>18.09.2026</a:t>
+              <a:t>22.09.2026</a:t>
             </a:fld>
             <a:endParaRPr lang="de-DE"/>
           </a:p>
@@ -1617,7 +1619,7 @@
           <a:p>
             <a:fld id="{0F04D7A0-D8C8-4B74-9611-9A000801FA36}" type="datetimeFigureOut">
               <a:rPr lang="de-DE" smtClean="0"/>
-              <a:t>18.09.2026</a:t>
+              <a:t>22.09.2026</a:t>
             </a:fld>
             <a:endParaRPr lang="de-DE"/>
           </a:p>
@@ -1735,7 +1737,7 @@
           <a:p>
             <a:fld id="{0F04D7A0-D8C8-4B74-9611-9A000801FA36}" type="datetimeFigureOut">
               <a:rPr lang="de-DE" smtClean="0"/>
-              <a:t>18.09.2026</a:t>
+              <a:t>22.09.2026</a:t>
             </a:fld>
             <a:endParaRPr lang="de-DE"/>
           </a:p>
@@ -1830,7 +1832,7 @@
           <a:p>
             <a:fld id="{0F04D7A0-D8C8-4B74-9611-9A000801FA36}" type="datetimeFigureOut">
               <a:rPr lang="de-DE" smtClean="0"/>
-              <a:t>18.09.2026</a:t>
+              <a:t>22.09.2026</a:t>
             </a:fld>
             <a:endParaRPr lang="de-DE"/>
           </a:p>
@@ -2107,7 +2109,7 @@
           <a:p>
             <a:fld id="{0F04D7A0-D8C8-4B74-9611-9A000801FA36}" type="datetimeFigureOut">
               <a:rPr lang="de-DE" smtClean="0"/>
-              <a:t>18.09.2026</a:t>
+              <a:t>22.09.2026</a:t>
             </a:fld>
             <a:endParaRPr lang="de-DE"/>
           </a:p>
@@ -2364,7 +2366,7 @@
           <a:p>
             <a:fld id="{0F04D7A0-D8C8-4B74-9611-9A000801FA36}" type="datetimeFigureOut">
               <a:rPr lang="de-DE" smtClean="0"/>
-              <a:t>18.09.2026</a:t>
+              <a:t>22.09.2026</a:t>
             </a:fld>
             <a:endParaRPr lang="de-DE"/>
           </a:p>
@@ -2577,7 +2579,7 @@
           <a:p>
             <a:fld id="{0F04D7A0-D8C8-4B74-9611-9A000801FA36}" type="datetimeFigureOut">
               <a:rPr lang="de-DE" smtClean="0"/>
-              <a:t>18.09.2026</a:t>
+              <a:t>22.09.2026</a:t>
             </a:fld>
             <a:endParaRPr lang="de-DE"/>
           </a:p>
@@ -4061,10 +4063,3766 @@
           <a:chExt cx="0" cy="0"/>
         </a:xfrm>
       </p:grpSpPr>
+      <p:sp>
+        <p:nvSpPr>
+          <p:cNvPr id="12" name="Gleichschenkliges Dreieck 11">
+            <a:extLst>
+              <a:ext uri="{FF2B5EF4-FFF2-40B4-BE49-F238E27FC236}">
+                <a16:creationId xmlns:a16="http://schemas.microsoft.com/office/drawing/2014/main" id="{CF7CDAD7-DC03-A202-FA27-1BBA075FF1E2}"/>
+              </a:ext>
+            </a:extLst>
+          </p:cNvPr>
+          <p:cNvSpPr/>
+          <p:nvPr/>
+        </p:nvSpPr>
+        <p:spPr>
+          <a:xfrm rot="16200000">
+            <a:off x="1382613" y="920748"/>
+            <a:ext cx="923316" cy="2464619"/>
+          </a:xfrm>
+          <a:prstGeom prst="triangle">
+            <a:avLst/>
+          </a:prstGeom>
+          <a:solidFill>
+            <a:schemeClr val="bg1">
+              <a:lumMod val="75000"/>
+            </a:schemeClr>
+          </a:solidFill>
+          <a:ln>
+            <a:noFill/>
+          </a:ln>
+        </p:spPr>
+        <p:style>
+          <a:lnRef idx="2">
+            <a:schemeClr val="accent1">
+              <a:shade val="15000"/>
+            </a:schemeClr>
+          </a:lnRef>
+          <a:fillRef idx="1">
+            <a:schemeClr val="accent1"/>
+          </a:fillRef>
+          <a:effectRef idx="0">
+            <a:schemeClr val="accent1"/>
+          </a:effectRef>
+          <a:fontRef idx="minor">
+            <a:schemeClr val="lt1"/>
+          </a:fontRef>
+        </p:style>
+        <p:txBody>
+          <a:bodyPr rtlCol="0" anchor="ctr"/>
+          <a:lstStyle/>
+          <a:p>
+            <a:pPr algn="ctr"/>
+            <a:endParaRPr lang="de-DE"/>
+          </a:p>
+        </p:txBody>
+      </p:sp>
+      <p:cxnSp>
+        <p:nvCxnSpPr>
+          <p:cNvPr id="2" name="Gerader Verbinder 1">
+            <a:extLst>
+              <a:ext uri="{FF2B5EF4-FFF2-40B4-BE49-F238E27FC236}">
+                <a16:creationId xmlns:a16="http://schemas.microsoft.com/office/drawing/2014/main" id="{F6DF08A2-F728-5E20-D9C6-F7882D5D3E4C}"/>
+              </a:ext>
+            </a:extLst>
+          </p:cNvPr>
+          <p:cNvCxnSpPr>
+            <a:cxnSpLocks/>
+          </p:cNvCxnSpPr>
+          <p:nvPr/>
+        </p:nvCxnSpPr>
+        <p:spPr>
+          <a:xfrm flipH="1">
+            <a:off x="611961" y="1691401"/>
+            <a:ext cx="2456044" cy="460773"/>
+          </a:xfrm>
+          <a:prstGeom prst="line">
+            <a:avLst/>
+          </a:prstGeom>
+          <a:ln cap="rnd">
+            <a:solidFill>
+              <a:schemeClr val="tx1">
+                <a:lumMod val="75000"/>
+                <a:lumOff val="25000"/>
+              </a:schemeClr>
+            </a:solidFill>
+            <a:round/>
+          </a:ln>
+        </p:spPr>
+        <p:style>
+          <a:lnRef idx="2">
+            <a:schemeClr val="accent1"/>
+          </a:lnRef>
+          <a:fillRef idx="0">
+            <a:schemeClr val="accent1"/>
+          </a:fillRef>
+          <a:effectRef idx="1">
+            <a:schemeClr val="accent1"/>
+          </a:effectRef>
+          <a:fontRef idx="minor">
+            <a:schemeClr val="tx1"/>
+          </a:fontRef>
+        </p:style>
+      </p:cxnSp>
+      <p:cxnSp>
+        <p:nvCxnSpPr>
+          <p:cNvPr id="4" name="Gerader Verbinder 3">
+            <a:extLst>
+              <a:ext uri="{FF2B5EF4-FFF2-40B4-BE49-F238E27FC236}">
+                <a16:creationId xmlns:a16="http://schemas.microsoft.com/office/drawing/2014/main" id="{88205F05-0B8B-B389-D228-C3AC13B41E34}"/>
+              </a:ext>
+            </a:extLst>
+          </p:cNvPr>
+          <p:cNvCxnSpPr>
+            <a:cxnSpLocks/>
+          </p:cNvCxnSpPr>
+          <p:nvPr/>
+        </p:nvCxnSpPr>
+        <p:spPr>
+          <a:xfrm flipH="1" flipV="1">
+            <a:off x="611961" y="2152174"/>
+            <a:ext cx="2456996" cy="461486"/>
+          </a:xfrm>
+          <a:prstGeom prst="line">
+            <a:avLst/>
+          </a:prstGeom>
+          <a:ln cap="rnd">
+            <a:solidFill>
+              <a:schemeClr val="tx1">
+                <a:lumMod val="75000"/>
+                <a:lumOff val="25000"/>
+              </a:schemeClr>
+            </a:solidFill>
+            <a:round/>
+          </a:ln>
+        </p:spPr>
+        <p:style>
+          <a:lnRef idx="2">
+            <a:schemeClr val="accent1"/>
+          </a:lnRef>
+          <a:fillRef idx="0">
+            <a:schemeClr val="accent1"/>
+          </a:fillRef>
+          <a:effectRef idx="1">
+            <a:schemeClr val="accent1"/>
+          </a:effectRef>
+          <a:fontRef idx="minor">
+            <a:schemeClr val="tx1"/>
+          </a:fontRef>
+        </p:style>
+      </p:cxnSp>
+      <p:sp>
+        <p:nvSpPr>
+          <p:cNvPr id="15" name="Freihandform: Form 14">
+            <a:extLst>
+              <a:ext uri="{FF2B5EF4-FFF2-40B4-BE49-F238E27FC236}">
+                <a16:creationId xmlns:a16="http://schemas.microsoft.com/office/drawing/2014/main" id="{65FEBBCF-5459-5A08-179C-D4142BD548DC}"/>
+              </a:ext>
+            </a:extLst>
+          </p:cNvPr>
+          <p:cNvSpPr/>
+          <p:nvPr/>
+        </p:nvSpPr>
+        <p:spPr>
+          <a:xfrm>
+            <a:off x="611507" y="1321435"/>
+            <a:ext cx="2457450" cy="828675"/>
+          </a:xfrm>
+          <a:custGeom>
+            <a:avLst/>
+            <a:gdLst>
+              <a:gd name="csX0" fmla="*/ 0 w 2457450"/>
+              <a:gd name="csY0" fmla="*/ 828675 h 828675"/>
+              <a:gd name="csX1" fmla="*/ 826770 w 2457450"/>
+              <a:gd name="csY1" fmla="*/ 415290 h 828675"/>
+              <a:gd name="csX2" fmla="*/ 2457450 w 2457450"/>
+              <a:gd name="csY2" fmla="*/ 0 h 828675"/>
+            </a:gdLst>
+            <a:ahLst/>
+            <a:cxnLst>
+              <a:cxn ang="0">
+                <a:pos x="csX0" y="csY0"/>
+              </a:cxn>
+              <a:cxn ang="0">
+                <a:pos x="csX1" y="csY1"/>
+              </a:cxn>
+              <a:cxn ang="0">
+                <a:pos x="csX2" y="csY2"/>
+              </a:cxn>
+            </a:cxnLst>
+            <a:rect l="l" t="t" r="r" b="b"/>
+            <a:pathLst>
+              <a:path w="2457450" h="828675">
+                <a:moveTo>
+                  <a:pt x="0" y="828675"/>
+                </a:moveTo>
+                <a:cubicBezTo>
+                  <a:pt x="154305" y="704373"/>
+                  <a:pt x="417195" y="553402"/>
+                  <a:pt x="826770" y="415290"/>
+                </a:cubicBezTo>
+                <a:cubicBezTo>
+                  <a:pt x="1236345" y="277177"/>
+                  <a:pt x="2094230" y="74295"/>
+                  <a:pt x="2457450" y="0"/>
+                </a:cubicBezTo>
+              </a:path>
+            </a:pathLst>
+          </a:custGeom>
+          <a:noFill/>
+          <a:ln cap="rnd">
+            <a:solidFill>
+              <a:schemeClr val="accent1"/>
+            </a:solidFill>
+            <a:round/>
+          </a:ln>
+        </p:spPr>
+        <p:style>
+          <a:lnRef idx="2">
+            <a:schemeClr val="accent1">
+              <a:shade val="15000"/>
+            </a:schemeClr>
+          </a:lnRef>
+          <a:fillRef idx="1">
+            <a:schemeClr val="accent1"/>
+          </a:fillRef>
+          <a:effectRef idx="0">
+            <a:schemeClr val="accent1"/>
+          </a:effectRef>
+          <a:fontRef idx="minor">
+            <a:schemeClr val="lt1"/>
+          </a:fontRef>
+        </p:style>
+        <p:txBody>
+          <a:bodyPr rtlCol="0" anchor="ctr"/>
+          <a:lstStyle/>
+          <a:p>
+            <a:pPr algn="ctr"/>
+            <a:endParaRPr lang="de-DE"/>
+          </a:p>
+        </p:txBody>
+      </p:sp>
+      <p:cxnSp>
+        <p:nvCxnSpPr>
+          <p:cNvPr id="16" name="Gerade Verbindung mit Pfeil 15">
+            <a:extLst>
+              <a:ext uri="{FF2B5EF4-FFF2-40B4-BE49-F238E27FC236}">
+                <a16:creationId xmlns:a16="http://schemas.microsoft.com/office/drawing/2014/main" id="{6A5A3969-E0EB-3662-0A48-4418EEA49AA0}"/>
+              </a:ext>
+            </a:extLst>
+          </p:cNvPr>
+          <p:cNvCxnSpPr>
+            <a:cxnSpLocks/>
+          </p:cNvCxnSpPr>
+          <p:nvPr/>
+        </p:nvCxnSpPr>
+        <p:spPr>
+          <a:xfrm flipV="1">
+            <a:off x="2219768" y="1707464"/>
+            <a:ext cx="287214" cy="54104"/>
+          </a:xfrm>
+          <a:prstGeom prst="straightConnector1">
+            <a:avLst/>
+          </a:prstGeom>
+          <a:ln w="12700" cap="rnd">
+            <a:solidFill>
+              <a:srgbClr val="0070C0"/>
+            </a:solidFill>
+            <a:round/>
+            <a:headEnd type="none"/>
+            <a:tailEnd type="triangle" w="sm" len="med"/>
+          </a:ln>
+        </p:spPr>
+        <p:style>
+          <a:lnRef idx="2">
+            <a:schemeClr val="accent1"/>
+          </a:lnRef>
+          <a:fillRef idx="0">
+            <a:schemeClr val="accent1"/>
+          </a:fillRef>
+          <a:effectRef idx="1">
+            <a:schemeClr val="accent1"/>
+          </a:effectRef>
+          <a:fontRef idx="minor">
+            <a:schemeClr val="tx1"/>
+          </a:fontRef>
+        </p:style>
+      </p:cxnSp>
+      <p:sp>
+        <p:nvSpPr>
+          <p:cNvPr id="17" name="Freihandform: Form 16">
+            <a:extLst>
+              <a:ext uri="{FF2B5EF4-FFF2-40B4-BE49-F238E27FC236}">
+                <a16:creationId xmlns:a16="http://schemas.microsoft.com/office/drawing/2014/main" id="{ECE35229-8E43-BBBF-CCA4-EBCB77A7D9F2}"/>
+              </a:ext>
+            </a:extLst>
+          </p:cNvPr>
+          <p:cNvSpPr/>
+          <p:nvPr/>
+        </p:nvSpPr>
+        <p:spPr>
+          <a:xfrm rot="20959920">
+            <a:off x="2200564" y="1469915"/>
+            <a:ext cx="384395" cy="344240"/>
+          </a:xfrm>
+          <a:custGeom>
+            <a:avLst/>
+            <a:gdLst>
+              <a:gd name="csX0" fmla="*/ 0 w 546100"/>
+              <a:gd name="csY0" fmla="*/ 1000760 h 1000760"/>
+              <a:gd name="csX1" fmla="*/ 340360 w 546100"/>
+              <a:gd name="csY1" fmla="*/ 843280 h 1000760"/>
+              <a:gd name="csX2" fmla="*/ 508000 w 546100"/>
+              <a:gd name="csY2" fmla="*/ 505460 h 1000760"/>
+              <a:gd name="csX3" fmla="*/ 546100 w 546100"/>
+              <a:gd name="csY3" fmla="*/ 0 h 1000760"/>
+            </a:gdLst>
+            <a:ahLst/>
+            <a:cxnLst>
+              <a:cxn ang="0">
+                <a:pos x="csX0" y="csY0"/>
+              </a:cxn>
+              <a:cxn ang="0">
+                <a:pos x="csX1" y="csY1"/>
+              </a:cxn>
+              <a:cxn ang="0">
+                <a:pos x="csX2" y="csY2"/>
+              </a:cxn>
+              <a:cxn ang="0">
+                <a:pos x="csX3" y="csY3"/>
+              </a:cxn>
+            </a:cxnLst>
+            <a:rect l="l" t="t" r="r" b="b"/>
+            <a:pathLst>
+              <a:path w="546100" h="1000760">
+                <a:moveTo>
+                  <a:pt x="0" y="1000760"/>
+                </a:moveTo>
+                <a:cubicBezTo>
+                  <a:pt x="102235" y="976418"/>
+                  <a:pt x="255693" y="925830"/>
+                  <a:pt x="340360" y="843280"/>
+                </a:cubicBezTo>
+                <a:cubicBezTo>
+                  <a:pt x="425027" y="760730"/>
+                  <a:pt x="479637" y="643890"/>
+                  <a:pt x="508000" y="505460"/>
+                </a:cubicBezTo>
+                <a:cubicBezTo>
+                  <a:pt x="536363" y="367030"/>
+                  <a:pt x="543771" y="189865"/>
+                  <a:pt x="546100" y="0"/>
+                </a:cubicBezTo>
+              </a:path>
+            </a:pathLst>
+          </a:custGeom>
+          <a:noFill/>
+          <a:ln w="12700" cap="rnd">
+            <a:solidFill>
+              <a:srgbClr val="0070C0"/>
+            </a:solidFill>
+            <a:round/>
+          </a:ln>
+        </p:spPr>
+        <p:style>
+          <a:lnRef idx="2">
+            <a:schemeClr val="accent1">
+              <a:shade val="15000"/>
+            </a:schemeClr>
+          </a:lnRef>
+          <a:fillRef idx="1">
+            <a:schemeClr val="accent1"/>
+          </a:fillRef>
+          <a:effectRef idx="0">
+            <a:schemeClr val="accent1"/>
+          </a:effectRef>
+          <a:fontRef idx="minor">
+            <a:schemeClr val="lt1"/>
+          </a:fontRef>
+        </p:style>
+        <p:txBody>
+          <a:bodyPr rtlCol="0" anchor="ctr"/>
+          <a:lstStyle/>
+          <a:p>
+            <a:pPr algn="ctr"/>
+            <a:endParaRPr lang="de-DE"/>
+          </a:p>
+        </p:txBody>
+      </p:sp>
+      <p:cxnSp>
+        <p:nvCxnSpPr>
+          <p:cNvPr id="18" name="Gerader Verbinder 17">
+            <a:extLst>
+              <a:ext uri="{FF2B5EF4-FFF2-40B4-BE49-F238E27FC236}">
+                <a16:creationId xmlns:a16="http://schemas.microsoft.com/office/drawing/2014/main" id="{31769634-BAC8-FCE2-B059-3695186CCBC1}"/>
+              </a:ext>
+            </a:extLst>
+          </p:cNvPr>
+          <p:cNvCxnSpPr>
+            <a:cxnSpLocks/>
+          </p:cNvCxnSpPr>
+          <p:nvPr/>
+        </p:nvCxnSpPr>
+        <p:spPr>
+          <a:xfrm flipH="1" flipV="1">
+            <a:off x="2173192" y="1528392"/>
+            <a:ext cx="59517" cy="315952"/>
+          </a:xfrm>
+          <a:prstGeom prst="line">
+            <a:avLst/>
+          </a:prstGeom>
+          <a:ln w="12700" cap="rnd">
+            <a:solidFill>
+              <a:srgbClr val="0070C0"/>
+            </a:solidFill>
+            <a:round/>
+          </a:ln>
+        </p:spPr>
+        <p:style>
+          <a:lnRef idx="2">
+            <a:schemeClr val="accent1"/>
+          </a:lnRef>
+          <a:fillRef idx="0">
+            <a:schemeClr val="accent1"/>
+          </a:fillRef>
+          <a:effectRef idx="1">
+            <a:schemeClr val="accent1"/>
+          </a:effectRef>
+          <a:fontRef idx="minor">
+            <a:schemeClr val="tx1"/>
+          </a:fontRef>
+        </p:style>
+      </p:cxnSp>
+      <p:cxnSp>
+        <p:nvCxnSpPr>
+          <p:cNvPr id="24" name="Gerade Verbindung mit Pfeil 23">
+            <a:extLst>
+              <a:ext uri="{FF2B5EF4-FFF2-40B4-BE49-F238E27FC236}">
+                <a16:creationId xmlns:a16="http://schemas.microsoft.com/office/drawing/2014/main" id="{40A70FC3-D205-7E20-E74C-FBCB91582100}"/>
+              </a:ext>
+            </a:extLst>
+          </p:cNvPr>
+          <p:cNvCxnSpPr>
+            <a:cxnSpLocks/>
+          </p:cNvCxnSpPr>
+          <p:nvPr/>
+        </p:nvCxnSpPr>
+        <p:spPr>
+          <a:xfrm flipV="1">
+            <a:off x="2210769" y="1625476"/>
+            <a:ext cx="344473" cy="64891"/>
+          </a:xfrm>
+          <a:prstGeom prst="straightConnector1">
+            <a:avLst/>
+          </a:prstGeom>
+          <a:ln w="12700" cap="rnd">
+            <a:solidFill>
+              <a:srgbClr val="0070C0"/>
+            </a:solidFill>
+            <a:round/>
+            <a:headEnd type="none"/>
+            <a:tailEnd type="triangle" w="sm" len="med"/>
+          </a:ln>
+        </p:spPr>
+        <p:style>
+          <a:lnRef idx="2">
+            <a:schemeClr val="accent1"/>
+          </a:lnRef>
+          <a:fillRef idx="0">
+            <a:schemeClr val="accent1"/>
+          </a:fillRef>
+          <a:effectRef idx="1">
+            <a:schemeClr val="accent1"/>
+          </a:effectRef>
+          <a:fontRef idx="minor">
+            <a:schemeClr val="tx1"/>
+          </a:fontRef>
+        </p:style>
+      </p:cxnSp>
+      <p:cxnSp>
+        <p:nvCxnSpPr>
+          <p:cNvPr id="26" name="Gerade Verbindung mit Pfeil 25">
+            <a:extLst>
+              <a:ext uri="{FF2B5EF4-FFF2-40B4-BE49-F238E27FC236}">
+                <a16:creationId xmlns:a16="http://schemas.microsoft.com/office/drawing/2014/main" id="{BB0C6A01-622F-A848-BECD-299C88ECEBE4}"/>
+              </a:ext>
+            </a:extLst>
+          </p:cNvPr>
+          <p:cNvCxnSpPr>
+            <a:cxnSpLocks/>
+          </p:cNvCxnSpPr>
+          <p:nvPr/>
+        </p:nvCxnSpPr>
+        <p:spPr>
+          <a:xfrm flipV="1">
+            <a:off x="2195646" y="1553856"/>
+            <a:ext cx="374717" cy="70588"/>
+          </a:xfrm>
+          <a:prstGeom prst="straightConnector1">
+            <a:avLst/>
+          </a:prstGeom>
+          <a:ln w="12700" cap="rnd">
+            <a:solidFill>
+              <a:srgbClr val="0070C0"/>
+            </a:solidFill>
+            <a:round/>
+            <a:headEnd type="none"/>
+            <a:tailEnd type="triangle" w="sm" len="med"/>
+          </a:ln>
+        </p:spPr>
+        <p:style>
+          <a:lnRef idx="2">
+            <a:schemeClr val="accent1"/>
+          </a:lnRef>
+          <a:fillRef idx="0">
+            <a:schemeClr val="accent1"/>
+          </a:fillRef>
+          <a:effectRef idx="1">
+            <a:schemeClr val="accent1"/>
+          </a:effectRef>
+          <a:fontRef idx="minor">
+            <a:schemeClr val="tx1"/>
+          </a:fontRef>
+        </p:style>
+      </p:cxnSp>
+      <p:cxnSp>
+        <p:nvCxnSpPr>
+          <p:cNvPr id="29" name="Gerade Verbindung mit Pfeil 28">
+            <a:extLst>
+              <a:ext uri="{FF2B5EF4-FFF2-40B4-BE49-F238E27FC236}">
+                <a16:creationId xmlns:a16="http://schemas.microsoft.com/office/drawing/2014/main" id="{1E1D2132-240C-DA4F-FDBD-789AA0966E3C}"/>
+              </a:ext>
+            </a:extLst>
+          </p:cNvPr>
+          <p:cNvCxnSpPr>
+            <a:cxnSpLocks/>
+          </p:cNvCxnSpPr>
+          <p:nvPr/>
+        </p:nvCxnSpPr>
+        <p:spPr>
+          <a:xfrm flipV="1">
+            <a:off x="2182183" y="1486671"/>
+            <a:ext cx="378139" cy="71233"/>
+          </a:xfrm>
+          <a:prstGeom prst="straightConnector1">
+            <a:avLst/>
+          </a:prstGeom>
+          <a:ln w="12700" cap="rnd">
+            <a:solidFill>
+              <a:srgbClr val="0070C0"/>
+            </a:solidFill>
+            <a:round/>
+            <a:headEnd type="none"/>
+            <a:tailEnd type="triangle" w="sm" len="med"/>
+          </a:ln>
+        </p:spPr>
+        <p:style>
+          <a:lnRef idx="2">
+            <a:schemeClr val="accent1"/>
+          </a:lnRef>
+          <a:fillRef idx="0">
+            <a:schemeClr val="accent1"/>
+          </a:fillRef>
+          <a:effectRef idx="1">
+            <a:schemeClr val="accent1"/>
+          </a:effectRef>
+          <a:fontRef idx="minor">
+            <a:schemeClr val="tx1"/>
+          </a:fontRef>
+        </p:style>
+      </p:cxnSp>
+      <p:sp>
+        <p:nvSpPr>
+          <p:cNvPr id="35" name="Textfeld 34">
+            <a:extLst>
+              <a:ext uri="{FF2B5EF4-FFF2-40B4-BE49-F238E27FC236}">
+                <a16:creationId xmlns:a16="http://schemas.microsoft.com/office/drawing/2014/main" id="{7BE9AF52-ED30-F851-2644-8580232B8CE6}"/>
+              </a:ext>
+            </a:extLst>
+          </p:cNvPr>
+          <p:cNvSpPr txBox="1"/>
+          <p:nvPr/>
+        </p:nvSpPr>
+        <p:spPr>
+          <a:xfrm>
+            <a:off x="2094135" y="1099670"/>
+            <a:ext cx="440055" cy="276999"/>
+          </a:xfrm>
+          <a:prstGeom prst="rect">
+            <a:avLst/>
+          </a:prstGeom>
+          <a:noFill/>
+        </p:spPr>
+        <p:txBody>
+          <a:bodyPr wrap="square" rtlCol="0" anchor="ctr">
+            <a:spAutoFit/>
+          </a:bodyPr>
+          <a:lstStyle/>
+          <a:p>
+            <a:pPr algn="ctr"/>
+            <a:r>
+              <a:rPr lang="de-DE" sz="1200" i="1" dirty="0" err="1">
+                <a:solidFill>
+                  <a:srgbClr val="0070C0"/>
+                </a:solidFill>
+                <a:latin typeface="CMU Serif" panose="02000603000000000000" pitchFamily="2" charset="0"/>
+                <a:ea typeface="CMU Serif" panose="02000603000000000000" pitchFamily="2" charset="0"/>
+                <a:cs typeface="CMU Serif" panose="02000603000000000000" pitchFamily="2" charset="0"/>
+              </a:rPr>
+              <a:t>u</a:t>
+            </a:r>
+            <a:r>
+              <a:rPr lang="de-DE" sz="1200" i="1" baseline="-25000" dirty="0" err="1">
+                <a:solidFill>
+                  <a:srgbClr val="0070C0"/>
+                </a:solidFill>
+                <a:latin typeface="Latin Modern Math" panose="02000503000000000000" pitchFamily="50" charset="0"/>
+                <a:ea typeface="Latin Modern Math" panose="02000503000000000000" pitchFamily="50" charset="0"/>
+                <a:cs typeface="CMU Serif" panose="02000603000000000000" pitchFamily="2" charset="0"/>
+              </a:rPr>
+              <a:t>δ</a:t>
+            </a:r>
+            <a:endParaRPr lang="de-DE" sz="1200" i="1" baseline="-25000" dirty="0">
+              <a:solidFill>
+                <a:srgbClr val="0070C0"/>
+              </a:solidFill>
+              <a:latin typeface="Latin Modern Math" panose="02000503000000000000" pitchFamily="50" charset="0"/>
+              <a:ea typeface="Latin Modern Math" panose="02000503000000000000" pitchFamily="50" charset="0"/>
+              <a:cs typeface="CMU Serif" panose="02000603000000000000" pitchFamily="2" charset="0"/>
+            </a:endParaRPr>
+          </a:p>
+        </p:txBody>
+      </p:sp>
+      <p:cxnSp>
+        <p:nvCxnSpPr>
+          <p:cNvPr id="36" name="Gerader Verbinder 35">
+            <a:extLst>
+              <a:ext uri="{FF2B5EF4-FFF2-40B4-BE49-F238E27FC236}">
+                <a16:creationId xmlns:a16="http://schemas.microsoft.com/office/drawing/2014/main" id="{9FC3FA97-2FB5-4EDD-E475-0CAD3A8279EB}"/>
+              </a:ext>
+            </a:extLst>
+          </p:cNvPr>
+          <p:cNvCxnSpPr>
+            <a:cxnSpLocks/>
+          </p:cNvCxnSpPr>
+          <p:nvPr/>
+        </p:nvCxnSpPr>
+        <p:spPr>
+          <a:xfrm flipH="1" flipV="1">
+            <a:off x="2128094" y="1282482"/>
+            <a:ext cx="47270" cy="250940"/>
+          </a:xfrm>
+          <a:prstGeom prst="line">
+            <a:avLst/>
+          </a:prstGeom>
+          <a:ln w="6350" cap="rnd">
+            <a:solidFill>
+              <a:srgbClr val="0070C0"/>
+            </a:solidFill>
+            <a:round/>
+          </a:ln>
+        </p:spPr>
+        <p:style>
+          <a:lnRef idx="2">
+            <a:schemeClr val="accent1"/>
+          </a:lnRef>
+          <a:fillRef idx="0">
+            <a:schemeClr val="accent1"/>
+          </a:fillRef>
+          <a:effectRef idx="1">
+            <a:schemeClr val="accent1"/>
+          </a:effectRef>
+          <a:fontRef idx="minor">
+            <a:schemeClr val="tx1"/>
+          </a:fontRef>
+        </p:style>
+      </p:cxnSp>
+      <p:cxnSp>
+        <p:nvCxnSpPr>
+          <p:cNvPr id="38" name="Gerader Verbinder 37">
+            <a:extLst>
+              <a:ext uri="{FF2B5EF4-FFF2-40B4-BE49-F238E27FC236}">
+                <a16:creationId xmlns:a16="http://schemas.microsoft.com/office/drawing/2014/main" id="{FE5A67DD-0777-8FD8-86B7-21887354157A}"/>
+              </a:ext>
+            </a:extLst>
+          </p:cNvPr>
+          <p:cNvCxnSpPr>
+            <a:cxnSpLocks/>
+          </p:cNvCxnSpPr>
+          <p:nvPr/>
+        </p:nvCxnSpPr>
+        <p:spPr>
+          <a:xfrm flipH="1" flipV="1">
+            <a:off x="2504065" y="1199220"/>
+            <a:ext cx="47270" cy="250940"/>
+          </a:xfrm>
+          <a:prstGeom prst="line">
+            <a:avLst/>
+          </a:prstGeom>
+          <a:ln w="6350" cap="rnd">
+            <a:solidFill>
+              <a:srgbClr val="0070C0"/>
+            </a:solidFill>
+            <a:round/>
+          </a:ln>
+        </p:spPr>
+        <p:style>
+          <a:lnRef idx="2">
+            <a:schemeClr val="accent1"/>
+          </a:lnRef>
+          <a:fillRef idx="0">
+            <a:schemeClr val="accent1"/>
+          </a:fillRef>
+          <a:effectRef idx="1">
+            <a:schemeClr val="accent1"/>
+          </a:effectRef>
+          <a:fontRef idx="minor">
+            <a:schemeClr val="tx1"/>
+          </a:fontRef>
+        </p:style>
+      </p:cxnSp>
+      <p:grpSp>
+        <p:nvGrpSpPr>
+          <p:cNvPr id="39" name="Gruppieren 38">
+            <a:extLst>
+              <a:ext uri="{FF2B5EF4-FFF2-40B4-BE49-F238E27FC236}">
+                <a16:creationId xmlns:a16="http://schemas.microsoft.com/office/drawing/2014/main" id="{01048B0A-DFF1-A53E-5217-2A9CA13C0367}"/>
+              </a:ext>
+            </a:extLst>
+          </p:cNvPr>
+          <p:cNvGrpSpPr/>
+          <p:nvPr/>
+        </p:nvGrpSpPr>
+        <p:grpSpPr>
+          <a:xfrm rot="20966550">
+            <a:off x="475374" y="1419231"/>
+            <a:ext cx="1097593" cy="722307"/>
+            <a:chOff x="1172591" y="1273167"/>
+            <a:chExt cx="1097593" cy="722307"/>
+          </a:xfrm>
+        </p:grpSpPr>
+        <p:cxnSp>
+          <p:nvCxnSpPr>
+            <p:cNvPr id="40" name="Gerader Verbinder 39">
+              <a:extLst>
+                <a:ext uri="{FF2B5EF4-FFF2-40B4-BE49-F238E27FC236}">
+                  <a16:creationId xmlns:a16="http://schemas.microsoft.com/office/drawing/2014/main" id="{A9478570-3591-B7C9-1E60-B9B404566070}"/>
+                </a:ext>
+              </a:extLst>
+            </p:cNvPr>
+            <p:cNvCxnSpPr>
+              <a:cxnSpLocks/>
+            </p:cNvCxnSpPr>
+            <p:nvPr/>
+          </p:nvCxnSpPr>
+          <p:spPr>
+            <a:xfrm rot="633450" flipH="1" flipV="1">
+              <a:off x="1190595" y="1341608"/>
+              <a:ext cx="107011" cy="574164"/>
+            </a:xfrm>
+            <a:prstGeom prst="line">
+              <a:avLst/>
+            </a:prstGeom>
+            <a:ln w="12700" cap="rnd">
+              <a:solidFill>
+                <a:schemeClr val="accent5">
+                  <a:lumMod val="75000"/>
+                </a:schemeClr>
+              </a:solidFill>
+              <a:round/>
+              <a:headEnd type="none"/>
+              <a:tailEnd type="triangle" w="med" len="med"/>
+            </a:ln>
+          </p:spPr>
+          <p:style>
+            <a:lnRef idx="2">
+              <a:schemeClr val="accent1"/>
+            </a:lnRef>
+            <a:fillRef idx="0">
+              <a:schemeClr val="accent1"/>
+            </a:fillRef>
+            <a:effectRef idx="1">
+              <a:schemeClr val="accent1"/>
+            </a:effectRef>
+            <a:fontRef idx="minor">
+              <a:schemeClr val="tx1"/>
+            </a:fontRef>
+          </p:style>
+        </p:cxnSp>
+        <p:cxnSp>
+          <p:nvCxnSpPr>
+            <p:cNvPr id="41" name="Gerader Verbinder 40">
+              <a:extLst>
+                <a:ext uri="{FF2B5EF4-FFF2-40B4-BE49-F238E27FC236}">
+                  <a16:creationId xmlns:a16="http://schemas.microsoft.com/office/drawing/2014/main" id="{66C0B6DC-A6F2-7F36-A756-01D09AAF4771}"/>
+                </a:ext>
+              </a:extLst>
+            </p:cNvPr>
+            <p:cNvCxnSpPr>
+              <a:cxnSpLocks/>
+            </p:cNvCxnSpPr>
+            <p:nvPr/>
+          </p:nvCxnSpPr>
+          <p:spPr>
+            <a:xfrm rot="633450" flipV="1">
+              <a:off x="1251008" y="1845957"/>
+              <a:ext cx="802226" cy="149517"/>
+            </a:xfrm>
+            <a:prstGeom prst="line">
+              <a:avLst/>
+            </a:prstGeom>
+            <a:ln w="12700" cap="rnd">
+              <a:solidFill>
+                <a:schemeClr val="accent5">
+                  <a:lumMod val="75000"/>
+                </a:schemeClr>
+              </a:solidFill>
+              <a:round/>
+              <a:headEnd type="none"/>
+              <a:tailEnd type="triangle" w="med" len="med"/>
+            </a:ln>
+          </p:spPr>
+          <p:style>
+            <a:lnRef idx="2">
+              <a:schemeClr val="accent1"/>
+            </a:lnRef>
+            <a:fillRef idx="0">
+              <a:schemeClr val="accent1"/>
+            </a:fillRef>
+            <a:effectRef idx="1">
+              <a:schemeClr val="accent1"/>
+            </a:effectRef>
+            <a:fontRef idx="minor">
+              <a:schemeClr val="tx1"/>
+            </a:fontRef>
+          </p:style>
+        </p:cxnSp>
+        <p:sp>
+          <p:nvSpPr>
+            <p:cNvPr id="42" name="Textfeld 41">
+              <a:extLst>
+                <a:ext uri="{FF2B5EF4-FFF2-40B4-BE49-F238E27FC236}">
+                  <a16:creationId xmlns:a16="http://schemas.microsoft.com/office/drawing/2014/main" id="{543E5C66-1BEB-E77B-F33C-9F124415F49E}"/>
+                </a:ext>
+              </a:extLst>
+            </p:cNvPr>
+            <p:cNvSpPr txBox="1"/>
+            <p:nvPr/>
+          </p:nvSpPr>
+          <p:spPr>
+            <a:xfrm rot="633450">
+              <a:off x="1861935" y="1654012"/>
+              <a:ext cx="408249" cy="276999"/>
+            </a:xfrm>
+            <a:prstGeom prst="rect">
+              <a:avLst/>
+            </a:prstGeom>
+            <a:noFill/>
+          </p:spPr>
+          <p:txBody>
+            <a:bodyPr wrap="square" rtlCol="0" anchor="ctr">
+              <a:spAutoFit/>
+            </a:bodyPr>
+            <a:lstStyle/>
+            <a:p>
+              <a:pPr algn="ctr"/>
+              <a:r>
+                <a:rPr lang="de-DE" sz="1200" i="1" dirty="0">
+                  <a:solidFill>
+                    <a:schemeClr val="accent5">
+                      <a:lumMod val="75000"/>
+                    </a:schemeClr>
+                  </a:solidFill>
+                  <a:latin typeface="CMU Serif" panose="02000603000000000000" pitchFamily="2" charset="0"/>
+                  <a:ea typeface="CMU Serif" panose="02000603000000000000" pitchFamily="2" charset="0"/>
+                  <a:cs typeface="CMU Serif" panose="02000603000000000000" pitchFamily="2" charset="0"/>
+                </a:rPr>
+                <a:t>x</a:t>
+              </a:r>
+              <a:endParaRPr lang="de-DE" sz="1200" baseline="-25000" dirty="0">
+                <a:solidFill>
+                  <a:schemeClr val="accent5">
+                    <a:lumMod val="75000"/>
+                  </a:schemeClr>
+                </a:solidFill>
+                <a:latin typeface="CMU Serif" panose="02000603000000000000" pitchFamily="2" charset="0"/>
+                <a:ea typeface="CMU Serif" panose="02000603000000000000" pitchFamily="2" charset="0"/>
+                <a:cs typeface="CMU Serif" panose="02000603000000000000" pitchFamily="2" charset="0"/>
+              </a:endParaRPr>
+            </a:p>
+          </p:txBody>
+        </p:sp>
+        <p:sp>
+          <p:nvSpPr>
+            <p:cNvPr id="43" name="Textfeld 42">
+              <a:extLst>
+                <a:ext uri="{FF2B5EF4-FFF2-40B4-BE49-F238E27FC236}">
+                  <a16:creationId xmlns:a16="http://schemas.microsoft.com/office/drawing/2014/main" id="{EF961584-3EE6-F092-2ECD-498845C55186}"/>
+                </a:ext>
+              </a:extLst>
+            </p:cNvPr>
+            <p:cNvSpPr txBox="1"/>
+            <p:nvPr/>
+          </p:nvSpPr>
+          <p:spPr>
+            <a:xfrm rot="633450">
+              <a:off x="1172591" y="1273167"/>
+              <a:ext cx="408249" cy="276999"/>
+            </a:xfrm>
+            <a:prstGeom prst="rect">
+              <a:avLst/>
+            </a:prstGeom>
+            <a:noFill/>
+          </p:spPr>
+          <p:txBody>
+            <a:bodyPr wrap="square" rtlCol="0" anchor="ctr">
+              <a:spAutoFit/>
+            </a:bodyPr>
+            <a:lstStyle/>
+            <a:p>
+              <a:pPr algn="ctr"/>
+              <a:r>
+                <a:rPr lang="de-DE" sz="1200" i="1" dirty="0">
+                  <a:solidFill>
+                    <a:schemeClr val="accent5">
+                      <a:lumMod val="75000"/>
+                    </a:schemeClr>
+                  </a:solidFill>
+                  <a:latin typeface="CMU Serif" panose="02000603000000000000" pitchFamily="2" charset="0"/>
+                  <a:ea typeface="CMU Serif" panose="02000603000000000000" pitchFamily="2" charset="0"/>
+                  <a:cs typeface="CMU Serif" panose="02000603000000000000" pitchFamily="2" charset="0"/>
+                </a:rPr>
+                <a:t>y</a:t>
+              </a:r>
+              <a:endParaRPr lang="de-DE" sz="1200" baseline="-25000" dirty="0">
+                <a:solidFill>
+                  <a:schemeClr val="accent5">
+                    <a:lumMod val="75000"/>
+                  </a:schemeClr>
+                </a:solidFill>
+                <a:latin typeface="CMU Serif" panose="02000603000000000000" pitchFamily="2" charset="0"/>
+                <a:ea typeface="CMU Serif" panose="02000603000000000000" pitchFamily="2" charset="0"/>
+                <a:cs typeface="CMU Serif" panose="02000603000000000000" pitchFamily="2" charset="0"/>
+              </a:endParaRPr>
+            </a:p>
+          </p:txBody>
+        </p:sp>
+        <p:sp>
+          <p:nvSpPr>
+            <p:cNvPr id="44" name="Ellipse 43">
+              <a:extLst>
+                <a:ext uri="{FF2B5EF4-FFF2-40B4-BE49-F238E27FC236}">
+                  <a16:creationId xmlns:a16="http://schemas.microsoft.com/office/drawing/2014/main" id="{C8468587-0A19-E294-B76D-7D3D0C57961A}"/>
+                </a:ext>
+              </a:extLst>
+            </p:cNvPr>
+            <p:cNvSpPr/>
+            <p:nvPr/>
+          </p:nvSpPr>
+          <p:spPr>
+            <a:xfrm flipH="1" flipV="1">
+              <a:off x="1213946" y="1889154"/>
+              <a:ext cx="63820" cy="63820"/>
+            </a:xfrm>
+            <a:prstGeom prst="ellipse">
+              <a:avLst/>
+            </a:prstGeom>
+            <a:solidFill>
+              <a:schemeClr val="accent5">
+                <a:lumMod val="75000"/>
+              </a:schemeClr>
+            </a:solidFill>
+            <a:ln>
+              <a:noFill/>
+            </a:ln>
+          </p:spPr>
+          <p:style>
+            <a:lnRef idx="2">
+              <a:schemeClr val="accent1">
+                <a:shade val="15000"/>
+              </a:schemeClr>
+            </a:lnRef>
+            <a:fillRef idx="1">
+              <a:schemeClr val="accent1"/>
+            </a:fillRef>
+            <a:effectRef idx="0">
+              <a:schemeClr val="accent1"/>
+            </a:effectRef>
+            <a:fontRef idx="minor">
+              <a:schemeClr val="lt1"/>
+            </a:fontRef>
+          </p:style>
+          <p:txBody>
+            <a:bodyPr rtlCol="0" anchor="ctr"/>
+            <a:lstStyle/>
+            <a:p>
+              <a:pPr algn="ctr"/>
+              <a:endParaRPr lang="de-DE"/>
+            </a:p>
+          </p:txBody>
+        </p:sp>
+      </p:grpSp>
+      <p:sp>
+        <p:nvSpPr>
+          <p:cNvPr id="48" name="Bogen 47">
+            <a:extLst>
+              <a:ext uri="{FF2B5EF4-FFF2-40B4-BE49-F238E27FC236}">
+                <a16:creationId xmlns:a16="http://schemas.microsoft.com/office/drawing/2014/main" id="{EED48409-DC30-EC54-AB00-0F84A4CC8AD7}"/>
+              </a:ext>
+            </a:extLst>
+          </p:cNvPr>
+          <p:cNvSpPr/>
+          <p:nvPr/>
+        </p:nvSpPr>
+        <p:spPr>
+          <a:xfrm>
+            <a:off x="-456313" y="1090874"/>
+            <a:ext cx="2128950" cy="2128950"/>
+          </a:xfrm>
+          <a:prstGeom prst="arc">
+            <a:avLst>
+              <a:gd name="adj1" fmla="val 20975646"/>
+              <a:gd name="adj2" fmla="val 624477"/>
+            </a:avLst>
+          </a:prstGeom>
+          <a:ln w="12700" cap="rnd">
+            <a:solidFill>
+              <a:schemeClr val="accent5">
+                <a:lumMod val="75000"/>
+              </a:schemeClr>
+            </a:solidFill>
+            <a:round/>
+            <a:headEnd type="triangle" w="sm" len="sm"/>
+            <a:tailEnd type="triangle" w="sm" len="sm"/>
+          </a:ln>
+        </p:spPr>
+        <p:style>
+          <a:lnRef idx="2">
+            <a:schemeClr val="accent1"/>
+          </a:lnRef>
+          <a:fillRef idx="0">
+            <a:schemeClr val="accent1"/>
+          </a:fillRef>
+          <a:effectRef idx="1">
+            <a:schemeClr val="accent1"/>
+          </a:effectRef>
+          <a:fontRef idx="minor">
+            <a:schemeClr val="tx1"/>
+          </a:fontRef>
+        </p:style>
+        <p:txBody>
+          <a:bodyPr rtlCol="0" anchor="ctr"/>
+          <a:lstStyle/>
+          <a:p>
+            <a:pPr algn="ctr"/>
+            <a:endParaRPr lang="de-DE" sz="1400"/>
+          </a:p>
+        </p:txBody>
+      </p:sp>
+      <p:sp>
+        <p:nvSpPr>
+          <p:cNvPr id="50" name="Textfeld 49">
+            <a:extLst>
+              <a:ext uri="{FF2B5EF4-FFF2-40B4-BE49-F238E27FC236}">
+                <a16:creationId xmlns:a16="http://schemas.microsoft.com/office/drawing/2014/main" id="{39370EAD-45B1-AA2D-FA41-E358D257B7F3}"/>
+              </a:ext>
+            </a:extLst>
+          </p:cNvPr>
+          <p:cNvSpPr txBox="1"/>
+          <p:nvPr/>
+        </p:nvSpPr>
+        <p:spPr>
+          <a:xfrm>
+            <a:off x="1473798" y="2054092"/>
+            <a:ext cx="675892" cy="307777"/>
+          </a:xfrm>
+          <a:prstGeom prst="rect">
+            <a:avLst/>
+          </a:prstGeom>
+          <a:noFill/>
+        </p:spPr>
+        <p:txBody>
+          <a:bodyPr wrap="square" rtlCol="0" anchor="ctr">
+            <a:spAutoFit/>
+          </a:bodyPr>
+          <a:lstStyle/>
+          <a:p>
+            <a:pPr algn="ctr"/>
+            <a:r>
+              <a:rPr lang="de-DE" sz="1400" i="1" dirty="0">
+                <a:solidFill>
+                  <a:schemeClr val="accent5">
+                    <a:lumMod val="75000"/>
+                  </a:schemeClr>
+                </a:solidFill>
+                <a:latin typeface="Latin Modern Math" panose="02000503000000000000" pitchFamily="50" charset="0"/>
+                <a:ea typeface="Latin Modern Math" panose="02000503000000000000" pitchFamily="50" charset="0"/>
+                <a:cs typeface="CMU Serif" panose="02000603000000000000" pitchFamily="2" charset="0"/>
+              </a:rPr>
+              <a:t>θ</a:t>
+            </a:r>
+            <a:endParaRPr lang="de-DE" sz="1400" baseline="-25000" dirty="0">
+              <a:solidFill>
+                <a:schemeClr val="accent5">
+                  <a:lumMod val="75000"/>
+                </a:schemeClr>
+              </a:solidFill>
+              <a:latin typeface="Latin Modern Math" panose="02000503000000000000" pitchFamily="50" charset="0"/>
+              <a:ea typeface="Latin Modern Math" panose="02000503000000000000" pitchFamily="50" charset="0"/>
+              <a:cs typeface="CMU Serif" panose="02000603000000000000" pitchFamily="2" charset="0"/>
+            </a:endParaRPr>
+          </a:p>
+        </p:txBody>
+      </p:sp>
     </p:spTree>
     <p:extLst>
       <p:ext uri="{BB962C8B-B14F-4D97-AF65-F5344CB8AC3E}">
         <p14:creationId xmlns:p14="http://schemas.microsoft.com/office/powerpoint/2010/main" val="2180941687"/>
+      </p:ext>
+    </p:extLst>
+  </p:cSld>
+  <p:clrMapOvr>
+    <a:masterClrMapping/>
+  </p:clrMapOvr>
+</p:sld>
+</file>
+
+<file path=ppt/slides/slide11.xml><?xml version="1.0" encoding="utf-8"?>
+<p:sld xmlns:a="http://schemas.openxmlformats.org/drawingml/2006/main" xmlns:r="http://schemas.openxmlformats.org/officeDocument/2006/relationships" xmlns:p="http://schemas.openxmlformats.org/presentationml/2006/main">
+  <p:cSld>
+    <p:spTree>
+      <p:nvGrpSpPr>
+        <p:cNvPr id="1" name="">
+          <a:extLst>
+            <a:ext uri="{FF2B5EF4-FFF2-40B4-BE49-F238E27FC236}">
+              <a16:creationId xmlns:a16="http://schemas.microsoft.com/office/drawing/2014/main" id="{E8816EA2-E150-255D-7E35-C4A1D2EA0939}"/>
+            </a:ext>
+          </a:extLst>
+        </p:cNvPr>
+        <p:cNvGrpSpPr/>
+        <p:nvPr/>
+      </p:nvGrpSpPr>
+      <p:grpSpPr>
+        <a:xfrm>
+          <a:off x="0" y="0"/>
+          <a:ext cx="0" cy="0"/>
+          <a:chOff x="0" y="0"/>
+          <a:chExt cx="0" cy="0"/>
+        </a:xfrm>
+      </p:grpSpPr>
+      <p:grpSp>
+        <p:nvGrpSpPr>
+          <p:cNvPr id="65" name="Gruppieren 64">
+            <a:extLst>
+              <a:ext uri="{FF2B5EF4-FFF2-40B4-BE49-F238E27FC236}">
+                <a16:creationId xmlns:a16="http://schemas.microsoft.com/office/drawing/2014/main" id="{732BD507-B10B-2D65-19DD-893BFD47EA0C}"/>
+              </a:ext>
+            </a:extLst>
+          </p:cNvPr>
+          <p:cNvGrpSpPr/>
+          <p:nvPr/>
+        </p:nvGrpSpPr>
+        <p:grpSpPr>
+          <a:xfrm>
+            <a:off x="543560" y="1081683"/>
+            <a:ext cx="2735421" cy="1357788"/>
+            <a:chOff x="569119" y="1081683"/>
+            <a:chExt cx="2709862" cy="1357788"/>
+          </a:xfrm>
+        </p:grpSpPr>
+        <p:cxnSp>
+          <p:nvCxnSpPr>
+            <p:cNvPr id="16" name="Gerader Verbinder 15">
+              <a:extLst>
+                <a:ext uri="{FF2B5EF4-FFF2-40B4-BE49-F238E27FC236}">
+                  <a16:creationId xmlns:a16="http://schemas.microsoft.com/office/drawing/2014/main" id="{9584D681-A61A-2C2A-9F5D-A08D940F3C62}"/>
+                </a:ext>
+              </a:extLst>
+            </p:cNvPr>
+            <p:cNvCxnSpPr>
+              <a:cxnSpLocks/>
+            </p:cNvCxnSpPr>
+            <p:nvPr/>
+          </p:nvCxnSpPr>
+          <p:spPr>
+            <a:xfrm>
+              <a:off x="569119" y="1081683"/>
+              <a:ext cx="2709862" cy="0"/>
+            </a:xfrm>
+            <a:prstGeom prst="line">
+              <a:avLst/>
+            </a:prstGeom>
+            <a:ln w="6350" cap="rnd">
+              <a:solidFill>
+                <a:schemeClr val="bg1">
+                  <a:lumMod val="75000"/>
+                </a:schemeClr>
+              </a:solidFill>
+              <a:round/>
+            </a:ln>
+          </p:spPr>
+          <p:style>
+            <a:lnRef idx="2">
+              <a:schemeClr val="accent1"/>
+            </a:lnRef>
+            <a:fillRef idx="0">
+              <a:schemeClr val="accent1"/>
+            </a:fillRef>
+            <a:effectRef idx="1">
+              <a:schemeClr val="accent1"/>
+            </a:effectRef>
+            <a:fontRef idx="minor">
+              <a:schemeClr val="tx1"/>
+            </a:fontRef>
+          </p:style>
+        </p:cxnSp>
+        <p:cxnSp>
+          <p:nvCxnSpPr>
+            <p:cNvPr id="19" name="Gerader Verbinder 18">
+              <a:extLst>
+                <a:ext uri="{FF2B5EF4-FFF2-40B4-BE49-F238E27FC236}">
+                  <a16:creationId xmlns:a16="http://schemas.microsoft.com/office/drawing/2014/main" id="{EDBE5621-3B2A-163B-AE56-FCEC03472587}"/>
+                </a:ext>
+              </a:extLst>
+            </p:cNvPr>
+            <p:cNvCxnSpPr>
+              <a:cxnSpLocks/>
+            </p:cNvCxnSpPr>
+            <p:nvPr/>
+          </p:nvCxnSpPr>
+          <p:spPr>
+            <a:xfrm>
+              <a:off x="569119" y="1353241"/>
+              <a:ext cx="2709862" cy="0"/>
+            </a:xfrm>
+            <a:prstGeom prst="line">
+              <a:avLst/>
+            </a:prstGeom>
+            <a:ln w="6350" cap="rnd">
+              <a:solidFill>
+                <a:schemeClr val="bg1">
+                  <a:lumMod val="75000"/>
+                </a:schemeClr>
+              </a:solidFill>
+              <a:round/>
+            </a:ln>
+          </p:spPr>
+          <p:style>
+            <a:lnRef idx="2">
+              <a:schemeClr val="accent1"/>
+            </a:lnRef>
+            <a:fillRef idx="0">
+              <a:schemeClr val="accent1"/>
+            </a:fillRef>
+            <a:effectRef idx="1">
+              <a:schemeClr val="accent1"/>
+            </a:effectRef>
+            <a:fontRef idx="minor">
+              <a:schemeClr val="tx1"/>
+            </a:fontRef>
+          </p:style>
+        </p:cxnSp>
+        <p:cxnSp>
+          <p:nvCxnSpPr>
+            <p:cNvPr id="20" name="Gerader Verbinder 19">
+              <a:extLst>
+                <a:ext uri="{FF2B5EF4-FFF2-40B4-BE49-F238E27FC236}">
+                  <a16:creationId xmlns:a16="http://schemas.microsoft.com/office/drawing/2014/main" id="{2F5A0578-0706-B5D3-EF77-A44D88BEC31E}"/>
+                </a:ext>
+              </a:extLst>
+            </p:cNvPr>
+            <p:cNvCxnSpPr>
+              <a:cxnSpLocks/>
+            </p:cNvCxnSpPr>
+            <p:nvPr/>
+          </p:nvCxnSpPr>
+          <p:spPr>
+            <a:xfrm>
+              <a:off x="569119" y="1624799"/>
+              <a:ext cx="2709862" cy="0"/>
+            </a:xfrm>
+            <a:prstGeom prst="line">
+              <a:avLst/>
+            </a:prstGeom>
+            <a:ln w="6350" cap="rnd">
+              <a:solidFill>
+                <a:schemeClr val="bg1">
+                  <a:lumMod val="75000"/>
+                </a:schemeClr>
+              </a:solidFill>
+              <a:round/>
+            </a:ln>
+          </p:spPr>
+          <p:style>
+            <a:lnRef idx="2">
+              <a:schemeClr val="accent1"/>
+            </a:lnRef>
+            <a:fillRef idx="0">
+              <a:schemeClr val="accent1"/>
+            </a:fillRef>
+            <a:effectRef idx="1">
+              <a:schemeClr val="accent1"/>
+            </a:effectRef>
+            <a:fontRef idx="minor">
+              <a:schemeClr val="tx1"/>
+            </a:fontRef>
+          </p:style>
+        </p:cxnSp>
+        <p:cxnSp>
+          <p:nvCxnSpPr>
+            <p:cNvPr id="21" name="Gerader Verbinder 20">
+              <a:extLst>
+                <a:ext uri="{FF2B5EF4-FFF2-40B4-BE49-F238E27FC236}">
+                  <a16:creationId xmlns:a16="http://schemas.microsoft.com/office/drawing/2014/main" id="{3FCF8EFA-F0A0-6766-202A-95903F37C096}"/>
+                </a:ext>
+              </a:extLst>
+            </p:cNvPr>
+            <p:cNvCxnSpPr>
+              <a:cxnSpLocks/>
+            </p:cNvCxnSpPr>
+            <p:nvPr/>
+          </p:nvCxnSpPr>
+          <p:spPr>
+            <a:xfrm>
+              <a:off x="569119" y="1896357"/>
+              <a:ext cx="2709862" cy="0"/>
+            </a:xfrm>
+            <a:prstGeom prst="line">
+              <a:avLst/>
+            </a:prstGeom>
+            <a:ln w="6350" cap="rnd">
+              <a:solidFill>
+                <a:schemeClr val="bg1">
+                  <a:lumMod val="75000"/>
+                </a:schemeClr>
+              </a:solidFill>
+              <a:round/>
+            </a:ln>
+          </p:spPr>
+          <p:style>
+            <a:lnRef idx="2">
+              <a:schemeClr val="accent1"/>
+            </a:lnRef>
+            <a:fillRef idx="0">
+              <a:schemeClr val="accent1"/>
+            </a:fillRef>
+            <a:effectRef idx="1">
+              <a:schemeClr val="accent1"/>
+            </a:effectRef>
+            <a:fontRef idx="minor">
+              <a:schemeClr val="tx1"/>
+            </a:fontRef>
+          </p:style>
+        </p:cxnSp>
+        <p:cxnSp>
+          <p:nvCxnSpPr>
+            <p:cNvPr id="22" name="Gerader Verbinder 21">
+              <a:extLst>
+                <a:ext uri="{FF2B5EF4-FFF2-40B4-BE49-F238E27FC236}">
+                  <a16:creationId xmlns:a16="http://schemas.microsoft.com/office/drawing/2014/main" id="{D66ECB39-1598-17F4-63B8-24837535828F}"/>
+                </a:ext>
+              </a:extLst>
+            </p:cNvPr>
+            <p:cNvCxnSpPr>
+              <a:cxnSpLocks/>
+            </p:cNvCxnSpPr>
+            <p:nvPr/>
+          </p:nvCxnSpPr>
+          <p:spPr>
+            <a:xfrm>
+              <a:off x="569119" y="2167915"/>
+              <a:ext cx="2709862" cy="0"/>
+            </a:xfrm>
+            <a:prstGeom prst="line">
+              <a:avLst/>
+            </a:prstGeom>
+            <a:ln w="6350" cap="rnd">
+              <a:solidFill>
+                <a:schemeClr val="bg1">
+                  <a:lumMod val="75000"/>
+                </a:schemeClr>
+              </a:solidFill>
+              <a:round/>
+            </a:ln>
+          </p:spPr>
+          <p:style>
+            <a:lnRef idx="2">
+              <a:schemeClr val="accent1"/>
+            </a:lnRef>
+            <a:fillRef idx="0">
+              <a:schemeClr val="accent1"/>
+            </a:fillRef>
+            <a:effectRef idx="1">
+              <a:schemeClr val="accent1"/>
+            </a:effectRef>
+            <a:fontRef idx="minor">
+              <a:schemeClr val="tx1"/>
+            </a:fontRef>
+          </p:style>
+        </p:cxnSp>
+        <p:cxnSp>
+          <p:nvCxnSpPr>
+            <p:cNvPr id="23" name="Gerader Verbinder 22">
+              <a:extLst>
+                <a:ext uri="{FF2B5EF4-FFF2-40B4-BE49-F238E27FC236}">
+                  <a16:creationId xmlns:a16="http://schemas.microsoft.com/office/drawing/2014/main" id="{9963BE96-21F3-C4B8-89C7-ECC8636FF1AD}"/>
+                </a:ext>
+              </a:extLst>
+            </p:cNvPr>
+            <p:cNvCxnSpPr>
+              <a:cxnSpLocks/>
+            </p:cNvCxnSpPr>
+            <p:nvPr/>
+          </p:nvCxnSpPr>
+          <p:spPr>
+            <a:xfrm>
+              <a:off x="569119" y="2439471"/>
+              <a:ext cx="2709862" cy="0"/>
+            </a:xfrm>
+            <a:prstGeom prst="line">
+              <a:avLst/>
+            </a:prstGeom>
+            <a:ln w="6350" cap="rnd">
+              <a:solidFill>
+                <a:schemeClr val="bg1">
+                  <a:lumMod val="75000"/>
+                </a:schemeClr>
+              </a:solidFill>
+              <a:round/>
+            </a:ln>
+          </p:spPr>
+          <p:style>
+            <a:lnRef idx="2">
+              <a:schemeClr val="accent1"/>
+            </a:lnRef>
+            <a:fillRef idx="0">
+              <a:schemeClr val="accent1"/>
+            </a:fillRef>
+            <a:effectRef idx="1">
+              <a:schemeClr val="accent1"/>
+            </a:effectRef>
+            <a:fontRef idx="minor">
+              <a:schemeClr val="tx1"/>
+            </a:fontRef>
+          </p:style>
+        </p:cxnSp>
+      </p:grpSp>
+      <p:grpSp>
+        <p:nvGrpSpPr>
+          <p:cNvPr id="24" name="Gruppieren 23">
+            <a:extLst>
+              <a:ext uri="{FF2B5EF4-FFF2-40B4-BE49-F238E27FC236}">
+                <a16:creationId xmlns:a16="http://schemas.microsoft.com/office/drawing/2014/main" id="{3CD99CED-5096-80E0-3838-2F9C3F8D6FF9}"/>
+              </a:ext>
+            </a:extLst>
+          </p:cNvPr>
+          <p:cNvGrpSpPr/>
+          <p:nvPr/>
+        </p:nvGrpSpPr>
+        <p:grpSpPr>
+          <a:xfrm>
+            <a:off x="571500" y="1081682"/>
+            <a:ext cx="2709862" cy="1407518"/>
+            <a:chOff x="450056" y="1078111"/>
+            <a:chExt cx="2709862" cy="1496616"/>
+          </a:xfrm>
+        </p:grpSpPr>
+        <p:cxnSp>
+          <p:nvCxnSpPr>
+            <p:cNvPr id="3" name="Gerader Verbinder 2">
+              <a:extLst>
+                <a:ext uri="{FF2B5EF4-FFF2-40B4-BE49-F238E27FC236}">
+                  <a16:creationId xmlns:a16="http://schemas.microsoft.com/office/drawing/2014/main" id="{7184ECB7-D6BF-047B-F183-2B854CAFD6F0}"/>
+                </a:ext>
+              </a:extLst>
+            </p:cNvPr>
+            <p:cNvCxnSpPr>
+              <a:cxnSpLocks/>
+            </p:cNvCxnSpPr>
+            <p:nvPr/>
+          </p:nvCxnSpPr>
+          <p:spPr>
+            <a:xfrm>
+              <a:off x="450056" y="1078111"/>
+              <a:ext cx="0" cy="1496616"/>
+            </a:xfrm>
+            <a:prstGeom prst="line">
+              <a:avLst/>
+            </a:prstGeom>
+            <a:ln w="6350" cap="rnd">
+              <a:solidFill>
+                <a:schemeClr val="bg1">
+                  <a:lumMod val="75000"/>
+                </a:schemeClr>
+              </a:solidFill>
+              <a:round/>
+            </a:ln>
+          </p:spPr>
+          <p:style>
+            <a:lnRef idx="2">
+              <a:schemeClr val="accent1"/>
+            </a:lnRef>
+            <a:fillRef idx="0">
+              <a:schemeClr val="accent1"/>
+            </a:fillRef>
+            <a:effectRef idx="1">
+              <a:schemeClr val="accent1"/>
+            </a:effectRef>
+            <a:fontRef idx="minor">
+              <a:schemeClr val="tx1"/>
+            </a:fontRef>
+          </p:style>
+        </p:cxnSp>
+        <p:cxnSp>
+          <p:nvCxnSpPr>
+            <p:cNvPr id="5" name="Gerader Verbinder 4">
+              <a:extLst>
+                <a:ext uri="{FF2B5EF4-FFF2-40B4-BE49-F238E27FC236}">
+                  <a16:creationId xmlns:a16="http://schemas.microsoft.com/office/drawing/2014/main" id="{A75366F4-F3D0-09F0-C1CC-8FA9E69A5A9E}"/>
+                </a:ext>
+              </a:extLst>
+            </p:cNvPr>
+            <p:cNvCxnSpPr>
+              <a:cxnSpLocks/>
+            </p:cNvCxnSpPr>
+            <p:nvPr/>
+          </p:nvCxnSpPr>
+          <p:spPr>
+            <a:xfrm>
+              <a:off x="721042" y="1078111"/>
+              <a:ext cx="0" cy="1496616"/>
+            </a:xfrm>
+            <a:prstGeom prst="line">
+              <a:avLst/>
+            </a:prstGeom>
+            <a:ln w="6350" cap="rnd">
+              <a:solidFill>
+                <a:schemeClr val="bg1">
+                  <a:lumMod val="75000"/>
+                </a:schemeClr>
+              </a:solidFill>
+              <a:round/>
+            </a:ln>
+          </p:spPr>
+          <p:style>
+            <a:lnRef idx="2">
+              <a:schemeClr val="accent1"/>
+            </a:lnRef>
+            <a:fillRef idx="0">
+              <a:schemeClr val="accent1"/>
+            </a:fillRef>
+            <a:effectRef idx="1">
+              <a:schemeClr val="accent1"/>
+            </a:effectRef>
+            <a:fontRef idx="minor">
+              <a:schemeClr val="tx1"/>
+            </a:fontRef>
+          </p:style>
+        </p:cxnSp>
+        <p:cxnSp>
+          <p:nvCxnSpPr>
+            <p:cNvPr id="6" name="Gerader Verbinder 5">
+              <a:extLst>
+                <a:ext uri="{FF2B5EF4-FFF2-40B4-BE49-F238E27FC236}">
+                  <a16:creationId xmlns:a16="http://schemas.microsoft.com/office/drawing/2014/main" id="{B9195551-BC90-22E2-C850-431D7688BA6D}"/>
+                </a:ext>
+              </a:extLst>
+            </p:cNvPr>
+            <p:cNvCxnSpPr>
+              <a:cxnSpLocks/>
+            </p:cNvCxnSpPr>
+            <p:nvPr/>
+          </p:nvCxnSpPr>
+          <p:spPr>
+            <a:xfrm>
+              <a:off x="992028" y="1078111"/>
+              <a:ext cx="0" cy="1496616"/>
+            </a:xfrm>
+            <a:prstGeom prst="line">
+              <a:avLst/>
+            </a:prstGeom>
+            <a:ln w="6350" cap="rnd">
+              <a:solidFill>
+                <a:schemeClr val="bg1">
+                  <a:lumMod val="75000"/>
+                </a:schemeClr>
+              </a:solidFill>
+              <a:round/>
+            </a:ln>
+          </p:spPr>
+          <p:style>
+            <a:lnRef idx="2">
+              <a:schemeClr val="accent1"/>
+            </a:lnRef>
+            <a:fillRef idx="0">
+              <a:schemeClr val="accent1"/>
+            </a:fillRef>
+            <a:effectRef idx="1">
+              <a:schemeClr val="accent1"/>
+            </a:effectRef>
+            <a:fontRef idx="minor">
+              <a:schemeClr val="tx1"/>
+            </a:fontRef>
+          </p:style>
+        </p:cxnSp>
+        <p:cxnSp>
+          <p:nvCxnSpPr>
+            <p:cNvPr id="7" name="Gerader Verbinder 6">
+              <a:extLst>
+                <a:ext uri="{FF2B5EF4-FFF2-40B4-BE49-F238E27FC236}">
+                  <a16:creationId xmlns:a16="http://schemas.microsoft.com/office/drawing/2014/main" id="{B63F70C2-A0E3-7726-705F-FCC786008CA3}"/>
+                </a:ext>
+              </a:extLst>
+            </p:cNvPr>
+            <p:cNvCxnSpPr>
+              <a:cxnSpLocks/>
+            </p:cNvCxnSpPr>
+            <p:nvPr/>
+          </p:nvCxnSpPr>
+          <p:spPr>
+            <a:xfrm>
+              <a:off x="1263014" y="1078111"/>
+              <a:ext cx="0" cy="1496616"/>
+            </a:xfrm>
+            <a:prstGeom prst="line">
+              <a:avLst/>
+            </a:prstGeom>
+            <a:ln w="6350" cap="rnd">
+              <a:solidFill>
+                <a:schemeClr val="bg1">
+                  <a:lumMod val="75000"/>
+                </a:schemeClr>
+              </a:solidFill>
+              <a:round/>
+            </a:ln>
+          </p:spPr>
+          <p:style>
+            <a:lnRef idx="2">
+              <a:schemeClr val="accent1"/>
+            </a:lnRef>
+            <a:fillRef idx="0">
+              <a:schemeClr val="accent1"/>
+            </a:fillRef>
+            <a:effectRef idx="1">
+              <a:schemeClr val="accent1"/>
+            </a:effectRef>
+            <a:fontRef idx="minor">
+              <a:schemeClr val="tx1"/>
+            </a:fontRef>
+          </p:style>
+        </p:cxnSp>
+        <p:cxnSp>
+          <p:nvCxnSpPr>
+            <p:cNvPr id="8" name="Gerader Verbinder 7">
+              <a:extLst>
+                <a:ext uri="{FF2B5EF4-FFF2-40B4-BE49-F238E27FC236}">
+                  <a16:creationId xmlns:a16="http://schemas.microsoft.com/office/drawing/2014/main" id="{D7F542CB-EE79-7E52-AA17-8C17883D8BF1}"/>
+                </a:ext>
+              </a:extLst>
+            </p:cNvPr>
+            <p:cNvCxnSpPr>
+              <a:cxnSpLocks/>
+            </p:cNvCxnSpPr>
+            <p:nvPr/>
+          </p:nvCxnSpPr>
+          <p:spPr>
+            <a:xfrm>
+              <a:off x="1534000" y="1078111"/>
+              <a:ext cx="0" cy="1496616"/>
+            </a:xfrm>
+            <a:prstGeom prst="line">
+              <a:avLst/>
+            </a:prstGeom>
+            <a:ln w="6350" cap="rnd">
+              <a:solidFill>
+                <a:schemeClr val="bg1">
+                  <a:lumMod val="75000"/>
+                </a:schemeClr>
+              </a:solidFill>
+              <a:round/>
+            </a:ln>
+          </p:spPr>
+          <p:style>
+            <a:lnRef idx="2">
+              <a:schemeClr val="accent1"/>
+            </a:lnRef>
+            <a:fillRef idx="0">
+              <a:schemeClr val="accent1"/>
+            </a:fillRef>
+            <a:effectRef idx="1">
+              <a:schemeClr val="accent1"/>
+            </a:effectRef>
+            <a:fontRef idx="minor">
+              <a:schemeClr val="tx1"/>
+            </a:fontRef>
+          </p:style>
+        </p:cxnSp>
+        <p:cxnSp>
+          <p:nvCxnSpPr>
+            <p:cNvPr id="9" name="Gerader Verbinder 8">
+              <a:extLst>
+                <a:ext uri="{FF2B5EF4-FFF2-40B4-BE49-F238E27FC236}">
+                  <a16:creationId xmlns:a16="http://schemas.microsoft.com/office/drawing/2014/main" id="{F863D6AB-5FAB-8284-6D24-0432D49D930E}"/>
+                </a:ext>
+              </a:extLst>
+            </p:cNvPr>
+            <p:cNvCxnSpPr>
+              <a:cxnSpLocks/>
+            </p:cNvCxnSpPr>
+            <p:nvPr/>
+          </p:nvCxnSpPr>
+          <p:spPr>
+            <a:xfrm>
+              <a:off x="1804986" y="1078111"/>
+              <a:ext cx="0" cy="1496616"/>
+            </a:xfrm>
+            <a:prstGeom prst="line">
+              <a:avLst/>
+            </a:prstGeom>
+            <a:ln w="6350" cap="rnd">
+              <a:solidFill>
+                <a:schemeClr val="bg1">
+                  <a:lumMod val="75000"/>
+                </a:schemeClr>
+              </a:solidFill>
+              <a:round/>
+            </a:ln>
+          </p:spPr>
+          <p:style>
+            <a:lnRef idx="2">
+              <a:schemeClr val="accent1"/>
+            </a:lnRef>
+            <a:fillRef idx="0">
+              <a:schemeClr val="accent1"/>
+            </a:fillRef>
+            <a:effectRef idx="1">
+              <a:schemeClr val="accent1"/>
+            </a:effectRef>
+            <a:fontRef idx="minor">
+              <a:schemeClr val="tx1"/>
+            </a:fontRef>
+          </p:style>
+        </p:cxnSp>
+        <p:cxnSp>
+          <p:nvCxnSpPr>
+            <p:cNvPr id="10" name="Gerader Verbinder 9">
+              <a:extLst>
+                <a:ext uri="{FF2B5EF4-FFF2-40B4-BE49-F238E27FC236}">
+                  <a16:creationId xmlns:a16="http://schemas.microsoft.com/office/drawing/2014/main" id="{860A520C-40CC-B12A-989E-C2D83BCA54A5}"/>
+                </a:ext>
+              </a:extLst>
+            </p:cNvPr>
+            <p:cNvCxnSpPr>
+              <a:cxnSpLocks/>
+            </p:cNvCxnSpPr>
+            <p:nvPr/>
+          </p:nvCxnSpPr>
+          <p:spPr>
+            <a:xfrm>
+              <a:off x="2075972" y="1078111"/>
+              <a:ext cx="0" cy="1496616"/>
+            </a:xfrm>
+            <a:prstGeom prst="line">
+              <a:avLst/>
+            </a:prstGeom>
+            <a:ln w="6350" cap="rnd">
+              <a:solidFill>
+                <a:schemeClr val="bg1">
+                  <a:lumMod val="75000"/>
+                </a:schemeClr>
+              </a:solidFill>
+              <a:round/>
+            </a:ln>
+          </p:spPr>
+          <p:style>
+            <a:lnRef idx="2">
+              <a:schemeClr val="accent1"/>
+            </a:lnRef>
+            <a:fillRef idx="0">
+              <a:schemeClr val="accent1"/>
+            </a:fillRef>
+            <a:effectRef idx="1">
+              <a:schemeClr val="accent1"/>
+            </a:effectRef>
+            <a:fontRef idx="minor">
+              <a:schemeClr val="tx1"/>
+            </a:fontRef>
+          </p:style>
+        </p:cxnSp>
+        <p:cxnSp>
+          <p:nvCxnSpPr>
+            <p:cNvPr id="11" name="Gerader Verbinder 10">
+              <a:extLst>
+                <a:ext uri="{FF2B5EF4-FFF2-40B4-BE49-F238E27FC236}">
+                  <a16:creationId xmlns:a16="http://schemas.microsoft.com/office/drawing/2014/main" id="{AE6AC259-DD70-7F35-48FF-F3308BDB41DE}"/>
+                </a:ext>
+              </a:extLst>
+            </p:cNvPr>
+            <p:cNvCxnSpPr>
+              <a:cxnSpLocks/>
+            </p:cNvCxnSpPr>
+            <p:nvPr/>
+          </p:nvCxnSpPr>
+          <p:spPr>
+            <a:xfrm>
+              <a:off x="2346958" y="1078111"/>
+              <a:ext cx="0" cy="1496616"/>
+            </a:xfrm>
+            <a:prstGeom prst="line">
+              <a:avLst/>
+            </a:prstGeom>
+            <a:ln w="6350" cap="rnd">
+              <a:solidFill>
+                <a:schemeClr val="bg1">
+                  <a:lumMod val="75000"/>
+                </a:schemeClr>
+              </a:solidFill>
+              <a:round/>
+            </a:ln>
+          </p:spPr>
+          <p:style>
+            <a:lnRef idx="2">
+              <a:schemeClr val="accent1"/>
+            </a:lnRef>
+            <a:fillRef idx="0">
+              <a:schemeClr val="accent1"/>
+            </a:fillRef>
+            <a:effectRef idx="1">
+              <a:schemeClr val="accent1"/>
+            </a:effectRef>
+            <a:fontRef idx="minor">
+              <a:schemeClr val="tx1"/>
+            </a:fontRef>
+          </p:style>
+        </p:cxnSp>
+        <p:cxnSp>
+          <p:nvCxnSpPr>
+            <p:cNvPr id="12" name="Gerader Verbinder 11">
+              <a:extLst>
+                <a:ext uri="{FF2B5EF4-FFF2-40B4-BE49-F238E27FC236}">
+                  <a16:creationId xmlns:a16="http://schemas.microsoft.com/office/drawing/2014/main" id="{E2817942-06E3-90CF-940A-01B346BFCD63}"/>
+                </a:ext>
+              </a:extLst>
+            </p:cNvPr>
+            <p:cNvCxnSpPr>
+              <a:cxnSpLocks/>
+            </p:cNvCxnSpPr>
+            <p:nvPr/>
+          </p:nvCxnSpPr>
+          <p:spPr>
+            <a:xfrm>
+              <a:off x="2617944" y="1078111"/>
+              <a:ext cx="0" cy="1496616"/>
+            </a:xfrm>
+            <a:prstGeom prst="line">
+              <a:avLst/>
+            </a:prstGeom>
+            <a:ln w="6350" cap="rnd">
+              <a:solidFill>
+                <a:schemeClr val="bg1">
+                  <a:lumMod val="75000"/>
+                </a:schemeClr>
+              </a:solidFill>
+              <a:round/>
+            </a:ln>
+          </p:spPr>
+          <p:style>
+            <a:lnRef idx="2">
+              <a:schemeClr val="accent1"/>
+            </a:lnRef>
+            <a:fillRef idx="0">
+              <a:schemeClr val="accent1"/>
+            </a:fillRef>
+            <a:effectRef idx="1">
+              <a:schemeClr val="accent1"/>
+            </a:effectRef>
+            <a:fontRef idx="minor">
+              <a:schemeClr val="tx1"/>
+            </a:fontRef>
+          </p:style>
+        </p:cxnSp>
+        <p:cxnSp>
+          <p:nvCxnSpPr>
+            <p:cNvPr id="13" name="Gerader Verbinder 12">
+              <a:extLst>
+                <a:ext uri="{FF2B5EF4-FFF2-40B4-BE49-F238E27FC236}">
+                  <a16:creationId xmlns:a16="http://schemas.microsoft.com/office/drawing/2014/main" id="{1739F27C-2718-43F6-ED7D-EACD8A6886F0}"/>
+                </a:ext>
+              </a:extLst>
+            </p:cNvPr>
+            <p:cNvCxnSpPr>
+              <a:cxnSpLocks/>
+            </p:cNvCxnSpPr>
+            <p:nvPr/>
+          </p:nvCxnSpPr>
+          <p:spPr>
+            <a:xfrm>
+              <a:off x="2888930" y="1078111"/>
+              <a:ext cx="0" cy="1496616"/>
+            </a:xfrm>
+            <a:prstGeom prst="line">
+              <a:avLst/>
+            </a:prstGeom>
+            <a:ln w="6350" cap="rnd">
+              <a:solidFill>
+                <a:schemeClr val="bg1">
+                  <a:lumMod val="75000"/>
+                </a:schemeClr>
+              </a:solidFill>
+              <a:round/>
+            </a:ln>
+          </p:spPr>
+          <p:style>
+            <a:lnRef idx="2">
+              <a:schemeClr val="accent1"/>
+            </a:lnRef>
+            <a:fillRef idx="0">
+              <a:schemeClr val="accent1"/>
+            </a:fillRef>
+            <a:effectRef idx="1">
+              <a:schemeClr val="accent1"/>
+            </a:effectRef>
+            <a:fontRef idx="minor">
+              <a:schemeClr val="tx1"/>
+            </a:fontRef>
+          </p:style>
+        </p:cxnSp>
+        <p:cxnSp>
+          <p:nvCxnSpPr>
+            <p:cNvPr id="14" name="Gerader Verbinder 13">
+              <a:extLst>
+                <a:ext uri="{FF2B5EF4-FFF2-40B4-BE49-F238E27FC236}">
+                  <a16:creationId xmlns:a16="http://schemas.microsoft.com/office/drawing/2014/main" id="{42743C88-5E0C-0CFC-976A-809A2BAE2FB0}"/>
+                </a:ext>
+              </a:extLst>
+            </p:cNvPr>
+            <p:cNvCxnSpPr>
+              <a:cxnSpLocks/>
+            </p:cNvCxnSpPr>
+            <p:nvPr/>
+          </p:nvCxnSpPr>
+          <p:spPr>
+            <a:xfrm>
+              <a:off x="3159918" y="1078111"/>
+              <a:ext cx="0" cy="1496616"/>
+            </a:xfrm>
+            <a:prstGeom prst="line">
+              <a:avLst/>
+            </a:prstGeom>
+            <a:ln w="6350" cap="rnd">
+              <a:solidFill>
+                <a:schemeClr val="bg1">
+                  <a:lumMod val="75000"/>
+                </a:schemeClr>
+              </a:solidFill>
+              <a:round/>
+            </a:ln>
+          </p:spPr>
+          <p:style>
+            <a:lnRef idx="2">
+              <a:schemeClr val="accent1"/>
+            </a:lnRef>
+            <a:fillRef idx="0">
+              <a:schemeClr val="accent1"/>
+            </a:fillRef>
+            <a:effectRef idx="1">
+              <a:schemeClr val="accent1"/>
+            </a:effectRef>
+            <a:fontRef idx="minor">
+              <a:schemeClr val="tx1"/>
+            </a:fontRef>
+          </p:style>
+        </p:cxnSp>
+      </p:grpSp>
+      <p:sp>
+        <p:nvSpPr>
+          <p:cNvPr id="28" name="Freihandform: Form 27">
+            <a:extLst>
+              <a:ext uri="{FF2B5EF4-FFF2-40B4-BE49-F238E27FC236}">
+                <a16:creationId xmlns:a16="http://schemas.microsoft.com/office/drawing/2014/main" id="{3C6A73C5-70DB-6408-7202-5D801F1D1DD2}"/>
+              </a:ext>
+            </a:extLst>
+          </p:cNvPr>
+          <p:cNvSpPr/>
+          <p:nvPr/>
+        </p:nvSpPr>
+        <p:spPr>
+          <a:xfrm>
+            <a:off x="571500" y="1076324"/>
+            <a:ext cx="928209" cy="1365885"/>
+          </a:xfrm>
+          <a:custGeom>
+            <a:avLst/>
+            <a:gdLst>
+              <a:gd name="csX0" fmla="*/ 0 w 938580"/>
+              <a:gd name="csY0" fmla="*/ 1365885 h 1365885"/>
+              <a:gd name="csX1" fmla="*/ 43815 w 938580"/>
+              <a:gd name="csY1" fmla="*/ 1089660 h 1365885"/>
+              <a:gd name="csX2" fmla="*/ 122154 w 938580"/>
+              <a:gd name="csY2" fmla="*/ 750570 h 1365885"/>
+              <a:gd name="csX3" fmla="*/ 238827 w 938580"/>
+              <a:gd name="csY3" fmla="*/ 390525 h 1365885"/>
+              <a:gd name="csX4" fmla="*/ 464799 w 938580"/>
+              <a:gd name="csY4" fmla="*/ 87630 h 1365885"/>
+              <a:gd name="csX5" fmla="*/ 938580 w 938580"/>
+              <a:gd name="csY5" fmla="*/ 0 h 1365885"/>
+            </a:gdLst>
+            <a:ahLst/>
+            <a:cxnLst>
+              <a:cxn ang="0">
+                <a:pos x="csX0" y="csY0"/>
+              </a:cxn>
+              <a:cxn ang="0">
+                <a:pos x="csX1" y="csY1"/>
+              </a:cxn>
+              <a:cxn ang="0">
+                <a:pos x="csX2" y="csY2"/>
+              </a:cxn>
+              <a:cxn ang="0">
+                <a:pos x="csX3" y="csY3"/>
+              </a:cxn>
+              <a:cxn ang="0">
+                <a:pos x="csX4" y="csY4"/>
+              </a:cxn>
+              <a:cxn ang="0">
+                <a:pos x="csX5" y="csY5"/>
+              </a:cxn>
+            </a:cxnLst>
+            <a:rect l="l" t="t" r="r" b="b"/>
+            <a:pathLst>
+              <a:path w="938580" h="1365885">
+                <a:moveTo>
+                  <a:pt x="0" y="1365885"/>
+                </a:moveTo>
+                <a:cubicBezTo>
+                  <a:pt x="13494" y="1273492"/>
+                  <a:pt x="23456" y="1192212"/>
+                  <a:pt x="43815" y="1089660"/>
+                </a:cubicBezTo>
+                <a:cubicBezTo>
+                  <a:pt x="64174" y="987108"/>
+                  <a:pt x="89652" y="867092"/>
+                  <a:pt x="122154" y="750570"/>
+                </a:cubicBezTo>
+                <a:cubicBezTo>
+                  <a:pt x="154656" y="634048"/>
+                  <a:pt x="188950" y="504461"/>
+                  <a:pt x="238827" y="390525"/>
+                </a:cubicBezTo>
+                <a:cubicBezTo>
+                  <a:pt x="280524" y="295275"/>
+                  <a:pt x="348174" y="152718"/>
+                  <a:pt x="464799" y="87630"/>
+                </a:cubicBezTo>
+                <a:cubicBezTo>
+                  <a:pt x="581425" y="22543"/>
+                  <a:pt x="718038" y="4763"/>
+                  <a:pt x="938580" y="0"/>
+                </a:cubicBezTo>
+              </a:path>
+            </a:pathLst>
+          </a:custGeom>
+          <a:noFill/>
+          <a:ln w="12700" cap="rnd">
+            <a:solidFill>
+              <a:schemeClr val="accent6"/>
+            </a:solidFill>
+            <a:prstDash val="solid"/>
+            <a:round/>
+          </a:ln>
+        </p:spPr>
+        <p:style>
+          <a:lnRef idx="2">
+            <a:schemeClr val="accent1">
+              <a:shade val="15000"/>
+            </a:schemeClr>
+          </a:lnRef>
+          <a:fillRef idx="1">
+            <a:schemeClr val="accent1"/>
+          </a:fillRef>
+          <a:effectRef idx="0">
+            <a:schemeClr val="accent1"/>
+          </a:effectRef>
+          <a:fontRef idx="minor">
+            <a:schemeClr val="lt1"/>
+          </a:fontRef>
+        </p:style>
+        <p:txBody>
+          <a:bodyPr rtlCol="0" anchor="ctr"/>
+          <a:lstStyle/>
+          <a:p>
+            <a:pPr algn="ctr"/>
+            <a:endParaRPr lang="de-DE" dirty="0"/>
+          </a:p>
+        </p:txBody>
+      </p:sp>
+      <p:sp>
+        <p:nvSpPr>
+          <p:cNvPr id="29" name="Freihandform: Form 28">
+            <a:extLst>
+              <a:ext uri="{FF2B5EF4-FFF2-40B4-BE49-F238E27FC236}">
+                <a16:creationId xmlns:a16="http://schemas.microsoft.com/office/drawing/2014/main" id="{E4316D02-8771-CD79-17FA-9C8EA8BE114D}"/>
+              </a:ext>
+            </a:extLst>
+          </p:cNvPr>
+          <p:cNvSpPr/>
+          <p:nvPr/>
+        </p:nvSpPr>
+        <p:spPr>
+          <a:xfrm>
+            <a:off x="569596" y="1085850"/>
+            <a:ext cx="2708910" cy="1356360"/>
+          </a:xfrm>
+          <a:custGeom>
+            <a:avLst/>
+            <a:gdLst>
+              <a:gd name="csX0" fmla="*/ 0 w 2714625"/>
+              <a:gd name="csY0" fmla="*/ 1360170 h 1360170"/>
+              <a:gd name="csX1" fmla="*/ 329565 w 2714625"/>
+              <a:gd name="csY1" fmla="*/ 815340 h 1360170"/>
+              <a:gd name="csX2" fmla="*/ 716280 w 2714625"/>
+              <a:gd name="csY2" fmla="*/ 304800 h 1360170"/>
+              <a:gd name="csX3" fmla="*/ 1053465 w 2714625"/>
+              <a:gd name="csY3" fmla="*/ 76200 h 1360170"/>
+              <a:gd name="csX4" fmla="*/ 1504950 w 2714625"/>
+              <a:gd name="csY4" fmla="*/ 9525 h 1360170"/>
+              <a:gd name="csX5" fmla="*/ 2714625 w 2714625"/>
+              <a:gd name="csY5" fmla="*/ 0 h 1360170"/>
+            </a:gdLst>
+            <a:ahLst/>
+            <a:cxnLst>
+              <a:cxn ang="0">
+                <a:pos x="csX0" y="csY0"/>
+              </a:cxn>
+              <a:cxn ang="0">
+                <a:pos x="csX1" y="csY1"/>
+              </a:cxn>
+              <a:cxn ang="0">
+                <a:pos x="csX2" y="csY2"/>
+              </a:cxn>
+              <a:cxn ang="0">
+                <a:pos x="csX3" y="csY3"/>
+              </a:cxn>
+              <a:cxn ang="0">
+                <a:pos x="csX4" y="csY4"/>
+              </a:cxn>
+              <a:cxn ang="0">
+                <a:pos x="csX5" y="csY5"/>
+              </a:cxn>
+            </a:cxnLst>
+            <a:rect l="l" t="t" r="r" b="b"/>
+            <a:pathLst>
+              <a:path w="2714625" h="1360170">
+                <a:moveTo>
+                  <a:pt x="0" y="1360170"/>
+                </a:moveTo>
+                <a:cubicBezTo>
+                  <a:pt x="105092" y="1175702"/>
+                  <a:pt x="210185" y="991235"/>
+                  <a:pt x="329565" y="815340"/>
+                </a:cubicBezTo>
+                <a:cubicBezTo>
+                  <a:pt x="448945" y="639445"/>
+                  <a:pt x="595630" y="427990"/>
+                  <a:pt x="716280" y="304800"/>
+                </a:cubicBezTo>
+                <a:cubicBezTo>
+                  <a:pt x="836930" y="181610"/>
+                  <a:pt x="944880" y="121602"/>
+                  <a:pt x="1053465" y="76200"/>
+                </a:cubicBezTo>
+                <a:cubicBezTo>
+                  <a:pt x="1162050" y="30798"/>
+                  <a:pt x="1238250" y="18415"/>
+                  <a:pt x="1504950" y="9525"/>
+                </a:cubicBezTo>
+                <a:cubicBezTo>
+                  <a:pt x="1771650" y="635"/>
+                  <a:pt x="2478088" y="3492"/>
+                  <a:pt x="2714625" y="0"/>
+                </a:cubicBezTo>
+              </a:path>
+            </a:pathLst>
+          </a:custGeom>
+          <a:noFill/>
+          <a:ln w="12700" cap="rnd">
+            <a:solidFill>
+              <a:srgbClr val="0070C0"/>
+            </a:solidFill>
+            <a:round/>
+          </a:ln>
+        </p:spPr>
+        <p:style>
+          <a:lnRef idx="2">
+            <a:schemeClr val="accent1">
+              <a:shade val="15000"/>
+            </a:schemeClr>
+          </a:lnRef>
+          <a:fillRef idx="1">
+            <a:schemeClr val="accent1"/>
+          </a:fillRef>
+          <a:effectRef idx="0">
+            <a:schemeClr val="accent1"/>
+          </a:effectRef>
+          <a:fontRef idx="minor">
+            <a:schemeClr val="lt1"/>
+          </a:fontRef>
+        </p:style>
+        <p:txBody>
+          <a:bodyPr rtlCol="0" anchor="ctr"/>
+          <a:lstStyle/>
+          <a:p>
+            <a:pPr algn="ctr"/>
+            <a:endParaRPr lang="de-DE"/>
+          </a:p>
+        </p:txBody>
+      </p:sp>
+      <p:sp>
+        <p:nvSpPr>
+          <p:cNvPr id="30" name="Freihandform: Form 29">
+            <a:extLst>
+              <a:ext uri="{FF2B5EF4-FFF2-40B4-BE49-F238E27FC236}">
+                <a16:creationId xmlns:a16="http://schemas.microsoft.com/office/drawing/2014/main" id="{44F2C840-E4F6-56DE-3D7E-9183FBBE3E71}"/>
+              </a:ext>
+            </a:extLst>
+          </p:cNvPr>
+          <p:cNvSpPr/>
+          <p:nvPr/>
+        </p:nvSpPr>
+        <p:spPr>
+          <a:xfrm>
+            <a:off x="569596" y="1085850"/>
+            <a:ext cx="2708910" cy="1356360"/>
+          </a:xfrm>
+          <a:custGeom>
+            <a:avLst/>
+            <a:gdLst>
+              <a:gd name="csX0" fmla="*/ 0 w 2714625"/>
+              <a:gd name="csY0" fmla="*/ 1358265 h 1358265"/>
+              <a:gd name="csX1" fmla="*/ 226695 w 2714625"/>
+              <a:gd name="csY1" fmla="*/ 1312545 h 1358265"/>
+              <a:gd name="csX2" fmla="*/ 468630 w 2714625"/>
+              <a:gd name="csY2" fmla="*/ 1169670 h 1358265"/>
+              <a:gd name="csX3" fmla="*/ 781050 w 2714625"/>
+              <a:gd name="csY3" fmla="*/ 866775 h 1358265"/>
+              <a:gd name="csX4" fmla="*/ 1127760 w 2714625"/>
+              <a:gd name="csY4" fmla="*/ 453390 h 1358265"/>
+              <a:gd name="csX5" fmla="*/ 1445895 w 2714625"/>
+              <a:gd name="csY5" fmla="*/ 169545 h 1358265"/>
+              <a:gd name="csX6" fmla="*/ 1744980 w 2714625"/>
+              <a:gd name="csY6" fmla="*/ 45720 h 1358265"/>
+              <a:gd name="csX7" fmla="*/ 2072640 w 2714625"/>
+              <a:gd name="csY7" fmla="*/ 11430 h 1358265"/>
+              <a:gd name="csX8" fmla="*/ 2714625 w 2714625"/>
+              <a:gd name="csY8" fmla="*/ 0 h 1358265"/>
+            </a:gdLst>
+            <a:ahLst/>
+            <a:cxnLst>
+              <a:cxn ang="0">
+                <a:pos x="csX0" y="csY0"/>
+              </a:cxn>
+              <a:cxn ang="0">
+                <a:pos x="csX1" y="csY1"/>
+              </a:cxn>
+              <a:cxn ang="0">
+                <a:pos x="csX2" y="csY2"/>
+              </a:cxn>
+              <a:cxn ang="0">
+                <a:pos x="csX3" y="csY3"/>
+              </a:cxn>
+              <a:cxn ang="0">
+                <a:pos x="csX4" y="csY4"/>
+              </a:cxn>
+              <a:cxn ang="0">
+                <a:pos x="csX5" y="csY5"/>
+              </a:cxn>
+              <a:cxn ang="0">
+                <a:pos x="csX6" y="csY6"/>
+              </a:cxn>
+              <a:cxn ang="0">
+                <a:pos x="csX7" y="csY7"/>
+              </a:cxn>
+              <a:cxn ang="0">
+                <a:pos x="csX8" y="csY8"/>
+              </a:cxn>
+            </a:cxnLst>
+            <a:rect l="l" t="t" r="r" b="b"/>
+            <a:pathLst>
+              <a:path w="2714625" h="1358265">
+                <a:moveTo>
+                  <a:pt x="0" y="1358265"/>
+                </a:moveTo>
+                <a:cubicBezTo>
+                  <a:pt x="69532" y="1355883"/>
+                  <a:pt x="148590" y="1343977"/>
+                  <a:pt x="226695" y="1312545"/>
+                </a:cubicBezTo>
+                <a:cubicBezTo>
+                  <a:pt x="304800" y="1281113"/>
+                  <a:pt x="376238" y="1243965"/>
+                  <a:pt x="468630" y="1169670"/>
+                </a:cubicBezTo>
+                <a:cubicBezTo>
+                  <a:pt x="561022" y="1095375"/>
+                  <a:pt x="671195" y="986155"/>
+                  <a:pt x="781050" y="866775"/>
+                </a:cubicBezTo>
+                <a:cubicBezTo>
+                  <a:pt x="890905" y="747395"/>
+                  <a:pt x="1024572" y="567690"/>
+                  <a:pt x="1127760" y="453390"/>
+                </a:cubicBezTo>
+                <a:cubicBezTo>
+                  <a:pt x="1230948" y="339090"/>
+                  <a:pt x="1343025" y="237490"/>
+                  <a:pt x="1445895" y="169545"/>
+                </a:cubicBezTo>
+                <a:cubicBezTo>
+                  <a:pt x="1548765" y="101600"/>
+                  <a:pt x="1640523" y="72072"/>
+                  <a:pt x="1744980" y="45720"/>
+                </a:cubicBezTo>
+                <a:cubicBezTo>
+                  <a:pt x="1849437" y="19368"/>
+                  <a:pt x="1911033" y="19050"/>
+                  <a:pt x="2072640" y="11430"/>
+                </a:cubicBezTo>
+                <a:cubicBezTo>
+                  <a:pt x="2234247" y="3810"/>
+                  <a:pt x="2714625" y="0"/>
+                  <a:pt x="2714625" y="0"/>
+                </a:cubicBezTo>
+              </a:path>
+            </a:pathLst>
+          </a:custGeom>
+          <a:noFill/>
+          <a:ln w="12700" cap="rnd">
+            <a:solidFill>
+              <a:schemeClr val="accent2"/>
+            </a:solidFill>
+            <a:round/>
+          </a:ln>
+        </p:spPr>
+        <p:style>
+          <a:lnRef idx="2">
+            <a:schemeClr val="accent1">
+              <a:shade val="15000"/>
+            </a:schemeClr>
+          </a:lnRef>
+          <a:fillRef idx="1">
+            <a:schemeClr val="accent1"/>
+          </a:fillRef>
+          <a:effectRef idx="0">
+            <a:schemeClr val="accent1"/>
+          </a:effectRef>
+          <a:fontRef idx="minor">
+            <a:schemeClr val="lt1"/>
+          </a:fontRef>
+        </p:style>
+        <p:txBody>
+          <a:bodyPr rtlCol="0" anchor="ctr"/>
+          <a:lstStyle/>
+          <a:p>
+            <a:pPr algn="ctr"/>
+            <a:endParaRPr lang="de-DE"/>
+          </a:p>
+        </p:txBody>
+      </p:sp>
+      <p:sp>
+        <p:nvSpPr>
+          <p:cNvPr id="32" name="Textfeld 31">
+            <a:extLst>
+              <a:ext uri="{FF2B5EF4-FFF2-40B4-BE49-F238E27FC236}">
+                <a16:creationId xmlns:a16="http://schemas.microsoft.com/office/drawing/2014/main" id="{A8D92422-4168-58F2-E04B-1E78BA0822DA}"/>
+              </a:ext>
+            </a:extLst>
+          </p:cNvPr>
+          <p:cNvSpPr txBox="1"/>
+          <p:nvPr/>
+        </p:nvSpPr>
+        <p:spPr>
+          <a:xfrm>
+            <a:off x="474422" y="2495305"/>
+            <a:ext cx="198916" cy="215444"/>
+          </a:xfrm>
+          <a:prstGeom prst="rect">
+            <a:avLst/>
+          </a:prstGeom>
+          <a:noFill/>
+        </p:spPr>
+        <p:txBody>
+          <a:bodyPr wrap="square" rtlCol="0" anchor="ctr">
+            <a:spAutoFit/>
+          </a:bodyPr>
+          <a:lstStyle/>
+          <a:p>
+            <a:pPr algn="ctr"/>
+            <a:r>
+              <a:rPr lang="de-DE" sz="800" dirty="0">
+                <a:latin typeface="CMU Serif" panose="02000603000000000000" pitchFamily="2" charset="0"/>
+                <a:ea typeface="CMU Serif" panose="02000603000000000000" pitchFamily="2" charset="0"/>
+                <a:cs typeface="CMU Serif" panose="02000603000000000000" pitchFamily="2" charset="0"/>
+              </a:rPr>
+              <a:t>0</a:t>
+            </a:r>
+            <a:endParaRPr lang="de-DE" sz="800" baseline="-25000" dirty="0">
+              <a:latin typeface="CMU Serif" panose="02000603000000000000" pitchFamily="2" charset="0"/>
+              <a:ea typeface="CMU Serif" panose="02000603000000000000" pitchFamily="2" charset="0"/>
+              <a:cs typeface="CMU Serif" panose="02000603000000000000" pitchFamily="2" charset="0"/>
+            </a:endParaRPr>
+          </a:p>
+        </p:txBody>
+      </p:sp>
+      <p:sp>
+        <p:nvSpPr>
+          <p:cNvPr id="34" name="Textfeld 33">
+            <a:extLst>
+              <a:ext uri="{FF2B5EF4-FFF2-40B4-BE49-F238E27FC236}">
+                <a16:creationId xmlns:a16="http://schemas.microsoft.com/office/drawing/2014/main" id="{E866A6A2-EAF9-6155-0922-E02D7056B306}"/>
+              </a:ext>
+            </a:extLst>
+          </p:cNvPr>
+          <p:cNvSpPr txBox="1"/>
+          <p:nvPr/>
+        </p:nvSpPr>
+        <p:spPr>
+          <a:xfrm>
+            <a:off x="745143" y="2495305"/>
+            <a:ext cx="198916" cy="215444"/>
+          </a:xfrm>
+          <a:prstGeom prst="rect">
+            <a:avLst/>
+          </a:prstGeom>
+          <a:noFill/>
+        </p:spPr>
+        <p:txBody>
+          <a:bodyPr wrap="square" rtlCol="0" anchor="ctr">
+            <a:spAutoFit/>
+          </a:bodyPr>
+          <a:lstStyle/>
+          <a:p>
+            <a:pPr algn="ctr"/>
+            <a:r>
+              <a:rPr lang="de-DE" sz="800" dirty="0">
+                <a:latin typeface="CMU Serif" panose="02000603000000000000" pitchFamily="2" charset="0"/>
+                <a:ea typeface="CMU Serif" panose="02000603000000000000" pitchFamily="2" charset="0"/>
+                <a:cs typeface="CMU Serif" panose="02000603000000000000" pitchFamily="2" charset="0"/>
+              </a:rPr>
+              <a:t>1</a:t>
+            </a:r>
+            <a:endParaRPr lang="de-DE" sz="800" baseline="-25000" dirty="0">
+              <a:latin typeface="CMU Serif" panose="02000603000000000000" pitchFamily="2" charset="0"/>
+              <a:ea typeface="CMU Serif" panose="02000603000000000000" pitchFamily="2" charset="0"/>
+              <a:cs typeface="CMU Serif" panose="02000603000000000000" pitchFamily="2" charset="0"/>
+            </a:endParaRPr>
+          </a:p>
+        </p:txBody>
+      </p:sp>
+      <p:sp>
+        <p:nvSpPr>
+          <p:cNvPr id="36" name="Textfeld 35">
+            <a:extLst>
+              <a:ext uri="{FF2B5EF4-FFF2-40B4-BE49-F238E27FC236}">
+                <a16:creationId xmlns:a16="http://schemas.microsoft.com/office/drawing/2014/main" id="{4AA82D66-C555-71B2-0749-41639C5AB21A}"/>
+              </a:ext>
+            </a:extLst>
+          </p:cNvPr>
+          <p:cNvSpPr txBox="1"/>
+          <p:nvPr/>
+        </p:nvSpPr>
+        <p:spPr>
+          <a:xfrm>
+            <a:off x="1015864" y="2495305"/>
+            <a:ext cx="198916" cy="215444"/>
+          </a:xfrm>
+          <a:prstGeom prst="rect">
+            <a:avLst/>
+          </a:prstGeom>
+          <a:noFill/>
+        </p:spPr>
+        <p:txBody>
+          <a:bodyPr wrap="square" rtlCol="0" anchor="ctr">
+            <a:spAutoFit/>
+          </a:bodyPr>
+          <a:lstStyle/>
+          <a:p>
+            <a:pPr algn="ctr"/>
+            <a:r>
+              <a:rPr lang="de-DE" sz="800" dirty="0">
+                <a:latin typeface="CMU Serif" panose="02000603000000000000" pitchFamily="2" charset="0"/>
+                <a:ea typeface="CMU Serif" panose="02000603000000000000" pitchFamily="2" charset="0"/>
+                <a:cs typeface="CMU Serif" panose="02000603000000000000" pitchFamily="2" charset="0"/>
+              </a:rPr>
+              <a:t>2</a:t>
+            </a:r>
+            <a:endParaRPr lang="de-DE" sz="800" baseline="-25000" dirty="0">
+              <a:latin typeface="CMU Serif" panose="02000603000000000000" pitchFamily="2" charset="0"/>
+              <a:ea typeface="CMU Serif" panose="02000603000000000000" pitchFamily="2" charset="0"/>
+              <a:cs typeface="CMU Serif" panose="02000603000000000000" pitchFamily="2" charset="0"/>
+            </a:endParaRPr>
+          </a:p>
+        </p:txBody>
+      </p:sp>
+      <p:sp>
+        <p:nvSpPr>
+          <p:cNvPr id="38" name="Textfeld 37">
+            <a:extLst>
+              <a:ext uri="{FF2B5EF4-FFF2-40B4-BE49-F238E27FC236}">
+                <a16:creationId xmlns:a16="http://schemas.microsoft.com/office/drawing/2014/main" id="{9D11E029-C448-1EB3-8EBA-9D1FAF0C9400}"/>
+              </a:ext>
+            </a:extLst>
+          </p:cNvPr>
+          <p:cNvSpPr txBox="1"/>
+          <p:nvPr/>
+        </p:nvSpPr>
+        <p:spPr>
+          <a:xfrm>
+            <a:off x="1286585" y="2495305"/>
+            <a:ext cx="198916" cy="215444"/>
+          </a:xfrm>
+          <a:prstGeom prst="rect">
+            <a:avLst/>
+          </a:prstGeom>
+          <a:noFill/>
+        </p:spPr>
+        <p:txBody>
+          <a:bodyPr wrap="square" rtlCol="0" anchor="ctr">
+            <a:spAutoFit/>
+          </a:bodyPr>
+          <a:lstStyle/>
+          <a:p>
+            <a:pPr algn="ctr"/>
+            <a:r>
+              <a:rPr lang="de-DE" sz="800" dirty="0">
+                <a:latin typeface="CMU Serif" panose="02000603000000000000" pitchFamily="2" charset="0"/>
+                <a:ea typeface="CMU Serif" panose="02000603000000000000" pitchFamily="2" charset="0"/>
+                <a:cs typeface="CMU Serif" panose="02000603000000000000" pitchFamily="2" charset="0"/>
+              </a:rPr>
+              <a:t>3</a:t>
+            </a:r>
+            <a:endParaRPr lang="de-DE" sz="800" baseline="-25000" dirty="0">
+              <a:latin typeface="CMU Serif" panose="02000603000000000000" pitchFamily="2" charset="0"/>
+              <a:ea typeface="CMU Serif" panose="02000603000000000000" pitchFamily="2" charset="0"/>
+              <a:cs typeface="CMU Serif" panose="02000603000000000000" pitchFamily="2" charset="0"/>
+            </a:endParaRPr>
+          </a:p>
+        </p:txBody>
+      </p:sp>
+      <p:sp>
+        <p:nvSpPr>
+          <p:cNvPr id="40" name="Textfeld 39">
+            <a:extLst>
+              <a:ext uri="{FF2B5EF4-FFF2-40B4-BE49-F238E27FC236}">
+                <a16:creationId xmlns:a16="http://schemas.microsoft.com/office/drawing/2014/main" id="{97E1E7FB-21D9-66F1-C251-ACE506A92FB9}"/>
+              </a:ext>
+            </a:extLst>
+          </p:cNvPr>
+          <p:cNvSpPr txBox="1"/>
+          <p:nvPr/>
+        </p:nvSpPr>
+        <p:spPr>
+          <a:xfrm>
+            <a:off x="1557306" y="2495305"/>
+            <a:ext cx="198916" cy="215444"/>
+          </a:xfrm>
+          <a:prstGeom prst="rect">
+            <a:avLst/>
+          </a:prstGeom>
+          <a:noFill/>
+        </p:spPr>
+        <p:txBody>
+          <a:bodyPr wrap="square" rtlCol="0" anchor="ctr">
+            <a:spAutoFit/>
+          </a:bodyPr>
+          <a:lstStyle/>
+          <a:p>
+            <a:pPr algn="ctr"/>
+            <a:r>
+              <a:rPr lang="de-DE" sz="800" dirty="0">
+                <a:latin typeface="CMU Serif" panose="02000603000000000000" pitchFamily="2" charset="0"/>
+                <a:ea typeface="CMU Serif" panose="02000603000000000000" pitchFamily="2" charset="0"/>
+                <a:cs typeface="CMU Serif" panose="02000603000000000000" pitchFamily="2" charset="0"/>
+              </a:rPr>
+              <a:t>4</a:t>
+            </a:r>
+            <a:endParaRPr lang="de-DE" sz="800" baseline="-25000" dirty="0">
+              <a:latin typeface="CMU Serif" panose="02000603000000000000" pitchFamily="2" charset="0"/>
+              <a:ea typeface="CMU Serif" panose="02000603000000000000" pitchFamily="2" charset="0"/>
+              <a:cs typeface="CMU Serif" panose="02000603000000000000" pitchFamily="2" charset="0"/>
+            </a:endParaRPr>
+          </a:p>
+        </p:txBody>
+      </p:sp>
+      <p:sp>
+        <p:nvSpPr>
+          <p:cNvPr id="42" name="Textfeld 41">
+            <a:extLst>
+              <a:ext uri="{FF2B5EF4-FFF2-40B4-BE49-F238E27FC236}">
+                <a16:creationId xmlns:a16="http://schemas.microsoft.com/office/drawing/2014/main" id="{B2ED6285-333C-AD05-C04E-22DAD949D5BC}"/>
+              </a:ext>
+            </a:extLst>
+          </p:cNvPr>
+          <p:cNvSpPr txBox="1"/>
+          <p:nvPr/>
+        </p:nvSpPr>
+        <p:spPr>
+          <a:xfrm>
+            <a:off x="1828027" y="2495305"/>
+            <a:ext cx="198916" cy="215444"/>
+          </a:xfrm>
+          <a:prstGeom prst="rect">
+            <a:avLst/>
+          </a:prstGeom>
+          <a:noFill/>
+        </p:spPr>
+        <p:txBody>
+          <a:bodyPr wrap="square" rtlCol="0" anchor="ctr">
+            <a:spAutoFit/>
+          </a:bodyPr>
+          <a:lstStyle/>
+          <a:p>
+            <a:pPr algn="ctr"/>
+            <a:r>
+              <a:rPr lang="de-DE" sz="800" dirty="0">
+                <a:latin typeface="CMU Serif" panose="02000603000000000000" pitchFamily="2" charset="0"/>
+                <a:ea typeface="CMU Serif" panose="02000603000000000000" pitchFamily="2" charset="0"/>
+                <a:cs typeface="CMU Serif" panose="02000603000000000000" pitchFamily="2" charset="0"/>
+              </a:rPr>
+              <a:t>5</a:t>
+            </a:r>
+            <a:endParaRPr lang="de-DE" sz="800" baseline="-25000" dirty="0">
+              <a:latin typeface="CMU Serif" panose="02000603000000000000" pitchFamily="2" charset="0"/>
+              <a:ea typeface="CMU Serif" panose="02000603000000000000" pitchFamily="2" charset="0"/>
+              <a:cs typeface="CMU Serif" panose="02000603000000000000" pitchFamily="2" charset="0"/>
+            </a:endParaRPr>
+          </a:p>
+        </p:txBody>
+      </p:sp>
+      <p:sp>
+        <p:nvSpPr>
+          <p:cNvPr id="44" name="Textfeld 43">
+            <a:extLst>
+              <a:ext uri="{FF2B5EF4-FFF2-40B4-BE49-F238E27FC236}">
+                <a16:creationId xmlns:a16="http://schemas.microsoft.com/office/drawing/2014/main" id="{AD4AD6ED-95F9-E637-F33F-C31550FF6DA5}"/>
+              </a:ext>
+            </a:extLst>
+          </p:cNvPr>
+          <p:cNvSpPr txBox="1"/>
+          <p:nvPr/>
+        </p:nvSpPr>
+        <p:spPr>
+          <a:xfrm>
+            <a:off x="2098748" y="2495305"/>
+            <a:ext cx="198916" cy="215444"/>
+          </a:xfrm>
+          <a:prstGeom prst="rect">
+            <a:avLst/>
+          </a:prstGeom>
+          <a:noFill/>
+        </p:spPr>
+        <p:txBody>
+          <a:bodyPr wrap="square" rtlCol="0" anchor="ctr">
+            <a:spAutoFit/>
+          </a:bodyPr>
+          <a:lstStyle/>
+          <a:p>
+            <a:pPr algn="ctr"/>
+            <a:r>
+              <a:rPr lang="de-DE" sz="800" dirty="0">
+                <a:latin typeface="CMU Serif" panose="02000603000000000000" pitchFamily="2" charset="0"/>
+                <a:ea typeface="CMU Serif" panose="02000603000000000000" pitchFamily="2" charset="0"/>
+                <a:cs typeface="CMU Serif" panose="02000603000000000000" pitchFamily="2" charset="0"/>
+              </a:rPr>
+              <a:t>6</a:t>
+            </a:r>
+            <a:endParaRPr lang="de-DE" sz="800" baseline="-25000" dirty="0">
+              <a:latin typeface="CMU Serif" panose="02000603000000000000" pitchFamily="2" charset="0"/>
+              <a:ea typeface="CMU Serif" panose="02000603000000000000" pitchFamily="2" charset="0"/>
+              <a:cs typeface="CMU Serif" panose="02000603000000000000" pitchFamily="2" charset="0"/>
+            </a:endParaRPr>
+          </a:p>
+        </p:txBody>
+      </p:sp>
+      <p:sp>
+        <p:nvSpPr>
+          <p:cNvPr id="46" name="Textfeld 45">
+            <a:extLst>
+              <a:ext uri="{FF2B5EF4-FFF2-40B4-BE49-F238E27FC236}">
+                <a16:creationId xmlns:a16="http://schemas.microsoft.com/office/drawing/2014/main" id="{586449B5-5D04-3D88-DD03-A1E3210E58AD}"/>
+              </a:ext>
+            </a:extLst>
+          </p:cNvPr>
+          <p:cNvSpPr txBox="1"/>
+          <p:nvPr/>
+        </p:nvSpPr>
+        <p:spPr>
+          <a:xfrm>
+            <a:off x="2369469" y="2495305"/>
+            <a:ext cx="198916" cy="215444"/>
+          </a:xfrm>
+          <a:prstGeom prst="rect">
+            <a:avLst/>
+          </a:prstGeom>
+          <a:noFill/>
+        </p:spPr>
+        <p:txBody>
+          <a:bodyPr wrap="square" rtlCol="0" anchor="ctr">
+            <a:spAutoFit/>
+          </a:bodyPr>
+          <a:lstStyle/>
+          <a:p>
+            <a:pPr algn="ctr"/>
+            <a:r>
+              <a:rPr lang="de-DE" sz="800" dirty="0">
+                <a:latin typeface="CMU Serif" panose="02000603000000000000" pitchFamily="2" charset="0"/>
+                <a:ea typeface="CMU Serif" panose="02000603000000000000" pitchFamily="2" charset="0"/>
+                <a:cs typeface="CMU Serif" panose="02000603000000000000" pitchFamily="2" charset="0"/>
+              </a:rPr>
+              <a:t>7</a:t>
+            </a:r>
+            <a:endParaRPr lang="de-DE" sz="800" baseline="-25000" dirty="0">
+              <a:latin typeface="CMU Serif" panose="02000603000000000000" pitchFamily="2" charset="0"/>
+              <a:ea typeface="CMU Serif" panose="02000603000000000000" pitchFamily="2" charset="0"/>
+              <a:cs typeface="CMU Serif" panose="02000603000000000000" pitchFamily="2" charset="0"/>
+            </a:endParaRPr>
+          </a:p>
+        </p:txBody>
+      </p:sp>
+      <p:sp>
+        <p:nvSpPr>
+          <p:cNvPr id="48" name="Textfeld 47">
+            <a:extLst>
+              <a:ext uri="{FF2B5EF4-FFF2-40B4-BE49-F238E27FC236}">
+                <a16:creationId xmlns:a16="http://schemas.microsoft.com/office/drawing/2014/main" id="{B761A7DE-10ED-2A94-1FE6-FEBEAD7A652A}"/>
+              </a:ext>
+            </a:extLst>
+          </p:cNvPr>
+          <p:cNvSpPr txBox="1"/>
+          <p:nvPr/>
+        </p:nvSpPr>
+        <p:spPr>
+          <a:xfrm>
+            <a:off x="2640190" y="2495305"/>
+            <a:ext cx="198916" cy="215444"/>
+          </a:xfrm>
+          <a:prstGeom prst="rect">
+            <a:avLst/>
+          </a:prstGeom>
+          <a:noFill/>
+        </p:spPr>
+        <p:txBody>
+          <a:bodyPr wrap="square" rtlCol="0" anchor="ctr">
+            <a:spAutoFit/>
+          </a:bodyPr>
+          <a:lstStyle/>
+          <a:p>
+            <a:pPr algn="ctr"/>
+            <a:r>
+              <a:rPr lang="de-DE" sz="800" dirty="0">
+                <a:latin typeface="CMU Serif" panose="02000603000000000000" pitchFamily="2" charset="0"/>
+                <a:ea typeface="CMU Serif" panose="02000603000000000000" pitchFamily="2" charset="0"/>
+                <a:cs typeface="CMU Serif" panose="02000603000000000000" pitchFamily="2" charset="0"/>
+              </a:rPr>
+              <a:t>8</a:t>
+            </a:r>
+            <a:endParaRPr lang="de-DE" sz="800" baseline="-25000" dirty="0">
+              <a:latin typeface="CMU Serif" panose="02000603000000000000" pitchFamily="2" charset="0"/>
+              <a:ea typeface="CMU Serif" panose="02000603000000000000" pitchFamily="2" charset="0"/>
+              <a:cs typeface="CMU Serif" panose="02000603000000000000" pitchFamily="2" charset="0"/>
+            </a:endParaRPr>
+          </a:p>
+        </p:txBody>
+      </p:sp>
+      <p:sp>
+        <p:nvSpPr>
+          <p:cNvPr id="50" name="Textfeld 49">
+            <a:extLst>
+              <a:ext uri="{FF2B5EF4-FFF2-40B4-BE49-F238E27FC236}">
+                <a16:creationId xmlns:a16="http://schemas.microsoft.com/office/drawing/2014/main" id="{66D97202-C9CD-C61E-F955-7CDB9824CC47}"/>
+              </a:ext>
+            </a:extLst>
+          </p:cNvPr>
+          <p:cNvSpPr txBox="1"/>
+          <p:nvPr/>
+        </p:nvSpPr>
+        <p:spPr>
+          <a:xfrm>
+            <a:off x="2910915" y="2495305"/>
+            <a:ext cx="198916" cy="215444"/>
+          </a:xfrm>
+          <a:prstGeom prst="rect">
+            <a:avLst/>
+          </a:prstGeom>
+          <a:noFill/>
+        </p:spPr>
+        <p:txBody>
+          <a:bodyPr wrap="square" rtlCol="0" anchor="ctr">
+            <a:spAutoFit/>
+          </a:bodyPr>
+          <a:lstStyle/>
+          <a:p>
+            <a:pPr algn="ctr"/>
+            <a:r>
+              <a:rPr lang="de-DE" sz="800" dirty="0">
+                <a:latin typeface="CMU Serif" panose="02000603000000000000" pitchFamily="2" charset="0"/>
+                <a:ea typeface="CMU Serif" panose="02000603000000000000" pitchFamily="2" charset="0"/>
+                <a:cs typeface="CMU Serif" panose="02000603000000000000" pitchFamily="2" charset="0"/>
+              </a:rPr>
+              <a:t>9</a:t>
+            </a:r>
+            <a:endParaRPr lang="de-DE" sz="800" baseline="-25000" dirty="0">
+              <a:latin typeface="CMU Serif" panose="02000603000000000000" pitchFamily="2" charset="0"/>
+              <a:ea typeface="CMU Serif" panose="02000603000000000000" pitchFamily="2" charset="0"/>
+              <a:cs typeface="CMU Serif" panose="02000603000000000000" pitchFamily="2" charset="0"/>
+            </a:endParaRPr>
+          </a:p>
+        </p:txBody>
+      </p:sp>
+      <p:sp>
+        <p:nvSpPr>
+          <p:cNvPr id="52" name="Textfeld 51">
+            <a:extLst>
+              <a:ext uri="{FF2B5EF4-FFF2-40B4-BE49-F238E27FC236}">
+                <a16:creationId xmlns:a16="http://schemas.microsoft.com/office/drawing/2014/main" id="{E9317CB6-711F-D2F2-6DA5-BCAFAD7743D5}"/>
+              </a:ext>
+            </a:extLst>
+          </p:cNvPr>
+          <p:cNvSpPr txBox="1"/>
+          <p:nvPr/>
+        </p:nvSpPr>
+        <p:spPr>
+          <a:xfrm>
+            <a:off x="3141444" y="2495305"/>
+            <a:ext cx="290079" cy="215444"/>
+          </a:xfrm>
+          <a:prstGeom prst="rect">
+            <a:avLst/>
+          </a:prstGeom>
+          <a:noFill/>
+        </p:spPr>
+        <p:txBody>
+          <a:bodyPr wrap="square" rtlCol="0" anchor="ctr">
+            <a:spAutoFit/>
+          </a:bodyPr>
+          <a:lstStyle/>
+          <a:p>
+            <a:pPr algn="ctr"/>
+            <a:r>
+              <a:rPr lang="de-DE" sz="800" dirty="0">
+                <a:latin typeface="CMU Serif" panose="02000603000000000000" pitchFamily="2" charset="0"/>
+                <a:ea typeface="CMU Serif" panose="02000603000000000000" pitchFamily="2" charset="0"/>
+                <a:cs typeface="CMU Serif" panose="02000603000000000000" pitchFamily="2" charset="0"/>
+              </a:rPr>
+              <a:t>10</a:t>
+            </a:r>
+            <a:endParaRPr lang="de-DE" sz="800" baseline="-25000" dirty="0">
+              <a:latin typeface="CMU Serif" panose="02000603000000000000" pitchFamily="2" charset="0"/>
+              <a:ea typeface="CMU Serif" panose="02000603000000000000" pitchFamily="2" charset="0"/>
+              <a:cs typeface="CMU Serif" panose="02000603000000000000" pitchFamily="2" charset="0"/>
+            </a:endParaRPr>
+          </a:p>
+        </p:txBody>
+      </p:sp>
+      <p:sp>
+        <p:nvSpPr>
+          <p:cNvPr id="54" name="Textfeld 53">
+            <a:extLst>
+              <a:ext uri="{FF2B5EF4-FFF2-40B4-BE49-F238E27FC236}">
+                <a16:creationId xmlns:a16="http://schemas.microsoft.com/office/drawing/2014/main" id="{1251DE49-D710-11C4-5C0A-D5B0941F5722}"/>
+              </a:ext>
+            </a:extLst>
+          </p:cNvPr>
+          <p:cNvSpPr txBox="1"/>
+          <p:nvPr/>
+        </p:nvSpPr>
+        <p:spPr>
+          <a:xfrm>
+            <a:off x="253541" y="2062078"/>
+            <a:ext cx="335541" cy="215444"/>
+          </a:xfrm>
+          <a:prstGeom prst="rect">
+            <a:avLst/>
+          </a:prstGeom>
+          <a:noFill/>
+        </p:spPr>
+        <p:txBody>
+          <a:bodyPr wrap="square" rtlCol="0" anchor="ctr">
+            <a:spAutoFit/>
+          </a:bodyPr>
+          <a:lstStyle/>
+          <a:p>
+            <a:pPr algn="ctr"/>
+            <a:r>
+              <a:rPr lang="de-DE" sz="800" dirty="0">
+                <a:latin typeface="CMU Serif" panose="02000603000000000000" pitchFamily="2" charset="0"/>
+                <a:ea typeface="CMU Serif" panose="02000603000000000000" pitchFamily="2" charset="0"/>
+                <a:cs typeface="CMU Serif" panose="02000603000000000000" pitchFamily="2" charset="0"/>
+              </a:rPr>
+              <a:t>0,2</a:t>
+            </a:r>
+            <a:endParaRPr lang="de-DE" sz="800" baseline="-25000" dirty="0">
+              <a:latin typeface="CMU Serif" panose="02000603000000000000" pitchFamily="2" charset="0"/>
+              <a:ea typeface="CMU Serif" panose="02000603000000000000" pitchFamily="2" charset="0"/>
+              <a:cs typeface="CMU Serif" panose="02000603000000000000" pitchFamily="2" charset="0"/>
+            </a:endParaRPr>
+          </a:p>
+        </p:txBody>
+      </p:sp>
+      <p:sp>
+        <p:nvSpPr>
+          <p:cNvPr id="56" name="Textfeld 55">
+            <a:extLst>
+              <a:ext uri="{FF2B5EF4-FFF2-40B4-BE49-F238E27FC236}">
+                <a16:creationId xmlns:a16="http://schemas.microsoft.com/office/drawing/2014/main" id="{CC254AEF-9C57-802E-01F3-7E7B8036E3C5}"/>
+              </a:ext>
+            </a:extLst>
+          </p:cNvPr>
+          <p:cNvSpPr txBox="1"/>
+          <p:nvPr/>
+        </p:nvSpPr>
+        <p:spPr>
+          <a:xfrm>
+            <a:off x="253541" y="2333360"/>
+            <a:ext cx="335541" cy="215444"/>
+          </a:xfrm>
+          <a:prstGeom prst="rect">
+            <a:avLst/>
+          </a:prstGeom>
+          <a:noFill/>
+        </p:spPr>
+        <p:txBody>
+          <a:bodyPr wrap="square" rtlCol="0" anchor="ctr">
+            <a:spAutoFit/>
+          </a:bodyPr>
+          <a:lstStyle/>
+          <a:p>
+            <a:pPr algn="ctr"/>
+            <a:r>
+              <a:rPr lang="de-DE" sz="800" dirty="0">
+                <a:latin typeface="CMU Serif" panose="02000603000000000000" pitchFamily="2" charset="0"/>
+                <a:ea typeface="CMU Serif" panose="02000603000000000000" pitchFamily="2" charset="0"/>
+                <a:cs typeface="CMU Serif" panose="02000603000000000000" pitchFamily="2" charset="0"/>
+              </a:rPr>
+              <a:t>0</a:t>
+            </a:r>
+            <a:endParaRPr lang="de-DE" sz="800" baseline="-25000" dirty="0">
+              <a:latin typeface="CMU Serif" panose="02000603000000000000" pitchFamily="2" charset="0"/>
+              <a:ea typeface="CMU Serif" panose="02000603000000000000" pitchFamily="2" charset="0"/>
+              <a:cs typeface="CMU Serif" panose="02000603000000000000" pitchFamily="2" charset="0"/>
+            </a:endParaRPr>
+          </a:p>
+        </p:txBody>
+      </p:sp>
+      <p:sp>
+        <p:nvSpPr>
+          <p:cNvPr id="58" name="Textfeld 57">
+            <a:extLst>
+              <a:ext uri="{FF2B5EF4-FFF2-40B4-BE49-F238E27FC236}">
+                <a16:creationId xmlns:a16="http://schemas.microsoft.com/office/drawing/2014/main" id="{44A4E3EA-47FB-2F44-FBF1-1B3881CFB69B}"/>
+              </a:ext>
+            </a:extLst>
+          </p:cNvPr>
+          <p:cNvSpPr txBox="1"/>
+          <p:nvPr/>
+        </p:nvSpPr>
+        <p:spPr>
+          <a:xfrm>
+            <a:off x="253541" y="1790798"/>
+            <a:ext cx="335541" cy="215444"/>
+          </a:xfrm>
+          <a:prstGeom prst="rect">
+            <a:avLst/>
+          </a:prstGeom>
+          <a:noFill/>
+        </p:spPr>
+        <p:txBody>
+          <a:bodyPr wrap="square" rtlCol="0" anchor="ctr">
+            <a:spAutoFit/>
+          </a:bodyPr>
+          <a:lstStyle/>
+          <a:p>
+            <a:pPr algn="ctr"/>
+            <a:r>
+              <a:rPr lang="de-DE" sz="800" dirty="0">
+                <a:latin typeface="CMU Serif" panose="02000603000000000000" pitchFamily="2" charset="0"/>
+                <a:ea typeface="CMU Serif" panose="02000603000000000000" pitchFamily="2" charset="0"/>
+                <a:cs typeface="CMU Serif" panose="02000603000000000000" pitchFamily="2" charset="0"/>
+              </a:rPr>
+              <a:t>0,4</a:t>
+            </a:r>
+            <a:endParaRPr lang="de-DE" sz="800" baseline="-25000" dirty="0">
+              <a:latin typeface="CMU Serif" panose="02000603000000000000" pitchFamily="2" charset="0"/>
+              <a:ea typeface="CMU Serif" panose="02000603000000000000" pitchFamily="2" charset="0"/>
+              <a:cs typeface="CMU Serif" panose="02000603000000000000" pitchFamily="2" charset="0"/>
+            </a:endParaRPr>
+          </a:p>
+        </p:txBody>
+      </p:sp>
+      <p:sp>
+        <p:nvSpPr>
+          <p:cNvPr id="60" name="Textfeld 59">
+            <a:extLst>
+              <a:ext uri="{FF2B5EF4-FFF2-40B4-BE49-F238E27FC236}">
+                <a16:creationId xmlns:a16="http://schemas.microsoft.com/office/drawing/2014/main" id="{47F4CF93-097E-42B6-2819-4890E9C6D4C7}"/>
+              </a:ext>
+            </a:extLst>
+          </p:cNvPr>
+          <p:cNvSpPr txBox="1"/>
+          <p:nvPr/>
+        </p:nvSpPr>
+        <p:spPr>
+          <a:xfrm>
+            <a:off x="253541" y="1519518"/>
+            <a:ext cx="335541" cy="215444"/>
+          </a:xfrm>
+          <a:prstGeom prst="rect">
+            <a:avLst/>
+          </a:prstGeom>
+          <a:noFill/>
+        </p:spPr>
+        <p:txBody>
+          <a:bodyPr wrap="square" rtlCol="0" anchor="ctr">
+            <a:spAutoFit/>
+          </a:bodyPr>
+          <a:lstStyle/>
+          <a:p>
+            <a:pPr algn="ctr"/>
+            <a:r>
+              <a:rPr lang="de-DE" sz="800" dirty="0">
+                <a:latin typeface="CMU Serif" panose="02000603000000000000" pitchFamily="2" charset="0"/>
+                <a:ea typeface="CMU Serif" panose="02000603000000000000" pitchFamily="2" charset="0"/>
+                <a:cs typeface="CMU Serif" panose="02000603000000000000" pitchFamily="2" charset="0"/>
+              </a:rPr>
+              <a:t>0,6</a:t>
+            </a:r>
+            <a:endParaRPr lang="de-DE" sz="800" baseline="-25000" dirty="0">
+              <a:latin typeface="CMU Serif" panose="02000603000000000000" pitchFamily="2" charset="0"/>
+              <a:ea typeface="CMU Serif" panose="02000603000000000000" pitchFamily="2" charset="0"/>
+              <a:cs typeface="CMU Serif" panose="02000603000000000000" pitchFamily="2" charset="0"/>
+            </a:endParaRPr>
+          </a:p>
+        </p:txBody>
+      </p:sp>
+      <p:sp>
+        <p:nvSpPr>
+          <p:cNvPr id="62" name="Textfeld 61">
+            <a:extLst>
+              <a:ext uri="{FF2B5EF4-FFF2-40B4-BE49-F238E27FC236}">
+                <a16:creationId xmlns:a16="http://schemas.microsoft.com/office/drawing/2014/main" id="{ECF4F59E-0B90-CF07-2564-A840D2349611}"/>
+              </a:ext>
+            </a:extLst>
+          </p:cNvPr>
+          <p:cNvSpPr txBox="1"/>
+          <p:nvPr/>
+        </p:nvSpPr>
+        <p:spPr>
+          <a:xfrm>
+            <a:off x="253541" y="1248238"/>
+            <a:ext cx="335541" cy="215444"/>
+          </a:xfrm>
+          <a:prstGeom prst="rect">
+            <a:avLst/>
+          </a:prstGeom>
+          <a:noFill/>
+        </p:spPr>
+        <p:txBody>
+          <a:bodyPr wrap="square" rtlCol="0" anchor="ctr">
+            <a:spAutoFit/>
+          </a:bodyPr>
+          <a:lstStyle/>
+          <a:p>
+            <a:pPr algn="ctr"/>
+            <a:r>
+              <a:rPr lang="de-DE" sz="800" dirty="0">
+                <a:latin typeface="CMU Serif" panose="02000603000000000000" pitchFamily="2" charset="0"/>
+                <a:ea typeface="CMU Serif" panose="02000603000000000000" pitchFamily="2" charset="0"/>
+                <a:cs typeface="CMU Serif" panose="02000603000000000000" pitchFamily="2" charset="0"/>
+              </a:rPr>
+              <a:t>0,8</a:t>
+            </a:r>
+            <a:endParaRPr lang="de-DE" sz="800" baseline="-25000" dirty="0">
+              <a:latin typeface="CMU Serif" panose="02000603000000000000" pitchFamily="2" charset="0"/>
+              <a:ea typeface="CMU Serif" panose="02000603000000000000" pitchFamily="2" charset="0"/>
+              <a:cs typeface="CMU Serif" panose="02000603000000000000" pitchFamily="2" charset="0"/>
+            </a:endParaRPr>
+          </a:p>
+        </p:txBody>
+      </p:sp>
+      <p:sp>
+        <p:nvSpPr>
+          <p:cNvPr id="64" name="Textfeld 63">
+            <a:extLst>
+              <a:ext uri="{FF2B5EF4-FFF2-40B4-BE49-F238E27FC236}">
+                <a16:creationId xmlns:a16="http://schemas.microsoft.com/office/drawing/2014/main" id="{969A12EC-9951-DD56-1F08-F968110AD18F}"/>
+              </a:ext>
+            </a:extLst>
+          </p:cNvPr>
+          <p:cNvSpPr txBox="1"/>
+          <p:nvPr/>
+        </p:nvSpPr>
+        <p:spPr>
+          <a:xfrm>
+            <a:off x="253541" y="976958"/>
+            <a:ext cx="335541" cy="215444"/>
+          </a:xfrm>
+          <a:prstGeom prst="rect">
+            <a:avLst/>
+          </a:prstGeom>
+          <a:noFill/>
+        </p:spPr>
+        <p:txBody>
+          <a:bodyPr wrap="square" rtlCol="0" anchor="ctr">
+            <a:spAutoFit/>
+          </a:bodyPr>
+          <a:lstStyle/>
+          <a:p>
+            <a:pPr algn="ctr"/>
+            <a:r>
+              <a:rPr lang="de-DE" sz="800" dirty="0">
+                <a:latin typeface="CMU Serif" panose="02000603000000000000" pitchFamily="2" charset="0"/>
+                <a:ea typeface="CMU Serif" panose="02000603000000000000" pitchFamily="2" charset="0"/>
+                <a:cs typeface="CMU Serif" panose="02000603000000000000" pitchFamily="2" charset="0"/>
+              </a:rPr>
+              <a:t>1</a:t>
+            </a:r>
+            <a:endParaRPr lang="de-DE" sz="800" baseline="-25000" dirty="0">
+              <a:latin typeface="CMU Serif" panose="02000603000000000000" pitchFamily="2" charset="0"/>
+              <a:ea typeface="CMU Serif" panose="02000603000000000000" pitchFamily="2" charset="0"/>
+              <a:cs typeface="CMU Serif" panose="02000603000000000000" pitchFamily="2" charset="0"/>
+            </a:endParaRPr>
+          </a:p>
+        </p:txBody>
+      </p:sp>
+      <p:sp>
+        <p:nvSpPr>
+          <p:cNvPr id="68" name="Rechteck 67">
+            <a:extLst>
+              <a:ext uri="{FF2B5EF4-FFF2-40B4-BE49-F238E27FC236}">
+                <a16:creationId xmlns:a16="http://schemas.microsoft.com/office/drawing/2014/main" id="{D506C9FF-56E4-897B-79F0-1E3FB865F5A2}"/>
+              </a:ext>
+            </a:extLst>
+          </p:cNvPr>
+          <p:cNvSpPr/>
+          <p:nvPr/>
+        </p:nvSpPr>
+        <p:spPr>
+          <a:xfrm>
+            <a:off x="1233882" y="1035299"/>
+            <a:ext cx="284603" cy="45719"/>
+          </a:xfrm>
+          <a:prstGeom prst="rect">
+            <a:avLst/>
+          </a:prstGeom>
+          <a:solidFill>
+            <a:schemeClr val="bg1"/>
+          </a:solidFill>
+          <a:ln>
+            <a:noFill/>
+          </a:ln>
+        </p:spPr>
+        <p:style>
+          <a:lnRef idx="2">
+            <a:schemeClr val="accent1">
+              <a:shade val="15000"/>
+            </a:schemeClr>
+          </a:lnRef>
+          <a:fillRef idx="1">
+            <a:schemeClr val="accent1"/>
+          </a:fillRef>
+          <a:effectRef idx="0">
+            <a:schemeClr val="accent1"/>
+          </a:effectRef>
+          <a:fontRef idx="minor">
+            <a:schemeClr val="lt1"/>
+          </a:fontRef>
+        </p:style>
+        <p:txBody>
+          <a:bodyPr rtlCol="0" anchor="ctr"/>
+          <a:lstStyle/>
+          <a:p>
+            <a:pPr algn="ctr"/>
+            <a:endParaRPr lang="de-DE"/>
+          </a:p>
+        </p:txBody>
+      </p:sp>
+      <p:sp>
+        <p:nvSpPr>
+          <p:cNvPr id="72" name="Textfeld 71">
+            <a:extLst>
+              <a:ext uri="{FF2B5EF4-FFF2-40B4-BE49-F238E27FC236}">
+                <a16:creationId xmlns:a16="http://schemas.microsoft.com/office/drawing/2014/main" id="{CF6C8F34-A2E4-5F5C-3322-86C6EAE33105}"/>
+              </a:ext>
+            </a:extLst>
+          </p:cNvPr>
+          <p:cNvSpPr txBox="1"/>
+          <p:nvPr/>
+        </p:nvSpPr>
+        <p:spPr>
+          <a:xfrm>
+            <a:off x="2958028" y="2618091"/>
+            <a:ext cx="366832" cy="276999"/>
+          </a:xfrm>
+          <a:prstGeom prst="rect">
+            <a:avLst/>
+          </a:prstGeom>
+          <a:noFill/>
+        </p:spPr>
+        <p:txBody>
+          <a:bodyPr wrap="square" rtlCol="0" anchor="ctr">
+            <a:spAutoFit/>
+          </a:bodyPr>
+          <a:lstStyle/>
+          <a:p>
+            <a:pPr algn="ctr"/>
+            <a:r>
+              <a:rPr lang="de-DE" sz="1200" i="1" dirty="0">
+                <a:latin typeface="Latin Modern Math" panose="02000503000000000000" pitchFamily="50" charset="0"/>
+                <a:ea typeface="Latin Modern Math" panose="02000503000000000000" pitchFamily="50" charset="0"/>
+                <a:cs typeface="CMU Serif" panose="02000603000000000000" pitchFamily="2" charset="0"/>
+              </a:rPr>
+              <a:t>η</a:t>
+            </a:r>
+            <a:endParaRPr lang="de-DE" sz="1200" baseline="-25000" dirty="0">
+              <a:latin typeface="Latin Modern Math" panose="02000503000000000000" pitchFamily="50" charset="0"/>
+              <a:ea typeface="Latin Modern Math" panose="02000503000000000000" pitchFamily="50" charset="0"/>
+              <a:cs typeface="CMU Serif" panose="02000603000000000000" pitchFamily="2" charset="0"/>
+            </a:endParaRPr>
+          </a:p>
+        </p:txBody>
+      </p:sp>
+      <p:sp>
+        <p:nvSpPr>
+          <p:cNvPr id="76" name="Textfeld 75">
+            <a:extLst>
+              <a:ext uri="{FF2B5EF4-FFF2-40B4-BE49-F238E27FC236}">
+                <a16:creationId xmlns:a16="http://schemas.microsoft.com/office/drawing/2014/main" id="{D9DC532A-24CF-23F1-78AD-07E10E1454E4}"/>
+              </a:ext>
+            </a:extLst>
+          </p:cNvPr>
+          <p:cNvSpPr txBox="1"/>
+          <p:nvPr/>
+        </p:nvSpPr>
+        <p:spPr>
+          <a:xfrm>
+            <a:off x="70982" y="1071750"/>
+            <a:ext cx="335541" cy="276999"/>
+          </a:xfrm>
+          <a:prstGeom prst="rect">
+            <a:avLst/>
+          </a:prstGeom>
+          <a:noFill/>
+        </p:spPr>
+        <p:txBody>
+          <a:bodyPr wrap="square" rtlCol="0" anchor="ctr">
+            <a:spAutoFit/>
+          </a:bodyPr>
+          <a:lstStyle/>
+          <a:p>
+            <a:pPr algn="ctr"/>
+            <a:r>
+              <a:rPr lang="de-DE" sz="1200" i="1" dirty="0">
+                <a:latin typeface="CMU Serif" panose="02000603000000000000" pitchFamily="2" charset="0"/>
+                <a:ea typeface="CMU Serif" panose="02000603000000000000" pitchFamily="2" charset="0"/>
+                <a:cs typeface="CMU Serif" panose="02000603000000000000" pitchFamily="2" charset="0"/>
+              </a:rPr>
+              <a:t>f</a:t>
+            </a:r>
+            <a:endParaRPr lang="de-DE" sz="1200" i="1" baseline="-25000" dirty="0">
+              <a:latin typeface="CMU Serif" panose="02000603000000000000" pitchFamily="2" charset="0"/>
+              <a:ea typeface="CMU Serif" panose="02000603000000000000" pitchFamily="2" charset="0"/>
+              <a:cs typeface="CMU Serif" panose="02000603000000000000" pitchFamily="2" charset="0"/>
+            </a:endParaRPr>
+          </a:p>
+        </p:txBody>
+      </p:sp>
+      <p:sp>
+        <p:nvSpPr>
+          <p:cNvPr id="80" name="Textfeld 79">
+            <a:extLst>
+              <a:ext uri="{FF2B5EF4-FFF2-40B4-BE49-F238E27FC236}">
+                <a16:creationId xmlns:a16="http://schemas.microsoft.com/office/drawing/2014/main" id="{6B5A1AC9-1F75-08E4-0363-661ACAB85EFE}"/>
+              </a:ext>
+            </a:extLst>
+          </p:cNvPr>
+          <p:cNvSpPr txBox="1"/>
+          <p:nvPr/>
+        </p:nvSpPr>
+        <p:spPr>
+          <a:xfrm>
+            <a:off x="190452" y="1063049"/>
+            <a:ext cx="222025" cy="276999"/>
+          </a:xfrm>
+          <a:prstGeom prst="rect">
+            <a:avLst/>
+          </a:prstGeom>
+          <a:noFill/>
+        </p:spPr>
+        <p:txBody>
+          <a:bodyPr wrap="square">
+            <a:spAutoFit/>
+          </a:bodyPr>
+          <a:lstStyle/>
+          <a:p>
+            <a:r>
+              <a:rPr lang="de-DE" sz="1200" i="1" dirty="0">
+                <a:latin typeface="CMU Serif" panose="02000603000000000000" pitchFamily="2" charset="0"/>
+                <a:ea typeface="CMU Serif" panose="02000603000000000000" pitchFamily="2" charset="0"/>
+                <a:cs typeface="CMU Serif" panose="02000603000000000000" pitchFamily="2" charset="0"/>
+              </a:rPr>
+              <a:t>′</a:t>
+            </a:r>
+          </a:p>
+        </p:txBody>
+      </p:sp>
+      <p:sp>
+        <p:nvSpPr>
+          <p:cNvPr id="81" name="Rechteck 80">
+            <a:extLst>
+              <a:ext uri="{FF2B5EF4-FFF2-40B4-BE49-F238E27FC236}">
+                <a16:creationId xmlns:a16="http://schemas.microsoft.com/office/drawing/2014/main" id="{A2E079F0-644F-6436-5A87-5303378615FB}"/>
+              </a:ext>
+            </a:extLst>
+          </p:cNvPr>
+          <p:cNvSpPr/>
+          <p:nvPr/>
+        </p:nvSpPr>
+        <p:spPr>
+          <a:xfrm>
+            <a:off x="2289810" y="1835517"/>
+            <a:ext cx="918469" cy="542561"/>
+          </a:xfrm>
+          <a:prstGeom prst="rect">
+            <a:avLst/>
+          </a:prstGeom>
+          <a:solidFill>
+            <a:schemeClr val="bg1"/>
+          </a:solidFill>
+          <a:ln w="6350" cap="rnd">
+            <a:solidFill>
+              <a:schemeClr val="tx1">
+                <a:lumMod val="95000"/>
+                <a:lumOff val="5000"/>
+              </a:schemeClr>
+            </a:solidFill>
+            <a:round/>
+          </a:ln>
+        </p:spPr>
+        <p:style>
+          <a:lnRef idx="2">
+            <a:schemeClr val="accent1">
+              <a:shade val="15000"/>
+            </a:schemeClr>
+          </a:lnRef>
+          <a:fillRef idx="1">
+            <a:schemeClr val="accent1"/>
+          </a:fillRef>
+          <a:effectRef idx="0">
+            <a:schemeClr val="accent1"/>
+          </a:effectRef>
+          <a:fontRef idx="minor">
+            <a:schemeClr val="lt1"/>
+          </a:fontRef>
+        </p:style>
+        <p:txBody>
+          <a:bodyPr rtlCol="0" anchor="ctr"/>
+          <a:lstStyle/>
+          <a:p>
+            <a:pPr algn="ctr"/>
+            <a:endParaRPr lang="de-DE"/>
+          </a:p>
+        </p:txBody>
+      </p:sp>
+      <p:grpSp>
+        <p:nvGrpSpPr>
+          <p:cNvPr id="92" name="Gruppieren 91">
+            <a:extLst>
+              <a:ext uri="{FF2B5EF4-FFF2-40B4-BE49-F238E27FC236}">
+                <a16:creationId xmlns:a16="http://schemas.microsoft.com/office/drawing/2014/main" id="{CDB3A42B-9DC8-703A-D8DA-F0844A9C1624}"/>
+              </a:ext>
+            </a:extLst>
+          </p:cNvPr>
+          <p:cNvGrpSpPr/>
+          <p:nvPr/>
+        </p:nvGrpSpPr>
+        <p:grpSpPr>
+          <a:xfrm>
+            <a:off x="2366455" y="1852315"/>
+            <a:ext cx="1106134" cy="184666"/>
+            <a:chOff x="2366455" y="1852315"/>
+            <a:chExt cx="1106134" cy="184666"/>
+          </a:xfrm>
+        </p:grpSpPr>
+        <p:cxnSp>
+          <p:nvCxnSpPr>
+            <p:cNvPr id="83" name="Gerader Verbinder 82">
+              <a:extLst>
+                <a:ext uri="{FF2B5EF4-FFF2-40B4-BE49-F238E27FC236}">
+                  <a16:creationId xmlns:a16="http://schemas.microsoft.com/office/drawing/2014/main" id="{A6531210-249B-FF5C-9751-905BE3B4D7A9}"/>
+                </a:ext>
+              </a:extLst>
+            </p:cNvPr>
+            <p:cNvCxnSpPr>
+              <a:cxnSpLocks/>
+            </p:cNvCxnSpPr>
+            <p:nvPr/>
+          </p:nvCxnSpPr>
+          <p:spPr>
+            <a:xfrm>
+              <a:off x="2366455" y="1944648"/>
+              <a:ext cx="240030" cy="0"/>
+            </a:xfrm>
+            <a:prstGeom prst="line">
+              <a:avLst/>
+            </a:prstGeom>
+            <a:ln w="12700" cap="rnd">
+              <a:solidFill>
+                <a:schemeClr val="accent6"/>
+              </a:solidFill>
+              <a:round/>
+            </a:ln>
+          </p:spPr>
+          <p:style>
+            <a:lnRef idx="2">
+              <a:schemeClr val="accent1"/>
+            </a:lnRef>
+            <a:fillRef idx="0">
+              <a:schemeClr val="accent1"/>
+            </a:fillRef>
+            <a:effectRef idx="1">
+              <a:schemeClr val="accent1"/>
+            </a:effectRef>
+            <a:fontRef idx="minor">
+              <a:schemeClr val="tx1"/>
+            </a:fontRef>
+          </p:style>
+        </p:cxnSp>
+        <p:sp>
+          <p:nvSpPr>
+            <p:cNvPr id="87" name="Textfeld 86">
+              <a:extLst>
+                <a:ext uri="{FF2B5EF4-FFF2-40B4-BE49-F238E27FC236}">
+                  <a16:creationId xmlns:a16="http://schemas.microsoft.com/office/drawing/2014/main" id="{8D122B7F-A9FC-7B9A-5055-D0F8208502B8}"/>
+                </a:ext>
+              </a:extLst>
+            </p:cNvPr>
+            <p:cNvSpPr txBox="1"/>
+            <p:nvPr/>
+          </p:nvSpPr>
+          <p:spPr>
+            <a:xfrm>
+              <a:off x="2585378" y="1852315"/>
+              <a:ext cx="887211" cy="184666"/>
+            </a:xfrm>
+            <a:prstGeom prst="rect">
+              <a:avLst/>
+            </a:prstGeom>
+            <a:noFill/>
+          </p:spPr>
+          <p:txBody>
+            <a:bodyPr wrap="square" rtlCol="0" anchor="ctr">
+              <a:spAutoFit/>
+            </a:bodyPr>
+            <a:lstStyle/>
+            <a:p>
+              <a:r>
+                <a:rPr lang="de-DE" sz="600" i="1" dirty="0">
+                  <a:latin typeface="CMU Serif" panose="02000603000000000000" pitchFamily="2" charset="0"/>
+                  <a:ea typeface="CMU Serif" panose="02000603000000000000" pitchFamily="2" charset="0"/>
+                  <a:cs typeface="CMU Serif" panose="02000603000000000000" pitchFamily="2" charset="0"/>
+                </a:rPr>
+                <a:t>m</a:t>
+              </a:r>
+              <a:r>
+                <a:rPr lang="de-DE" sz="600" dirty="0">
+                  <a:latin typeface="CMU Serif" panose="02000603000000000000" pitchFamily="2" charset="0"/>
+                  <a:ea typeface="CMU Serif" panose="02000603000000000000" pitchFamily="2" charset="0"/>
+                  <a:cs typeface="CMU Serif" panose="02000603000000000000" pitchFamily="2" charset="0"/>
+                </a:rPr>
+                <a:t> = 1</a:t>
+              </a:r>
+              <a:endParaRPr lang="de-DE" sz="600" baseline="-25000" dirty="0">
+                <a:latin typeface="CMU Serif" panose="02000603000000000000" pitchFamily="2" charset="0"/>
+                <a:ea typeface="CMU Serif" panose="02000603000000000000" pitchFamily="2" charset="0"/>
+                <a:cs typeface="CMU Serif" panose="02000603000000000000" pitchFamily="2" charset="0"/>
+              </a:endParaRPr>
+            </a:p>
+          </p:txBody>
+        </p:sp>
+      </p:grpSp>
+      <p:grpSp>
+        <p:nvGrpSpPr>
+          <p:cNvPr id="93" name="Gruppieren 92">
+            <a:extLst>
+              <a:ext uri="{FF2B5EF4-FFF2-40B4-BE49-F238E27FC236}">
+                <a16:creationId xmlns:a16="http://schemas.microsoft.com/office/drawing/2014/main" id="{9D51D016-CDF9-B0F9-A74D-1595976BC315}"/>
+              </a:ext>
+            </a:extLst>
+          </p:cNvPr>
+          <p:cNvGrpSpPr/>
+          <p:nvPr/>
+        </p:nvGrpSpPr>
+        <p:grpSpPr>
+          <a:xfrm>
+            <a:off x="2367318" y="2011166"/>
+            <a:ext cx="1104408" cy="184666"/>
+            <a:chOff x="2366455" y="2011166"/>
+            <a:chExt cx="1104408" cy="184666"/>
+          </a:xfrm>
+        </p:grpSpPr>
+        <p:cxnSp>
+          <p:nvCxnSpPr>
+            <p:cNvPr id="84" name="Gerader Verbinder 83">
+              <a:extLst>
+                <a:ext uri="{FF2B5EF4-FFF2-40B4-BE49-F238E27FC236}">
+                  <a16:creationId xmlns:a16="http://schemas.microsoft.com/office/drawing/2014/main" id="{27E28EB7-307C-89A8-4DE3-499F4A7FB76D}"/>
+                </a:ext>
+              </a:extLst>
+            </p:cNvPr>
+            <p:cNvCxnSpPr>
+              <a:cxnSpLocks/>
+            </p:cNvCxnSpPr>
+            <p:nvPr/>
+          </p:nvCxnSpPr>
+          <p:spPr>
+            <a:xfrm>
+              <a:off x="2366455" y="2103499"/>
+              <a:ext cx="240030" cy="0"/>
+            </a:xfrm>
+            <a:prstGeom prst="line">
+              <a:avLst/>
+            </a:prstGeom>
+            <a:ln w="12700" cap="rnd">
+              <a:solidFill>
+                <a:srgbClr val="0070C0"/>
+              </a:solidFill>
+              <a:round/>
+            </a:ln>
+          </p:spPr>
+          <p:style>
+            <a:lnRef idx="2">
+              <a:schemeClr val="accent1"/>
+            </a:lnRef>
+            <a:fillRef idx="0">
+              <a:schemeClr val="accent1"/>
+            </a:fillRef>
+            <a:effectRef idx="1">
+              <a:schemeClr val="accent1"/>
+            </a:effectRef>
+            <a:fontRef idx="minor">
+              <a:schemeClr val="tx1"/>
+            </a:fontRef>
+          </p:style>
+        </p:cxnSp>
+        <p:sp>
+          <p:nvSpPr>
+            <p:cNvPr id="89" name="Textfeld 88">
+              <a:extLst>
+                <a:ext uri="{FF2B5EF4-FFF2-40B4-BE49-F238E27FC236}">
+                  <a16:creationId xmlns:a16="http://schemas.microsoft.com/office/drawing/2014/main" id="{003B963E-4E57-3788-2E92-A245D56C4D42}"/>
+                </a:ext>
+              </a:extLst>
+            </p:cNvPr>
+            <p:cNvSpPr txBox="1"/>
+            <p:nvPr/>
+          </p:nvSpPr>
+          <p:spPr>
+            <a:xfrm>
+              <a:off x="2583652" y="2011166"/>
+              <a:ext cx="887211" cy="184666"/>
+            </a:xfrm>
+            <a:prstGeom prst="rect">
+              <a:avLst/>
+            </a:prstGeom>
+            <a:noFill/>
+          </p:spPr>
+          <p:txBody>
+            <a:bodyPr wrap="square" rtlCol="0" anchor="ctr">
+              <a:spAutoFit/>
+            </a:bodyPr>
+            <a:lstStyle/>
+            <a:p>
+              <a:r>
+                <a:rPr lang="de-DE" sz="600" i="1" dirty="0">
+                  <a:latin typeface="CMU Serif" panose="02000603000000000000" pitchFamily="2" charset="0"/>
+                  <a:ea typeface="CMU Serif" panose="02000603000000000000" pitchFamily="2" charset="0"/>
+                  <a:cs typeface="CMU Serif" panose="02000603000000000000" pitchFamily="2" charset="0"/>
+                </a:rPr>
+                <a:t>m</a:t>
+              </a:r>
+              <a:r>
+                <a:rPr lang="de-DE" sz="600" dirty="0">
+                  <a:latin typeface="CMU Serif" panose="02000603000000000000" pitchFamily="2" charset="0"/>
+                  <a:ea typeface="CMU Serif" panose="02000603000000000000" pitchFamily="2" charset="0"/>
+                  <a:cs typeface="CMU Serif" panose="02000603000000000000" pitchFamily="2" charset="0"/>
+                </a:rPr>
+                <a:t> = 0</a:t>
+              </a:r>
+              <a:endParaRPr lang="de-DE" sz="600" baseline="-25000" dirty="0">
+                <a:latin typeface="CMU Serif" panose="02000603000000000000" pitchFamily="2" charset="0"/>
+                <a:ea typeface="CMU Serif" panose="02000603000000000000" pitchFamily="2" charset="0"/>
+                <a:cs typeface="CMU Serif" panose="02000603000000000000" pitchFamily="2" charset="0"/>
+              </a:endParaRPr>
+            </a:p>
+          </p:txBody>
+        </p:sp>
+      </p:grpSp>
+      <p:grpSp>
+        <p:nvGrpSpPr>
+          <p:cNvPr id="94" name="Gruppieren 93">
+            <a:extLst>
+              <a:ext uri="{FF2B5EF4-FFF2-40B4-BE49-F238E27FC236}">
+                <a16:creationId xmlns:a16="http://schemas.microsoft.com/office/drawing/2014/main" id="{6F9FDA71-8C28-C1A5-38A0-FB7753E419B6}"/>
+              </a:ext>
+            </a:extLst>
+          </p:cNvPr>
+          <p:cNvGrpSpPr/>
+          <p:nvPr/>
+        </p:nvGrpSpPr>
+        <p:grpSpPr>
+          <a:xfrm>
+            <a:off x="2366887" y="2170017"/>
+            <a:ext cx="1105271" cy="184666"/>
+            <a:chOff x="2366455" y="2170017"/>
+            <a:chExt cx="1105271" cy="184666"/>
+          </a:xfrm>
+        </p:grpSpPr>
+        <p:cxnSp>
+          <p:nvCxnSpPr>
+            <p:cNvPr id="85" name="Gerader Verbinder 84">
+              <a:extLst>
+                <a:ext uri="{FF2B5EF4-FFF2-40B4-BE49-F238E27FC236}">
+                  <a16:creationId xmlns:a16="http://schemas.microsoft.com/office/drawing/2014/main" id="{3391416C-3883-E7CB-843F-A7CED1720726}"/>
+                </a:ext>
+              </a:extLst>
+            </p:cNvPr>
+            <p:cNvCxnSpPr>
+              <a:cxnSpLocks/>
+            </p:cNvCxnSpPr>
+            <p:nvPr/>
+          </p:nvCxnSpPr>
+          <p:spPr>
+            <a:xfrm>
+              <a:off x="2366455" y="2262350"/>
+              <a:ext cx="240030" cy="0"/>
+            </a:xfrm>
+            <a:prstGeom prst="line">
+              <a:avLst/>
+            </a:prstGeom>
+            <a:ln w="12700" cap="rnd">
+              <a:solidFill>
+                <a:schemeClr val="accent2"/>
+              </a:solidFill>
+              <a:round/>
+            </a:ln>
+          </p:spPr>
+          <p:style>
+            <a:lnRef idx="2">
+              <a:schemeClr val="accent1"/>
+            </a:lnRef>
+            <a:fillRef idx="0">
+              <a:schemeClr val="accent1"/>
+            </a:fillRef>
+            <a:effectRef idx="1">
+              <a:schemeClr val="accent1"/>
+            </a:effectRef>
+            <a:fontRef idx="minor">
+              <a:schemeClr val="tx1"/>
+            </a:fontRef>
+          </p:style>
+        </p:cxnSp>
+        <p:sp>
+          <p:nvSpPr>
+            <p:cNvPr id="91" name="Textfeld 90">
+              <a:extLst>
+                <a:ext uri="{FF2B5EF4-FFF2-40B4-BE49-F238E27FC236}">
+                  <a16:creationId xmlns:a16="http://schemas.microsoft.com/office/drawing/2014/main" id="{E604C0EB-197B-4915-0FF6-93AF12670B37}"/>
+                </a:ext>
+              </a:extLst>
+            </p:cNvPr>
+            <p:cNvSpPr txBox="1"/>
+            <p:nvPr/>
+          </p:nvSpPr>
+          <p:spPr>
+            <a:xfrm>
+              <a:off x="2584515" y="2170017"/>
+              <a:ext cx="887211" cy="184666"/>
+            </a:xfrm>
+            <a:prstGeom prst="rect">
+              <a:avLst/>
+            </a:prstGeom>
+            <a:noFill/>
+          </p:spPr>
+          <p:txBody>
+            <a:bodyPr wrap="square" rtlCol="0" anchor="ctr">
+              <a:spAutoFit/>
+            </a:bodyPr>
+            <a:lstStyle/>
+            <a:p>
+              <a:r>
+                <a:rPr lang="de-DE" sz="600" i="1" dirty="0">
+                  <a:latin typeface="CMU Serif" panose="02000603000000000000" pitchFamily="2" charset="0"/>
+                  <a:ea typeface="CMU Serif" panose="02000603000000000000" pitchFamily="2" charset="0"/>
+                  <a:cs typeface="CMU Serif" panose="02000603000000000000" pitchFamily="2" charset="0"/>
+                </a:rPr>
+                <a:t>m</a:t>
+              </a:r>
+              <a:r>
+                <a:rPr lang="de-DE" sz="600" dirty="0">
+                  <a:latin typeface="CMU Serif" panose="02000603000000000000" pitchFamily="2" charset="0"/>
+                  <a:ea typeface="CMU Serif" panose="02000603000000000000" pitchFamily="2" charset="0"/>
+                  <a:cs typeface="CMU Serif" panose="02000603000000000000" pitchFamily="2" charset="0"/>
+                </a:rPr>
+                <a:t> = −0,0904</a:t>
+              </a:r>
+              <a:endParaRPr lang="de-DE" sz="600" baseline="-25000" dirty="0">
+                <a:latin typeface="CMU Serif" panose="02000603000000000000" pitchFamily="2" charset="0"/>
+                <a:ea typeface="CMU Serif" panose="02000603000000000000" pitchFamily="2" charset="0"/>
+                <a:cs typeface="CMU Serif" panose="02000603000000000000" pitchFamily="2" charset="0"/>
+              </a:endParaRPr>
+            </a:p>
+          </p:txBody>
+        </p:sp>
+      </p:grpSp>
+    </p:spTree>
+    <p:extLst>
+      <p:ext uri="{BB962C8B-B14F-4D97-AF65-F5344CB8AC3E}">
+        <p14:creationId xmlns:p14="http://schemas.microsoft.com/office/powerpoint/2010/main" val="378390306"/>
+      </p:ext>
+    </p:extLst>
+  </p:cSld>
+  <p:clrMapOvr>
+    <a:masterClrMapping/>
+  </p:clrMapOvr>
+</p:sld>
+</file>
+
+<file path=ppt/slides/slide12.xml><?xml version="1.0" encoding="utf-8"?>
+<p:sld xmlns:a="http://schemas.openxmlformats.org/drawingml/2006/main" xmlns:r="http://schemas.openxmlformats.org/officeDocument/2006/relationships" xmlns:p="http://schemas.openxmlformats.org/presentationml/2006/main">
+  <p:cSld>
+    <p:spTree>
+      <p:nvGrpSpPr>
+        <p:cNvPr id="1" name="">
+          <a:extLst>
+            <a:ext uri="{FF2B5EF4-FFF2-40B4-BE49-F238E27FC236}">
+              <a16:creationId xmlns:a16="http://schemas.microsoft.com/office/drawing/2014/main" id="{76A94F82-9956-145F-D4CD-512DF78CADEC}"/>
+            </a:ext>
+          </a:extLst>
+        </p:cNvPr>
+        <p:cNvGrpSpPr/>
+        <p:nvPr/>
+      </p:nvGrpSpPr>
+      <p:grpSpPr>
+        <a:xfrm>
+          <a:off x="0" y="0"/>
+          <a:ext cx="0" cy="0"/>
+          <a:chOff x="0" y="0"/>
+          <a:chExt cx="0" cy="0"/>
+        </a:xfrm>
+      </p:grpSpPr>
+    </p:spTree>
+    <p:extLst>
+      <p:ext uri="{BB962C8B-B14F-4D97-AF65-F5344CB8AC3E}">
+        <p14:creationId xmlns:p14="http://schemas.microsoft.com/office/powerpoint/2010/main" val="1100447898"/>
       </p:ext>
     </p:extLst>
   </p:cSld>

</xml_diff>

<commit_message>
added and finished chapter Turbulenz to SL1
</commit_message>
<xml_diff>
--- a/LaTeX B.Sc. LRT/Strömungslehre 1/images/SL1-Images.pptx
+++ b/LaTeX B.Sc. LRT/Strömungslehre 1/images/SL1-Images.pptx
@@ -17,6 +17,7 @@
     <p:sldId id="265" r:id="rId11"/>
     <p:sldId id="266" r:id="rId12"/>
     <p:sldId id="267" r:id="rId13"/>
+    <p:sldId id="268" r:id="rId14"/>
   </p:sldIdLst>
   <p:sldSz cx="3600450" cy="3600450"/>
   <p:notesSz cx="6858000" cy="9144000"/>
@@ -254,7 +255,7 @@
           <a:p>
             <a:fld id="{0F04D7A0-D8C8-4B74-9611-9A000801FA36}" type="datetimeFigureOut">
               <a:rPr lang="de-DE" smtClean="0"/>
-              <a:t>22.09.2026</a:t>
+              <a:t>23.09.2026</a:t>
             </a:fld>
             <a:endParaRPr lang="de-DE"/>
           </a:p>
@@ -424,7 +425,7 @@
           <a:p>
             <a:fld id="{0F04D7A0-D8C8-4B74-9611-9A000801FA36}" type="datetimeFigureOut">
               <a:rPr lang="de-DE" smtClean="0"/>
-              <a:t>22.09.2026</a:t>
+              <a:t>23.09.2026</a:t>
             </a:fld>
             <a:endParaRPr lang="de-DE"/>
           </a:p>
@@ -604,7 +605,7 @@
           <a:p>
             <a:fld id="{0F04D7A0-D8C8-4B74-9611-9A000801FA36}" type="datetimeFigureOut">
               <a:rPr lang="de-DE" smtClean="0"/>
-              <a:t>22.09.2026</a:t>
+              <a:t>23.09.2026</a:t>
             </a:fld>
             <a:endParaRPr lang="de-DE"/>
           </a:p>
@@ -774,7 +775,7 @@
           <a:p>
             <a:fld id="{0F04D7A0-D8C8-4B74-9611-9A000801FA36}" type="datetimeFigureOut">
               <a:rPr lang="de-DE" smtClean="0"/>
-              <a:t>22.09.2026</a:t>
+              <a:t>23.09.2026</a:t>
             </a:fld>
             <a:endParaRPr lang="de-DE"/>
           </a:p>
@@ -1020,7 +1021,7 @@
           <a:p>
             <a:fld id="{0F04D7A0-D8C8-4B74-9611-9A000801FA36}" type="datetimeFigureOut">
               <a:rPr lang="de-DE" smtClean="0"/>
-              <a:t>22.09.2026</a:t>
+              <a:t>23.09.2026</a:t>
             </a:fld>
             <a:endParaRPr lang="de-DE"/>
           </a:p>
@@ -1252,7 +1253,7 @@
           <a:p>
             <a:fld id="{0F04D7A0-D8C8-4B74-9611-9A000801FA36}" type="datetimeFigureOut">
               <a:rPr lang="de-DE" smtClean="0"/>
-              <a:t>22.09.2026</a:t>
+              <a:t>23.09.2026</a:t>
             </a:fld>
             <a:endParaRPr lang="de-DE"/>
           </a:p>
@@ -1619,7 +1620,7 @@
           <a:p>
             <a:fld id="{0F04D7A0-D8C8-4B74-9611-9A000801FA36}" type="datetimeFigureOut">
               <a:rPr lang="de-DE" smtClean="0"/>
-              <a:t>22.09.2026</a:t>
+              <a:t>23.09.2026</a:t>
             </a:fld>
             <a:endParaRPr lang="de-DE"/>
           </a:p>
@@ -1737,7 +1738,7 @@
           <a:p>
             <a:fld id="{0F04D7A0-D8C8-4B74-9611-9A000801FA36}" type="datetimeFigureOut">
               <a:rPr lang="de-DE" smtClean="0"/>
-              <a:t>22.09.2026</a:t>
+              <a:t>23.09.2026</a:t>
             </a:fld>
             <a:endParaRPr lang="de-DE"/>
           </a:p>
@@ -1832,7 +1833,7 @@
           <a:p>
             <a:fld id="{0F04D7A0-D8C8-4B74-9611-9A000801FA36}" type="datetimeFigureOut">
               <a:rPr lang="de-DE" smtClean="0"/>
-              <a:t>22.09.2026</a:t>
+              <a:t>23.09.2026</a:t>
             </a:fld>
             <a:endParaRPr lang="de-DE"/>
           </a:p>
@@ -2109,7 +2110,7 @@
           <a:p>
             <a:fld id="{0F04D7A0-D8C8-4B74-9611-9A000801FA36}" type="datetimeFigureOut">
               <a:rPr lang="de-DE" smtClean="0"/>
-              <a:t>22.09.2026</a:t>
+              <a:t>23.09.2026</a:t>
             </a:fld>
             <a:endParaRPr lang="de-DE"/>
           </a:p>
@@ -2366,7 +2367,7 @@
           <a:p>
             <a:fld id="{0F04D7A0-D8C8-4B74-9611-9A000801FA36}" type="datetimeFigureOut">
               <a:rPr lang="de-DE" smtClean="0"/>
-              <a:t>22.09.2026</a:t>
+              <a:t>23.09.2026</a:t>
             </a:fld>
             <a:endParaRPr lang="de-DE"/>
           </a:p>
@@ -2579,7 +2580,7 @@
           <a:p>
             <a:fld id="{0F04D7A0-D8C8-4B74-9611-9A000801FA36}" type="datetimeFigureOut">
               <a:rPr lang="de-DE" smtClean="0"/>
-              <a:t>22.09.2026</a:t>
+              <a:t>23.09.2026</a:t>
             </a:fld>
             <a:endParaRPr lang="de-DE"/>
           </a:p>
@@ -7819,10 +7820,1112 @@
           <a:chExt cx="0" cy="0"/>
         </a:xfrm>
       </p:grpSpPr>
+      <p:cxnSp>
+        <p:nvCxnSpPr>
+          <p:cNvPr id="60" name="Gerader Verbinder 59">
+            <a:extLst>
+              <a:ext uri="{FF2B5EF4-FFF2-40B4-BE49-F238E27FC236}">
+                <a16:creationId xmlns:a16="http://schemas.microsoft.com/office/drawing/2014/main" id="{332C9B4B-57BF-2421-94CE-71EE88D7DB5E}"/>
+              </a:ext>
+            </a:extLst>
+          </p:cNvPr>
+          <p:cNvCxnSpPr>
+            <a:cxnSpLocks/>
+          </p:cNvCxnSpPr>
+          <p:nvPr/>
+        </p:nvCxnSpPr>
+        <p:spPr>
+          <a:xfrm flipH="1">
+            <a:off x="654317" y="1289547"/>
+            <a:ext cx="236955" cy="806132"/>
+          </a:xfrm>
+          <a:prstGeom prst="line">
+            <a:avLst/>
+          </a:prstGeom>
+          <a:ln w="6350">
+            <a:solidFill>
+              <a:schemeClr val="tx1"/>
+            </a:solidFill>
+            <a:prstDash val="sysDash"/>
+          </a:ln>
+        </p:spPr>
+        <p:style>
+          <a:lnRef idx="2">
+            <a:schemeClr val="accent1"/>
+          </a:lnRef>
+          <a:fillRef idx="0">
+            <a:schemeClr val="accent1"/>
+          </a:fillRef>
+          <a:effectRef idx="1">
+            <a:schemeClr val="accent1"/>
+          </a:effectRef>
+          <a:fontRef idx="minor">
+            <a:schemeClr val="tx1"/>
+          </a:fontRef>
+        </p:style>
+      </p:cxnSp>
+      <p:sp>
+        <p:nvSpPr>
+          <p:cNvPr id="22" name="Freihandform: Form 21">
+            <a:extLst>
+              <a:ext uri="{FF2B5EF4-FFF2-40B4-BE49-F238E27FC236}">
+                <a16:creationId xmlns:a16="http://schemas.microsoft.com/office/drawing/2014/main" id="{A82C945E-4880-AEAC-B5C8-6028B884E736}"/>
+              </a:ext>
+            </a:extLst>
+          </p:cNvPr>
+          <p:cNvSpPr/>
+          <p:nvPr/>
+        </p:nvSpPr>
+        <p:spPr>
+          <a:xfrm>
+            <a:off x="546021" y="1002903"/>
+            <a:ext cx="2366645" cy="1470263"/>
+          </a:xfrm>
+          <a:custGeom>
+            <a:avLst/>
+            <a:gdLst>
+              <a:gd name="csX0" fmla="*/ 0 w 2366645"/>
+              <a:gd name="csY0" fmla="*/ 1576208 h 1576208"/>
+              <a:gd name="csX1" fmla="*/ 182165 w 2366645"/>
+              <a:gd name="csY1" fmla="*/ 908268 h 1576208"/>
+              <a:gd name="csX2" fmla="*/ 271462 w 2366645"/>
+              <a:gd name="csY2" fmla="*/ 651093 h 1576208"/>
+              <a:gd name="csX3" fmla="*/ 417909 w 2366645"/>
+              <a:gd name="csY3" fmla="*/ 393918 h 1576208"/>
+              <a:gd name="csX4" fmla="*/ 710803 w 2366645"/>
+              <a:gd name="csY4" fmla="*/ 165318 h 1576208"/>
+              <a:gd name="csX5" fmla="*/ 1235868 w 2366645"/>
+              <a:gd name="csY5" fmla="*/ 36730 h 1576208"/>
+              <a:gd name="csX6" fmla="*/ 2366645 w 2366645"/>
+              <a:gd name="csY6" fmla="*/ 0 h 1576208"/>
+            </a:gdLst>
+            <a:ahLst/>
+            <a:cxnLst>
+              <a:cxn ang="0">
+                <a:pos x="csX0" y="csY0"/>
+              </a:cxn>
+              <a:cxn ang="0">
+                <a:pos x="csX1" y="csY1"/>
+              </a:cxn>
+              <a:cxn ang="0">
+                <a:pos x="csX2" y="csY2"/>
+              </a:cxn>
+              <a:cxn ang="0">
+                <a:pos x="csX3" y="csY3"/>
+              </a:cxn>
+              <a:cxn ang="0">
+                <a:pos x="csX4" y="csY4"/>
+              </a:cxn>
+              <a:cxn ang="0">
+                <a:pos x="csX5" y="csY5"/>
+              </a:cxn>
+              <a:cxn ang="0">
+                <a:pos x="csX6" y="csY6"/>
+              </a:cxn>
+            </a:cxnLst>
+            <a:rect l="l" t="t" r="r" b="b"/>
+            <a:pathLst>
+              <a:path w="2366645" h="1576208">
+                <a:moveTo>
+                  <a:pt x="0" y="1576208"/>
+                </a:moveTo>
+                <a:cubicBezTo>
+                  <a:pt x="68460" y="1319331"/>
+                  <a:pt x="135016" y="1071979"/>
+                  <a:pt x="182165" y="908268"/>
+                </a:cubicBezTo>
+                <a:cubicBezTo>
+                  <a:pt x="229314" y="744557"/>
+                  <a:pt x="249316" y="702528"/>
+                  <a:pt x="271462" y="651093"/>
+                </a:cubicBezTo>
+                <a:cubicBezTo>
+                  <a:pt x="293608" y="599658"/>
+                  <a:pt x="361831" y="461545"/>
+                  <a:pt x="417909" y="393918"/>
+                </a:cubicBezTo>
+                <a:cubicBezTo>
+                  <a:pt x="473987" y="326291"/>
+                  <a:pt x="543997" y="249614"/>
+                  <a:pt x="710803" y="165318"/>
+                </a:cubicBezTo>
+                <a:cubicBezTo>
+                  <a:pt x="877609" y="81022"/>
+                  <a:pt x="959048" y="62924"/>
+                  <a:pt x="1235868" y="36730"/>
+                </a:cubicBezTo>
+                <a:cubicBezTo>
+                  <a:pt x="1512688" y="10536"/>
+                  <a:pt x="1919346" y="6627"/>
+                  <a:pt x="2366645" y="0"/>
+                </a:cubicBezTo>
+              </a:path>
+            </a:pathLst>
+          </a:custGeom>
+          <a:noFill/>
+          <a:ln cap="rnd">
+            <a:solidFill>
+              <a:schemeClr val="accent2"/>
+            </a:solidFill>
+            <a:round/>
+          </a:ln>
+        </p:spPr>
+        <p:style>
+          <a:lnRef idx="2">
+            <a:schemeClr val="accent1">
+              <a:shade val="15000"/>
+            </a:schemeClr>
+          </a:lnRef>
+          <a:fillRef idx="1">
+            <a:schemeClr val="accent1"/>
+          </a:fillRef>
+          <a:effectRef idx="0">
+            <a:schemeClr val="accent1"/>
+          </a:effectRef>
+          <a:fontRef idx="minor">
+            <a:schemeClr val="lt1"/>
+          </a:fontRef>
+        </p:style>
+        <p:txBody>
+          <a:bodyPr rtlCol="0" anchor="ctr"/>
+          <a:lstStyle/>
+          <a:p>
+            <a:pPr algn="ctr"/>
+            <a:endParaRPr lang="de-DE"/>
+          </a:p>
+        </p:txBody>
+      </p:sp>
+      <p:cxnSp>
+        <p:nvCxnSpPr>
+          <p:cNvPr id="3" name="Gerade Verbindung mit Pfeil 2">
+            <a:extLst>
+              <a:ext uri="{FF2B5EF4-FFF2-40B4-BE49-F238E27FC236}">
+                <a16:creationId xmlns:a16="http://schemas.microsoft.com/office/drawing/2014/main" id="{E88D3AFF-D5E5-A6E5-660F-33E5907587C3}"/>
+              </a:ext>
+            </a:extLst>
+          </p:cNvPr>
+          <p:cNvCxnSpPr>
+            <a:cxnSpLocks/>
+          </p:cNvCxnSpPr>
+          <p:nvPr/>
+        </p:nvCxnSpPr>
+        <p:spPr>
+          <a:xfrm flipV="1">
+            <a:off x="546497" y="828437"/>
+            <a:ext cx="0" cy="1643062"/>
+          </a:xfrm>
+          <a:prstGeom prst="straightConnector1">
+            <a:avLst/>
+          </a:prstGeom>
+          <a:ln cap="rnd">
+            <a:solidFill>
+              <a:schemeClr val="tx1"/>
+            </a:solidFill>
+            <a:round/>
+            <a:tailEnd type="triangle"/>
+          </a:ln>
+        </p:spPr>
+        <p:style>
+          <a:lnRef idx="2">
+            <a:schemeClr val="accent1"/>
+          </a:lnRef>
+          <a:fillRef idx="0">
+            <a:schemeClr val="accent1"/>
+          </a:fillRef>
+          <a:effectRef idx="1">
+            <a:schemeClr val="accent1"/>
+          </a:effectRef>
+          <a:fontRef idx="minor">
+            <a:schemeClr val="tx1"/>
+          </a:fontRef>
+        </p:style>
+      </p:cxnSp>
+      <p:cxnSp>
+        <p:nvCxnSpPr>
+          <p:cNvPr id="4" name="Gerade Verbindung mit Pfeil 3">
+            <a:extLst>
+              <a:ext uri="{FF2B5EF4-FFF2-40B4-BE49-F238E27FC236}">
+                <a16:creationId xmlns:a16="http://schemas.microsoft.com/office/drawing/2014/main" id="{DBBB79F7-D579-F451-F105-5A244D60BD80}"/>
+              </a:ext>
+            </a:extLst>
+          </p:cNvPr>
+          <p:cNvCxnSpPr>
+            <a:cxnSpLocks/>
+          </p:cNvCxnSpPr>
+          <p:nvPr/>
+        </p:nvCxnSpPr>
+        <p:spPr>
+          <a:xfrm>
+            <a:off x="546497" y="2473404"/>
+            <a:ext cx="2503884" cy="0"/>
+          </a:xfrm>
+          <a:prstGeom prst="straightConnector1">
+            <a:avLst/>
+          </a:prstGeom>
+          <a:ln cap="rnd">
+            <a:solidFill>
+              <a:schemeClr val="tx1"/>
+            </a:solidFill>
+            <a:round/>
+            <a:tailEnd type="triangle"/>
+          </a:ln>
+        </p:spPr>
+        <p:style>
+          <a:lnRef idx="2">
+            <a:schemeClr val="accent1"/>
+          </a:lnRef>
+          <a:fillRef idx="0">
+            <a:schemeClr val="accent1"/>
+          </a:fillRef>
+          <a:effectRef idx="1">
+            <a:schemeClr val="accent1"/>
+          </a:effectRef>
+          <a:fontRef idx="minor">
+            <a:schemeClr val="tx1"/>
+          </a:fontRef>
+        </p:style>
+      </p:cxnSp>
+      <p:grpSp>
+        <p:nvGrpSpPr>
+          <p:cNvPr id="17" name="Gruppieren 16">
+            <a:extLst>
+              <a:ext uri="{FF2B5EF4-FFF2-40B4-BE49-F238E27FC236}">
+                <a16:creationId xmlns:a16="http://schemas.microsoft.com/office/drawing/2014/main" id="{CA373CE5-DDC4-718C-B4A7-228C9EA6ACFF}"/>
+              </a:ext>
+            </a:extLst>
+          </p:cNvPr>
+          <p:cNvGrpSpPr/>
+          <p:nvPr/>
+        </p:nvGrpSpPr>
+        <p:grpSpPr>
+          <a:xfrm>
+            <a:off x="177541" y="794308"/>
+            <a:ext cx="368956" cy="378695"/>
+            <a:chOff x="148966" y="769305"/>
+            <a:chExt cx="368956" cy="378695"/>
+          </a:xfrm>
+        </p:grpSpPr>
+        <p:sp>
+          <p:nvSpPr>
+            <p:cNvPr id="10" name="Textfeld 9">
+              <a:extLst>
+                <a:ext uri="{FF2B5EF4-FFF2-40B4-BE49-F238E27FC236}">
+                  <a16:creationId xmlns:a16="http://schemas.microsoft.com/office/drawing/2014/main" id="{D2848951-20C3-D7B1-7440-C8DDE6743179}"/>
+                </a:ext>
+              </a:extLst>
+            </p:cNvPr>
+            <p:cNvSpPr txBox="1"/>
+            <p:nvPr/>
+          </p:nvSpPr>
+          <p:spPr>
+            <a:xfrm>
+              <a:off x="148967" y="769305"/>
+              <a:ext cx="368955" cy="246221"/>
+            </a:xfrm>
+            <a:prstGeom prst="rect">
+              <a:avLst/>
+            </a:prstGeom>
+            <a:noFill/>
+          </p:spPr>
+          <p:txBody>
+            <a:bodyPr wrap="square" rtlCol="0" anchor="ctr">
+              <a:spAutoFit/>
+            </a:bodyPr>
+            <a:lstStyle/>
+            <a:p>
+              <a:pPr algn="ctr"/>
+              <a:r>
+                <a:rPr lang="de-DE" sz="1000" i="1" dirty="0">
+                  <a:latin typeface="CMU Serif" panose="02000603000000000000" pitchFamily="2" charset="0"/>
+                  <a:ea typeface="CMU Serif" panose="02000603000000000000" pitchFamily="2" charset="0"/>
+                  <a:cs typeface="CMU Serif" panose="02000603000000000000" pitchFamily="2" charset="0"/>
+                </a:rPr>
+                <a:t>u</a:t>
+              </a:r>
+              <a:endParaRPr lang="de-DE" sz="1000" baseline="-25000" dirty="0">
+                <a:latin typeface="CMU Serif" panose="02000603000000000000" pitchFamily="2" charset="0"/>
+                <a:ea typeface="CMU Serif" panose="02000603000000000000" pitchFamily="2" charset="0"/>
+                <a:cs typeface="CMU Serif" panose="02000603000000000000" pitchFamily="2" charset="0"/>
+              </a:endParaRPr>
+            </a:p>
+          </p:txBody>
+        </p:sp>
+        <p:sp>
+          <p:nvSpPr>
+            <p:cNvPr id="12" name="Textfeld 11">
+              <a:extLst>
+                <a:ext uri="{FF2B5EF4-FFF2-40B4-BE49-F238E27FC236}">
+                  <a16:creationId xmlns:a16="http://schemas.microsoft.com/office/drawing/2014/main" id="{F9915151-38A8-AA01-AE60-502F6E49F857}"/>
+                </a:ext>
+              </a:extLst>
+            </p:cNvPr>
+            <p:cNvSpPr txBox="1"/>
+            <p:nvPr/>
+          </p:nvSpPr>
+          <p:spPr>
+            <a:xfrm>
+              <a:off x="148966" y="901779"/>
+              <a:ext cx="368955" cy="246221"/>
+            </a:xfrm>
+            <a:prstGeom prst="rect">
+              <a:avLst/>
+            </a:prstGeom>
+            <a:noFill/>
+          </p:spPr>
+          <p:txBody>
+            <a:bodyPr wrap="square" rtlCol="0" anchor="ctr">
+              <a:spAutoFit/>
+            </a:bodyPr>
+            <a:lstStyle/>
+            <a:p>
+              <a:pPr algn="ctr"/>
+              <a:r>
+                <a:rPr lang="de-DE" sz="1000" i="1" dirty="0" err="1">
+                  <a:latin typeface="CMU Serif" panose="02000603000000000000" pitchFamily="2" charset="0"/>
+                  <a:ea typeface="CMU Serif" panose="02000603000000000000" pitchFamily="2" charset="0"/>
+                  <a:cs typeface="CMU Serif" panose="02000603000000000000" pitchFamily="2" charset="0"/>
+                </a:rPr>
+                <a:t>u</a:t>
+              </a:r>
+              <a:r>
+                <a:rPr lang="de-DE" sz="1000" i="1" baseline="-25000" dirty="0" err="1">
+                  <a:latin typeface="Latin Modern Math" panose="02000503000000000000" pitchFamily="50" charset="0"/>
+                  <a:ea typeface="Latin Modern Math" panose="02000503000000000000" pitchFamily="50" charset="0"/>
+                  <a:cs typeface="CMU Serif" panose="02000603000000000000" pitchFamily="2" charset="0"/>
+                </a:rPr>
+                <a:t>δ</a:t>
+              </a:r>
+              <a:endParaRPr lang="de-DE" sz="1000" i="1" baseline="-25000" dirty="0">
+                <a:latin typeface="Latin Modern Math" panose="02000503000000000000" pitchFamily="50" charset="0"/>
+                <a:ea typeface="Latin Modern Math" panose="02000503000000000000" pitchFamily="50" charset="0"/>
+                <a:cs typeface="CMU Serif" panose="02000603000000000000" pitchFamily="2" charset="0"/>
+              </a:endParaRPr>
+            </a:p>
+          </p:txBody>
+        </p:sp>
+        <p:cxnSp>
+          <p:nvCxnSpPr>
+            <p:cNvPr id="14" name="Gerader Verbinder 13">
+              <a:extLst>
+                <a:ext uri="{FF2B5EF4-FFF2-40B4-BE49-F238E27FC236}">
+                  <a16:creationId xmlns:a16="http://schemas.microsoft.com/office/drawing/2014/main" id="{38813EB2-13A2-E47D-8CCE-C233E301B653}"/>
+                </a:ext>
+              </a:extLst>
+            </p:cNvPr>
+            <p:cNvCxnSpPr>
+              <a:cxnSpLocks/>
+            </p:cNvCxnSpPr>
+            <p:nvPr/>
+          </p:nvCxnSpPr>
+          <p:spPr>
+            <a:xfrm>
+              <a:off x="282008" y="952500"/>
+              <a:ext cx="114232" cy="0"/>
+            </a:xfrm>
+            <a:prstGeom prst="line">
+              <a:avLst/>
+            </a:prstGeom>
+            <a:ln w="6350" cap="rnd">
+              <a:solidFill>
+                <a:schemeClr val="tx1"/>
+              </a:solidFill>
+              <a:round/>
+            </a:ln>
+          </p:spPr>
+          <p:style>
+            <a:lnRef idx="2">
+              <a:schemeClr val="accent1"/>
+            </a:lnRef>
+            <a:fillRef idx="0">
+              <a:schemeClr val="accent1"/>
+            </a:fillRef>
+            <a:effectRef idx="1">
+              <a:schemeClr val="accent1"/>
+            </a:effectRef>
+            <a:fontRef idx="minor">
+              <a:schemeClr val="tx1"/>
+            </a:fontRef>
+          </p:style>
+        </p:cxnSp>
+      </p:grpSp>
+      <p:grpSp>
+        <p:nvGrpSpPr>
+          <p:cNvPr id="18" name="Gruppieren 17">
+            <a:extLst>
+              <a:ext uri="{FF2B5EF4-FFF2-40B4-BE49-F238E27FC236}">
+                <a16:creationId xmlns:a16="http://schemas.microsoft.com/office/drawing/2014/main" id="{CF57A2D2-3018-8F12-079B-F273CF736615}"/>
+              </a:ext>
+            </a:extLst>
+          </p:cNvPr>
+          <p:cNvGrpSpPr/>
+          <p:nvPr/>
+        </p:nvGrpSpPr>
+        <p:grpSpPr>
+          <a:xfrm>
+            <a:off x="2991940" y="2278341"/>
+            <a:ext cx="370861" cy="433940"/>
+            <a:chOff x="147061" y="769305"/>
+            <a:chExt cx="370861" cy="433940"/>
+          </a:xfrm>
+        </p:grpSpPr>
+        <p:sp>
+          <p:nvSpPr>
+            <p:cNvPr id="19" name="Textfeld 18">
+              <a:extLst>
+                <a:ext uri="{FF2B5EF4-FFF2-40B4-BE49-F238E27FC236}">
+                  <a16:creationId xmlns:a16="http://schemas.microsoft.com/office/drawing/2014/main" id="{00CC66DD-620B-6090-7B0E-B3F4F9CE052A}"/>
+                </a:ext>
+              </a:extLst>
+            </p:cNvPr>
+            <p:cNvSpPr txBox="1"/>
+            <p:nvPr/>
+          </p:nvSpPr>
+          <p:spPr>
+            <a:xfrm>
+              <a:off x="148967" y="769305"/>
+              <a:ext cx="368955" cy="246221"/>
+            </a:xfrm>
+            <a:prstGeom prst="rect">
+              <a:avLst/>
+            </a:prstGeom>
+            <a:noFill/>
+          </p:spPr>
+          <p:txBody>
+            <a:bodyPr wrap="square" rtlCol="0" anchor="ctr">
+              <a:spAutoFit/>
+            </a:bodyPr>
+            <a:lstStyle/>
+            <a:p>
+              <a:pPr algn="ctr"/>
+              <a:r>
+                <a:rPr lang="de-DE" sz="1000" i="1" dirty="0">
+                  <a:latin typeface="CMU Serif" panose="02000603000000000000" pitchFamily="2" charset="0"/>
+                  <a:ea typeface="CMU Serif" panose="02000603000000000000" pitchFamily="2" charset="0"/>
+                  <a:cs typeface="CMU Serif" panose="02000603000000000000" pitchFamily="2" charset="0"/>
+                </a:rPr>
+                <a:t>y</a:t>
+              </a:r>
+              <a:endParaRPr lang="de-DE" sz="1000" baseline="-25000" dirty="0">
+                <a:latin typeface="CMU Serif" panose="02000603000000000000" pitchFamily="2" charset="0"/>
+                <a:ea typeface="CMU Serif" panose="02000603000000000000" pitchFamily="2" charset="0"/>
+                <a:cs typeface="CMU Serif" panose="02000603000000000000" pitchFamily="2" charset="0"/>
+              </a:endParaRPr>
+            </a:p>
+          </p:txBody>
+        </p:sp>
+        <p:sp>
+          <p:nvSpPr>
+            <p:cNvPr id="20" name="Textfeld 19">
+              <a:extLst>
+                <a:ext uri="{FF2B5EF4-FFF2-40B4-BE49-F238E27FC236}">
+                  <a16:creationId xmlns:a16="http://schemas.microsoft.com/office/drawing/2014/main" id="{21ED73A7-3424-6607-B0C1-8E683002177F}"/>
+                </a:ext>
+              </a:extLst>
+            </p:cNvPr>
+            <p:cNvSpPr txBox="1"/>
+            <p:nvPr/>
+          </p:nvSpPr>
+          <p:spPr>
+            <a:xfrm>
+              <a:off x="147061" y="957024"/>
+              <a:ext cx="368955" cy="246221"/>
+            </a:xfrm>
+            <a:prstGeom prst="rect">
+              <a:avLst/>
+            </a:prstGeom>
+            <a:noFill/>
+          </p:spPr>
+          <p:txBody>
+            <a:bodyPr wrap="square" rtlCol="0" anchor="ctr">
+              <a:spAutoFit/>
+            </a:bodyPr>
+            <a:lstStyle/>
+            <a:p>
+              <a:pPr algn="ctr"/>
+              <a:r>
+                <a:rPr lang="de-DE" sz="1000" i="1" dirty="0">
+                  <a:latin typeface="Latin Modern Math" panose="02000503000000000000" pitchFamily="50" charset="0"/>
+                  <a:ea typeface="Latin Modern Math" panose="02000503000000000000" pitchFamily="50" charset="0"/>
+                  <a:cs typeface="CMU Serif" panose="02000603000000000000" pitchFamily="2" charset="0"/>
+                </a:rPr>
+                <a:t>δ</a:t>
+              </a:r>
+            </a:p>
+          </p:txBody>
+        </p:sp>
+        <p:cxnSp>
+          <p:nvCxnSpPr>
+            <p:cNvPr id="21" name="Gerader Verbinder 20">
+              <a:extLst>
+                <a:ext uri="{FF2B5EF4-FFF2-40B4-BE49-F238E27FC236}">
+                  <a16:creationId xmlns:a16="http://schemas.microsoft.com/office/drawing/2014/main" id="{E9E2A966-C5F7-287D-1133-C71C32D00E12}"/>
+                </a:ext>
+              </a:extLst>
+            </p:cNvPr>
+            <p:cNvCxnSpPr>
+              <a:cxnSpLocks/>
+            </p:cNvCxnSpPr>
+            <p:nvPr/>
+          </p:nvCxnSpPr>
+          <p:spPr>
+            <a:xfrm>
+              <a:off x="282008" y="963930"/>
+              <a:ext cx="114232" cy="0"/>
+            </a:xfrm>
+            <a:prstGeom prst="line">
+              <a:avLst/>
+            </a:prstGeom>
+            <a:ln w="6350" cap="rnd">
+              <a:solidFill>
+                <a:schemeClr val="tx1"/>
+              </a:solidFill>
+              <a:round/>
+            </a:ln>
+          </p:spPr>
+          <p:style>
+            <a:lnRef idx="2">
+              <a:schemeClr val="accent1"/>
+            </a:lnRef>
+            <a:fillRef idx="0">
+              <a:schemeClr val="accent1"/>
+            </a:fillRef>
+            <a:effectRef idx="1">
+              <a:schemeClr val="accent1"/>
+            </a:effectRef>
+            <a:fontRef idx="minor">
+              <a:schemeClr val="tx1"/>
+            </a:fontRef>
+          </p:style>
+        </p:cxnSp>
+      </p:grpSp>
+      <p:cxnSp>
+        <p:nvCxnSpPr>
+          <p:cNvPr id="24" name="Gerader Verbinder 23">
+            <a:extLst>
+              <a:ext uri="{FF2B5EF4-FFF2-40B4-BE49-F238E27FC236}">
+                <a16:creationId xmlns:a16="http://schemas.microsoft.com/office/drawing/2014/main" id="{143F1EA5-84F2-97AC-802B-CD843D46A4F8}"/>
+              </a:ext>
+            </a:extLst>
+          </p:cNvPr>
+          <p:cNvCxnSpPr>
+            <a:cxnSpLocks/>
+          </p:cNvCxnSpPr>
+          <p:nvPr/>
+        </p:nvCxnSpPr>
+        <p:spPr>
+          <a:xfrm>
+            <a:off x="549275" y="996917"/>
+            <a:ext cx="2451100" cy="0"/>
+          </a:xfrm>
+          <a:prstGeom prst="line">
+            <a:avLst/>
+          </a:prstGeom>
+          <a:ln w="6350">
+            <a:solidFill>
+              <a:schemeClr val="tx1"/>
+            </a:solidFill>
+          </a:ln>
+        </p:spPr>
+        <p:style>
+          <a:lnRef idx="2">
+            <a:schemeClr val="accent1"/>
+          </a:lnRef>
+          <a:fillRef idx="0">
+            <a:schemeClr val="accent1"/>
+          </a:fillRef>
+          <a:effectRef idx="1">
+            <a:schemeClr val="accent1"/>
+          </a:effectRef>
+          <a:fontRef idx="minor">
+            <a:schemeClr val="tx1"/>
+          </a:fontRef>
+        </p:style>
+      </p:cxnSp>
+      <p:cxnSp>
+        <p:nvCxnSpPr>
+          <p:cNvPr id="33" name="Gerader Verbinder 32">
+            <a:extLst>
+              <a:ext uri="{FF2B5EF4-FFF2-40B4-BE49-F238E27FC236}">
+                <a16:creationId xmlns:a16="http://schemas.microsoft.com/office/drawing/2014/main" id="{59958D50-E3C4-8115-5869-49DA30EA816C}"/>
+              </a:ext>
+            </a:extLst>
+          </p:cNvPr>
+          <p:cNvCxnSpPr>
+            <a:cxnSpLocks/>
+          </p:cNvCxnSpPr>
+          <p:nvPr/>
+        </p:nvCxnSpPr>
+        <p:spPr>
+          <a:xfrm>
+            <a:off x="772795" y="1338183"/>
+            <a:ext cx="0" cy="1338580"/>
+          </a:xfrm>
+          <a:prstGeom prst="line">
+            <a:avLst/>
+          </a:prstGeom>
+          <a:ln w="6350">
+            <a:solidFill>
+              <a:schemeClr val="tx1"/>
+            </a:solidFill>
+          </a:ln>
+        </p:spPr>
+        <p:style>
+          <a:lnRef idx="2">
+            <a:schemeClr val="accent1"/>
+          </a:lnRef>
+          <a:fillRef idx="0">
+            <a:schemeClr val="accent1"/>
+          </a:fillRef>
+          <a:effectRef idx="1">
+            <a:schemeClr val="accent1"/>
+          </a:effectRef>
+          <a:fontRef idx="minor">
+            <a:schemeClr val="tx1"/>
+          </a:fontRef>
+        </p:style>
+      </p:cxnSp>
+      <p:cxnSp>
+        <p:nvCxnSpPr>
+          <p:cNvPr id="38" name="Gerader Verbinder 37">
+            <a:extLst>
+              <a:ext uri="{FF2B5EF4-FFF2-40B4-BE49-F238E27FC236}">
+                <a16:creationId xmlns:a16="http://schemas.microsoft.com/office/drawing/2014/main" id="{4ED8F093-E376-DC65-4600-28E133F73F2A}"/>
+              </a:ext>
+            </a:extLst>
+          </p:cNvPr>
+          <p:cNvCxnSpPr>
+            <a:cxnSpLocks/>
+          </p:cNvCxnSpPr>
+          <p:nvPr/>
+        </p:nvCxnSpPr>
+        <p:spPr>
+          <a:xfrm>
+            <a:off x="1367155" y="1018325"/>
+            <a:ext cx="0" cy="1658438"/>
+          </a:xfrm>
+          <a:prstGeom prst="line">
+            <a:avLst/>
+          </a:prstGeom>
+          <a:ln w="6350">
+            <a:solidFill>
+              <a:schemeClr val="tx1"/>
+            </a:solidFill>
+          </a:ln>
+        </p:spPr>
+        <p:style>
+          <a:lnRef idx="2">
+            <a:schemeClr val="accent1"/>
+          </a:lnRef>
+          <a:fillRef idx="0">
+            <a:schemeClr val="accent1"/>
+          </a:fillRef>
+          <a:effectRef idx="1">
+            <a:schemeClr val="accent1"/>
+          </a:effectRef>
+          <a:fontRef idx="minor">
+            <a:schemeClr val="tx1"/>
+          </a:fontRef>
+        </p:style>
+      </p:cxnSp>
+      <p:cxnSp>
+        <p:nvCxnSpPr>
+          <p:cNvPr id="40" name="Gerader Verbinder 39">
+            <a:extLst>
+              <a:ext uri="{FF2B5EF4-FFF2-40B4-BE49-F238E27FC236}">
+                <a16:creationId xmlns:a16="http://schemas.microsoft.com/office/drawing/2014/main" id="{C60320FC-6292-AEE1-12B9-9248F6B49E4B}"/>
+              </a:ext>
+            </a:extLst>
+          </p:cNvPr>
+          <p:cNvCxnSpPr>
+            <a:cxnSpLocks/>
+          </p:cNvCxnSpPr>
+          <p:nvPr/>
+        </p:nvCxnSpPr>
+        <p:spPr>
+          <a:xfrm>
+            <a:off x="2347595" y="908815"/>
+            <a:ext cx="0" cy="1767948"/>
+          </a:xfrm>
+          <a:prstGeom prst="line">
+            <a:avLst/>
+          </a:prstGeom>
+          <a:ln w="6350">
+            <a:solidFill>
+              <a:schemeClr val="tx1"/>
+            </a:solidFill>
+          </a:ln>
+        </p:spPr>
+        <p:style>
+          <a:lnRef idx="2">
+            <a:schemeClr val="accent1"/>
+          </a:lnRef>
+          <a:fillRef idx="0">
+            <a:schemeClr val="accent1"/>
+          </a:fillRef>
+          <a:effectRef idx="1">
+            <a:schemeClr val="accent1"/>
+          </a:effectRef>
+          <a:fontRef idx="minor">
+            <a:schemeClr val="tx1"/>
+          </a:fontRef>
+        </p:style>
+      </p:cxnSp>
+      <p:cxnSp>
+        <p:nvCxnSpPr>
+          <p:cNvPr id="42" name="Gerade Verbindung mit Pfeil 41">
+            <a:extLst>
+              <a:ext uri="{FF2B5EF4-FFF2-40B4-BE49-F238E27FC236}">
+                <a16:creationId xmlns:a16="http://schemas.microsoft.com/office/drawing/2014/main" id="{73C72B0A-9444-27BF-32D8-77A6CF7EEF75}"/>
+              </a:ext>
+            </a:extLst>
+          </p:cNvPr>
+          <p:cNvCxnSpPr>
+            <a:cxnSpLocks/>
+          </p:cNvCxnSpPr>
+          <p:nvPr/>
+        </p:nvCxnSpPr>
+        <p:spPr>
+          <a:xfrm>
+            <a:off x="772795" y="2618184"/>
+            <a:ext cx="594360" cy="0"/>
+          </a:xfrm>
+          <a:prstGeom prst="straightConnector1">
+            <a:avLst/>
+          </a:prstGeom>
+          <a:ln w="12700" cap="rnd">
+            <a:solidFill>
+              <a:schemeClr val="tx1"/>
+            </a:solidFill>
+            <a:round/>
+            <a:headEnd type="triangle" w="sm" len="med"/>
+            <a:tailEnd type="triangle" w="sm" len="med"/>
+          </a:ln>
+        </p:spPr>
+        <p:style>
+          <a:lnRef idx="2">
+            <a:schemeClr val="accent1"/>
+          </a:lnRef>
+          <a:fillRef idx="0">
+            <a:schemeClr val="accent1"/>
+          </a:fillRef>
+          <a:effectRef idx="1">
+            <a:schemeClr val="accent1"/>
+          </a:effectRef>
+          <a:fontRef idx="minor">
+            <a:schemeClr val="tx1"/>
+          </a:fontRef>
+        </p:style>
+      </p:cxnSp>
+      <p:cxnSp>
+        <p:nvCxnSpPr>
+          <p:cNvPr id="46" name="Gerade Verbindung mit Pfeil 45">
+            <a:extLst>
+              <a:ext uri="{FF2B5EF4-FFF2-40B4-BE49-F238E27FC236}">
+                <a16:creationId xmlns:a16="http://schemas.microsoft.com/office/drawing/2014/main" id="{B22C6BB2-34FA-415A-AD80-90CA1E595A5A}"/>
+              </a:ext>
+            </a:extLst>
+          </p:cNvPr>
+          <p:cNvCxnSpPr>
+            <a:cxnSpLocks/>
+          </p:cNvCxnSpPr>
+          <p:nvPr/>
+        </p:nvCxnSpPr>
+        <p:spPr>
+          <a:xfrm>
+            <a:off x="1367155" y="2618184"/>
+            <a:ext cx="980440" cy="0"/>
+          </a:xfrm>
+          <a:prstGeom prst="straightConnector1">
+            <a:avLst/>
+          </a:prstGeom>
+          <a:ln w="12700" cap="rnd">
+            <a:solidFill>
+              <a:schemeClr val="tx1"/>
+            </a:solidFill>
+            <a:round/>
+            <a:headEnd type="triangle" w="sm" len="med"/>
+            <a:tailEnd type="triangle" w="sm" len="med"/>
+          </a:ln>
+        </p:spPr>
+        <p:style>
+          <a:lnRef idx="2">
+            <a:schemeClr val="accent1"/>
+          </a:lnRef>
+          <a:fillRef idx="0">
+            <a:schemeClr val="accent1"/>
+          </a:fillRef>
+          <a:effectRef idx="1">
+            <a:schemeClr val="accent1"/>
+          </a:effectRef>
+          <a:fontRef idx="minor">
+            <a:schemeClr val="tx1"/>
+          </a:fontRef>
+        </p:style>
+      </p:cxnSp>
+      <p:cxnSp>
+        <p:nvCxnSpPr>
+          <p:cNvPr id="48" name="Gerader Verbinder 47">
+            <a:extLst>
+              <a:ext uri="{FF2B5EF4-FFF2-40B4-BE49-F238E27FC236}">
+                <a16:creationId xmlns:a16="http://schemas.microsoft.com/office/drawing/2014/main" id="{16EE5A6A-0566-5F8B-5F0A-13E0E89B85D0}"/>
+              </a:ext>
+            </a:extLst>
+          </p:cNvPr>
+          <p:cNvCxnSpPr>
+            <a:cxnSpLocks/>
+          </p:cNvCxnSpPr>
+          <p:nvPr/>
+        </p:nvCxnSpPr>
+        <p:spPr>
+          <a:xfrm>
+            <a:off x="546021" y="2313543"/>
+            <a:ext cx="0" cy="363220"/>
+          </a:xfrm>
+          <a:prstGeom prst="line">
+            <a:avLst/>
+          </a:prstGeom>
+          <a:ln w="6350">
+            <a:solidFill>
+              <a:schemeClr val="tx1"/>
+            </a:solidFill>
+          </a:ln>
+        </p:spPr>
+        <p:style>
+          <a:lnRef idx="2">
+            <a:schemeClr val="accent1"/>
+          </a:lnRef>
+          <a:fillRef idx="0">
+            <a:schemeClr val="accent1"/>
+          </a:fillRef>
+          <a:effectRef idx="1">
+            <a:schemeClr val="accent1"/>
+          </a:effectRef>
+          <a:fontRef idx="minor">
+            <a:schemeClr val="tx1"/>
+          </a:fontRef>
+        </p:style>
+      </p:cxnSp>
+      <p:cxnSp>
+        <p:nvCxnSpPr>
+          <p:cNvPr id="51" name="Gerade Verbindung mit Pfeil 50">
+            <a:extLst>
+              <a:ext uri="{FF2B5EF4-FFF2-40B4-BE49-F238E27FC236}">
+                <a16:creationId xmlns:a16="http://schemas.microsoft.com/office/drawing/2014/main" id="{0D455E2D-64C8-1EB3-3312-EB5E093D4927}"/>
+              </a:ext>
+            </a:extLst>
+          </p:cNvPr>
+          <p:cNvCxnSpPr>
+            <a:cxnSpLocks/>
+          </p:cNvCxnSpPr>
+          <p:nvPr/>
+        </p:nvCxnSpPr>
+        <p:spPr>
+          <a:xfrm>
+            <a:off x="546021" y="2618184"/>
+            <a:ext cx="226774" cy="0"/>
+          </a:xfrm>
+          <a:prstGeom prst="straightConnector1">
+            <a:avLst/>
+          </a:prstGeom>
+          <a:ln w="12700" cap="rnd">
+            <a:solidFill>
+              <a:schemeClr val="tx1"/>
+            </a:solidFill>
+            <a:round/>
+            <a:headEnd type="triangle" w="sm" len="med"/>
+            <a:tailEnd type="triangle" w="sm" len="med"/>
+          </a:ln>
+        </p:spPr>
+        <p:style>
+          <a:lnRef idx="2">
+            <a:schemeClr val="accent1"/>
+          </a:lnRef>
+          <a:fillRef idx="0">
+            <a:schemeClr val="accent1"/>
+          </a:fillRef>
+          <a:effectRef idx="1">
+            <a:schemeClr val="accent1"/>
+          </a:effectRef>
+          <a:fontRef idx="minor">
+            <a:schemeClr val="tx1"/>
+          </a:fontRef>
+        </p:style>
+      </p:cxnSp>
+      <p:sp>
+        <p:nvSpPr>
+          <p:cNvPr id="55" name="Textfeld 54">
+            <a:extLst>
+              <a:ext uri="{FF2B5EF4-FFF2-40B4-BE49-F238E27FC236}">
+                <a16:creationId xmlns:a16="http://schemas.microsoft.com/office/drawing/2014/main" id="{F20FE673-2488-041A-75B6-1FA16F009D30}"/>
+              </a:ext>
+            </a:extLst>
+          </p:cNvPr>
+          <p:cNvSpPr txBox="1"/>
+          <p:nvPr/>
+        </p:nvSpPr>
+        <p:spPr>
+          <a:xfrm>
+            <a:off x="463123" y="2604099"/>
+            <a:ext cx="368955" cy="276999"/>
+          </a:xfrm>
+          <a:prstGeom prst="rect">
+            <a:avLst/>
+          </a:prstGeom>
+          <a:noFill/>
+        </p:spPr>
+        <p:txBody>
+          <a:bodyPr wrap="square" rtlCol="0" anchor="ctr">
+            <a:spAutoFit/>
+          </a:bodyPr>
+          <a:lstStyle/>
+          <a:p>
+            <a:pPr algn="ctr"/>
+            <a:r>
+              <a:rPr lang="de-DE" sz="1200" i="1" dirty="0">
+                <a:latin typeface="CMU Serif" panose="02000603000000000000" pitchFamily="2" charset="0"/>
+                <a:ea typeface="CMU Serif" panose="02000603000000000000" pitchFamily="2" charset="0"/>
+                <a:cs typeface="CMU Serif" panose="02000603000000000000" pitchFamily="2" charset="0"/>
+              </a:rPr>
+              <a:t>a</a:t>
+            </a:r>
+            <a:endParaRPr lang="de-DE" sz="1200" baseline="-25000" dirty="0">
+              <a:latin typeface="CMU Serif" panose="02000603000000000000" pitchFamily="2" charset="0"/>
+              <a:ea typeface="CMU Serif" panose="02000603000000000000" pitchFamily="2" charset="0"/>
+              <a:cs typeface="CMU Serif" panose="02000603000000000000" pitchFamily="2" charset="0"/>
+            </a:endParaRPr>
+          </a:p>
+        </p:txBody>
+      </p:sp>
+      <p:sp>
+        <p:nvSpPr>
+          <p:cNvPr id="57" name="Textfeld 56">
+            <a:extLst>
+              <a:ext uri="{FF2B5EF4-FFF2-40B4-BE49-F238E27FC236}">
+                <a16:creationId xmlns:a16="http://schemas.microsoft.com/office/drawing/2014/main" id="{5FAB5A20-E690-4B0F-2E54-068BFBA445AD}"/>
+              </a:ext>
+            </a:extLst>
+          </p:cNvPr>
+          <p:cNvSpPr txBox="1"/>
+          <p:nvPr/>
+        </p:nvSpPr>
+        <p:spPr>
+          <a:xfrm>
+            <a:off x="883532" y="2603973"/>
+            <a:ext cx="368955" cy="276999"/>
+          </a:xfrm>
+          <a:prstGeom prst="rect">
+            <a:avLst/>
+          </a:prstGeom>
+          <a:noFill/>
+        </p:spPr>
+        <p:txBody>
+          <a:bodyPr wrap="square" rtlCol="0" anchor="ctr">
+            <a:spAutoFit/>
+          </a:bodyPr>
+          <a:lstStyle/>
+          <a:p>
+            <a:pPr algn="ctr"/>
+            <a:r>
+              <a:rPr lang="de-DE" sz="1200" i="1" dirty="0">
+                <a:latin typeface="CMU Serif" panose="02000603000000000000" pitchFamily="2" charset="0"/>
+                <a:ea typeface="CMU Serif" panose="02000603000000000000" pitchFamily="2" charset="0"/>
+                <a:cs typeface="CMU Serif" panose="02000603000000000000" pitchFamily="2" charset="0"/>
+              </a:rPr>
+              <a:t>b</a:t>
+            </a:r>
+            <a:endParaRPr lang="de-DE" sz="1200" baseline="-25000" dirty="0">
+              <a:latin typeface="CMU Serif" panose="02000603000000000000" pitchFamily="2" charset="0"/>
+              <a:ea typeface="CMU Serif" panose="02000603000000000000" pitchFamily="2" charset="0"/>
+              <a:cs typeface="CMU Serif" panose="02000603000000000000" pitchFamily="2" charset="0"/>
+            </a:endParaRPr>
+          </a:p>
+        </p:txBody>
+      </p:sp>
+      <p:sp>
+        <p:nvSpPr>
+          <p:cNvPr id="59" name="Textfeld 58">
+            <a:extLst>
+              <a:ext uri="{FF2B5EF4-FFF2-40B4-BE49-F238E27FC236}">
+                <a16:creationId xmlns:a16="http://schemas.microsoft.com/office/drawing/2014/main" id="{24CBAC8F-A8EA-2AEA-13E6-58E19141EE03}"/>
+              </a:ext>
+            </a:extLst>
+          </p:cNvPr>
+          <p:cNvSpPr txBox="1"/>
+          <p:nvPr/>
+        </p:nvSpPr>
+        <p:spPr>
+          <a:xfrm>
+            <a:off x="1672897" y="2603973"/>
+            <a:ext cx="368955" cy="276999"/>
+          </a:xfrm>
+          <a:prstGeom prst="rect">
+            <a:avLst/>
+          </a:prstGeom>
+          <a:noFill/>
+        </p:spPr>
+        <p:txBody>
+          <a:bodyPr wrap="square" rtlCol="0" anchor="ctr">
+            <a:spAutoFit/>
+          </a:bodyPr>
+          <a:lstStyle/>
+          <a:p>
+            <a:pPr algn="ctr"/>
+            <a:r>
+              <a:rPr lang="de-DE" sz="1200" i="1" dirty="0">
+                <a:latin typeface="CMU Serif" panose="02000603000000000000" pitchFamily="2" charset="0"/>
+                <a:ea typeface="CMU Serif" panose="02000603000000000000" pitchFamily="2" charset="0"/>
+                <a:cs typeface="CMU Serif" panose="02000603000000000000" pitchFamily="2" charset="0"/>
+              </a:rPr>
+              <a:t>c</a:t>
+            </a:r>
+            <a:endParaRPr lang="de-DE" sz="1200" baseline="-25000" dirty="0">
+              <a:latin typeface="CMU Serif" panose="02000603000000000000" pitchFamily="2" charset="0"/>
+              <a:ea typeface="CMU Serif" panose="02000603000000000000" pitchFamily="2" charset="0"/>
+              <a:cs typeface="CMU Serif" panose="02000603000000000000" pitchFamily="2" charset="0"/>
+            </a:endParaRPr>
+          </a:p>
+        </p:txBody>
+      </p:sp>
     </p:spTree>
     <p:extLst>
       <p:ext uri="{BB962C8B-B14F-4D97-AF65-F5344CB8AC3E}">
         <p14:creationId xmlns:p14="http://schemas.microsoft.com/office/powerpoint/2010/main" val="1100447898"/>
+      </p:ext>
+    </p:extLst>
+  </p:cSld>
+  <p:clrMapOvr>
+    <a:masterClrMapping/>
+  </p:clrMapOvr>
+</p:sld>
+</file>
+
+<file path=ppt/slides/slide13.xml><?xml version="1.0" encoding="utf-8"?>
+<p:sld xmlns:a="http://schemas.openxmlformats.org/drawingml/2006/main" xmlns:r="http://schemas.openxmlformats.org/officeDocument/2006/relationships" xmlns:p="http://schemas.openxmlformats.org/presentationml/2006/main">
+  <p:cSld>
+    <p:spTree>
+      <p:nvGrpSpPr>
+        <p:cNvPr id="1" name="">
+          <a:extLst>
+            <a:ext uri="{FF2B5EF4-FFF2-40B4-BE49-F238E27FC236}">
+              <a16:creationId xmlns:a16="http://schemas.microsoft.com/office/drawing/2014/main" id="{3FBBA32C-BDB9-136E-1F2B-252FA81ACD83}"/>
+            </a:ext>
+          </a:extLst>
+        </p:cNvPr>
+        <p:cNvGrpSpPr/>
+        <p:nvPr/>
+      </p:nvGrpSpPr>
+      <p:grpSpPr>
+        <a:xfrm>
+          <a:off x="0" y="0"/>
+          <a:ext cx="0" cy="0"/>
+          <a:chOff x="0" y="0"/>
+          <a:chExt cx="0" cy="0"/>
+        </a:xfrm>
+      </p:grpSpPr>
+    </p:spTree>
+    <p:extLst>
+      <p:ext uri="{BB962C8B-B14F-4D97-AF65-F5344CB8AC3E}">
+        <p14:creationId xmlns:p14="http://schemas.microsoft.com/office/powerpoint/2010/main" val="3411843301"/>
       </p:ext>
     </p:extLst>
   </p:cSld>

</xml_diff>

<commit_message>
continued chapter Rohrhydraulik in SL1
</commit_message>
<xml_diff>
--- a/LaTeX B.Sc. LRT/Strömungslehre 1/images/SL1-Images.pptx
+++ b/LaTeX B.Sc. LRT/Strömungslehre 1/images/SL1-Images.pptx
@@ -18,6 +18,7 @@
     <p:sldId id="266" r:id="rId12"/>
     <p:sldId id="267" r:id="rId13"/>
     <p:sldId id="268" r:id="rId14"/>
+    <p:sldId id="269" r:id="rId15"/>
   </p:sldIdLst>
   <p:sldSz cx="3600450" cy="3600450"/>
   <p:notesSz cx="6858000" cy="9144000"/>
@@ -255,7 +256,7 @@
           <a:p>
             <a:fld id="{0F04D7A0-D8C8-4B74-9611-9A000801FA36}" type="datetimeFigureOut">
               <a:rPr lang="de-DE" smtClean="0"/>
-              <a:t>23.09.2026</a:t>
+              <a:t>25.09.2026</a:t>
             </a:fld>
             <a:endParaRPr lang="de-DE"/>
           </a:p>
@@ -425,7 +426,7 @@
           <a:p>
             <a:fld id="{0F04D7A0-D8C8-4B74-9611-9A000801FA36}" type="datetimeFigureOut">
               <a:rPr lang="de-DE" smtClean="0"/>
-              <a:t>23.09.2026</a:t>
+              <a:t>25.09.2026</a:t>
             </a:fld>
             <a:endParaRPr lang="de-DE"/>
           </a:p>
@@ -605,7 +606,7 @@
           <a:p>
             <a:fld id="{0F04D7A0-D8C8-4B74-9611-9A000801FA36}" type="datetimeFigureOut">
               <a:rPr lang="de-DE" smtClean="0"/>
-              <a:t>23.09.2026</a:t>
+              <a:t>25.09.2026</a:t>
             </a:fld>
             <a:endParaRPr lang="de-DE"/>
           </a:p>
@@ -775,7 +776,7 @@
           <a:p>
             <a:fld id="{0F04D7A0-D8C8-4B74-9611-9A000801FA36}" type="datetimeFigureOut">
               <a:rPr lang="de-DE" smtClean="0"/>
-              <a:t>23.09.2026</a:t>
+              <a:t>25.09.2026</a:t>
             </a:fld>
             <a:endParaRPr lang="de-DE"/>
           </a:p>
@@ -1021,7 +1022,7 @@
           <a:p>
             <a:fld id="{0F04D7A0-D8C8-4B74-9611-9A000801FA36}" type="datetimeFigureOut">
               <a:rPr lang="de-DE" smtClean="0"/>
-              <a:t>23.09.2026</a:t>
+              <a:t>25.09.2026</a:t>
             </a:fld>
             <a:endParaRPr lang="de-DE"/>
           </a:p>
@@ -1253,7 +1254,7 @@
           <a:p>
             <a:fld id="{0F04D7A0-D8C8-4B74-9611-9A000801FA36}" type="datetimeFigureOut">
               <a:rPr lang="de-DE" smtClean="0"/>
-              <a:t>23.09.2026</a:t>
+              <a:t>25.09.2026</a:t>
             </a:fld>
             <a:endParaRPr lang="de-DE"/>
           </a:p>
@@ -1620,7 +1621,7 @@
           <a:p>
             <a:fld id="{0F04D7A0-D8C8-4B74-9611-9A000801FA36}" type="datetimeFigureOut">
               <a:rPr lang="de-DE" smtClean="0"/>
-              <a:t>23.09.2026</a:t>
+              <a:t>25.09.2026</a:t>
             </a:fld>
             <a:endParaRPr lang="de-DE"/>
           </a:p>
@@ -1738,7 +1739,7 @@
           <a:p>
             <a:fld id="{0F04D7A0-D8C8-4B74-9611-9A000801FA36}" type="datetimeFigureOut">
               <a:rPr lang="de-DE" smtClean="0"/>
-              <a:t>23.09.2026</a:t>
+              <a:t>25.09.2026</a:t>
             </a:fld>
             <a:endParaRPr lang="de-DE"/>
           </a:p>
@@ -1833,7 +1834,7 @@
           <a:p>
             <a:fld id="{0F04D7A0-D8C8-4B74-9611-9A000801FA36}" type="datetimeFigureOut">
               <a:rPr lang="de-DE" smtClean="0"/>
-              <a:t>23.09.2026</a:t>
+              <a:t>25.09.2026</a:t>
             </a:fld>
             <a:endParaRPr lang="de-DE"/>
           </a:p>
@@ -2110,7 +2111,7 @@
           <a:p>
             <a:fld id="{0F04D7A0-D8C8-4B74-9611-9A000801FA36}" type="datetimeFigureOut">
               <a:rPr lang="de-DE" smtClean="0"/>
-              <a:t>23.09.2026</a:t>
+              <a:t>25.09.2026</a:t>
             </a:fld>
             <a:endParaRPr lang="de-DE"/>
           </a:p>
@@ -2367,7 +2368,7 @@
           <a:p>
             <a:fld id="{0F04D7A0-D8C8-4B74-9611-9A000801FA36}" type="datetimeFigureOut">
               <a:rPr lang="de-DE" smtClean="0"/>
-              <a:t>23.09.2026</a:t>
+              <a:t>25.09.2026</a:t>
             </a:fld>
             <a:endParaRPr lang="de-DE"/>
           </a:p>
@@ -2580,7 +2581,7 @@
           <a:p>
             <a:fld id="{0F04D7A0-D8C8-4B74-9611-9A000801FA36}" type="datetimeFigureOut">
               <a:rPr lang="de-DE" smtClean="0"/>
-              <a:t>23.09.2026</a:t>
+              <a:t>25.09.2026</a:t>
             </a:fld>
             <a:endParaRPr lang="de-DE"/>
           </a:p>
@@ -8922,10 +8923,2264 @@
           <a:chExt cx="0" cy="0"/>
         </a:xfrm>
       </p:grpSpPr>
+      <p:sp>
+        <p:nvSpPr>
+          <p:cNvPr id="16" name="Rechteck 15">
+            <a:extLst>
+              <a:ext uri="{FF2B5EF4-FFF2-40B4-BE49-F238E27FC236}">
+                <a16:creationId xmlns:a16="http://schemas.microsoft.com/office/drawing/2014/main" id="{0C467AB4-19CC-23E0-E97F-EAAEF879B37C}"/>
+              </a:ext>
+            </a:extLst>
+          </p:cNvPr>
+          <p:cNvSpPr/>
+          <p:nvPr/>
+        </p:nvSpPr>
+        <p:spPr>
+          <a:xfrm>
+            <a:off x="1506856" y="1506856"/>
+            <a:ext cx="110490" cy="201930"/>
+          </a:xfrm>
+          <a:prstGeom prst="rect">
+            <a:avLst/>
+          </a:prstGeom>
+          <a:solidFill>
+            <a:schemeClr val="bg1">
+              <a:lumMod val="75000"/>
+            </a:schemeClr>
+          </a:solidFill>
+          <a:ln>
+            <a:noFill/>
+          </a:ln>
+        </p:spPr>
+        <p:style>
+          <a:lnRef idx="2">
+            <a:schemeClr val="accent1">
+              <a:shade val="15000"/>
+            </a:schemeClr>
+          </a:lnRef>
+          <a:fillRef idx="1">
+            <a:schemeClr val="accent1"/>
+          </a:fillRef>
+          <a:effectRef idx="0">
+            <a:schemeClr val="accent1"/>
+          </a:effectRef>
+          <a:fontRef idx="minor">
+            <a:schemeClr val="lt1"/>
+          </a:fontRef>
+        </p:style>
+        <p:txBody>
+          <a:bodyPr rtlCol="0" anchor="ctr"/>
+          <a:lstStyle/>
+          <a:p>
+            <a:pPr algn="ctr"/>
+            <a:endParaRPr lang="de-DE" sz="1200" dirty="0">
+              <a:solidFill>
+                <a:schemeClr val="tx1"/>
+              </a:solidFill>
+              <a:latin typeface="CMU Serif" panose="02000603000000000000" pitchFamily="2" charset="0"/>
+              <a:ea typeface="CMU Serif" panose="02000603000000000000" pitchFamily="2" charset="0"/>
+              <a:cs typeface="CMU Serif" panose="02000603000000000000" pitchFamily="2" charset="0"/>
+            </a:endParaRPr>
+          </a:p>
+        </p:txBody>
+      </p:sp>
+      <p:sp>
+        <p:nvSpPr>
+          <p:cNvPr id="18" name="Rechteck 17">
+            <a:extLst>
+              <a:ext uri="{FF2B5EF4-FFF2-40B4-BE49-F238E27FC236}">
+                <a16:creationId xmlns:a16="http://schemas.microsoft.com/office/drawing/2014/main" id="{0971F827-281C-BB71-276D-E4CFCCB76EE3}"/>
+              </a:ext>
+            </a:extLst>
+          </p:cNvPr>
+          <p:cNvSpPr/>
+          <p:nvPr/>
+        </p:nvSpPr>
+        <p:spPr>
+          <a:xfrm>
+            <a:off x="1507160" y="1431847"/>
+            <a:ext cx="1229679" cy="112991"/>
+          </a:xfrm>
+          <a:prstGeom prst="rect">
+            <a:avLst/>
+          </a:prstGeom>
+          <a:solidFill>
+            <a:schemeClr val="bg1">
+              <a:lumMod val="75000"/>
+            </a:schemeClr>
+          </a:solidFill>
+          <a:ln>
+            <a:noFill/>
+          </a:ln>
+        </p:spPr>
+        <p:style>
+          <a:lnRef idx="2">
+            <a:schemeClr val="accent1">
+              <a:shade val="15000"/>
+            </a:schemeClr>
+          </a:lnRef>
+          <a:fillRef idx="1">
+            <a:schemeClr val="accent1"/>
+          </a:fillRef>
+          <a:effectRef idx="0">
+            <a:schemeClr val="accent1"/>
+          </a:effectRef>
+          <a:fontRef idx="minor">
+            <a:schemeClr val="lt1"/>
+          </a:fontRef>
+        </p:style>
+        <p:txBody>
+          <a:bodyPr rtlCol="0" anchor="ctr"/>
+          <a:lstStyle/>
+          <a:p>
+            <a:pPr algn="ctr"/>
+            <a:endParaRPr lang="de-DE" sz="1200" dirty="0">
+              <a:solidFill>
+                <a:schemeClr val="tx1"/>
+              </a:solidFill>
+              <a:latin typeface="CMU Serif" panose="02000603000000000000" pitchFamily="2" charset="0"/>
+              <a:ea typeface="CMU Serif" panose="02000603000000000000" pitchFamily="2" charset="0"/>
+              <a:cs typeface="CMU Serif" panose="02000603000000000000" pitchFamily="2" charset="0"/>
+            </a:endParaRPr>
+          </a:p>
+        </p:txBody>
+      </p:sp>
+      <p:sp>
+        <p:nvSpPr>
+          <p:cNvPr id="14" name="Rechteck 13">
+            <a:extLst>
+              <a:ext uri="{FF2B5EF4-FFF2-40B4-BE49-F238E27FC236}">
+                <a16:creationId xmlns:a16="http://schemas.microsoft.com/office/drawing/2014/main" id="{53F3F189-7935-1B03-30D0-B8DF49E7263A}"/>
+              </a:ext>
+            </a:extLst>
+          </p:cNvPr>
+          <p:cNvSpPr/>
+          <p:nvPr/>
+        </p:nvSpPr>
+        <p:spPr>
+          <a:xfrm>
+            <a:off x="1506856" y="933686"/>
+            <a:ext cx="110490" cy="199317"/>
+          </a:xfrm>
+          <a:prstGeom prst="rect">
+            <a:avLst/>
+          </a:prstGeom>
+          <a:solidFill>
+            <a:schemeClr val="bg1">
+              <a:lumMod val="75000"/>
+            </a:schemeClr>
+          </a:solidFill>
+          <a:ln>
+            <a:noFill/>
+          </a:ln>
+        </p:spPr>
+        <p:style>
+          <a:lnRef idx="2">
+            <a:schemeClr val="accent1">
+              <a:shade val="15000"/>
+            </a:schemeClr>
+          </a:lnRef>
+          <a:fillRef idx="1">
+            <a:schemeClr val="accent1"/>
+          </a:fillRef>
+          <a:effectRef idx="0">
+            <a:schemeClr val="accent1"/>
+          </a:effectRef>
+          <a:fontRef idx="minor">
+            <a:schemeClr val="lt1"/>
+          </a:fontRef>
+        </p:style>
+        <p:txBody>
+          <a:bodyPr rtlCol="0" anchor="ctr"/>
+          <a:lstStyle/>
+          <a:p>
+            <a:pPr algn="ctr"/>
+            <a:endParaRPr lang="de-DE" sz="1200" dirty="0">
+              <a:solidFill>
+                <a:schemeClr val="tx1"/>
+              </a:solidFill>
+              <a:latin typeface="CMU Serif" panose="02000603000000000000" pitchFamily="2" charset="0"/>
+              <a:ea typeface="CMU Serif" panose="02000603000000000000" pitchFamily="2" charset="0"/>
+              <a:cs typeface="CMU Serif" panose="02000603000000000000" pitchFamily="2" charset="0"/>
+            </a:endParaRPr>
+          </a:p>
+        </p:txBody>
+      </p:sp>
+      <p:sp>
+        <p:nvSpPr>
+          <p:cNvPr id="12" name="Rechteck 11">
+            <a:extLst>
+              <a:ext uri="{FF2B5EF4-FFF2-40B4-BE49-F238E27FC236}">
+                <a16:creationId xmlns:a16="http://schemas.microsoft.com/office/drawing/2014/main" id="{F941A233-6ADB-9F19-56DA-14162D399051}"/>
+              </a:ext>
+            </a:extLst>
+          </p:cNvPr>
+          <p:cNvSpPr/>
+          <p:nvPr/>
+        </p:nvSpPr>
+        <p:spPr>
+          <a:xfrm>
+            <a:off x="1506855" y="1095376"/>
+            <a:ext cx="1229679" cy="112991"/>
+          </a:xfrm>
+          <a:prstGeom prst="rect">
+            <a:avLst/>
+          </a:prstGeom>
+          <a:solidFill>
+            <a:schemeClr val="bg1">
+              <a:lumMod val="75000"/>
+            </a:schemeClr>
+          </a:solidFill>
+          <a:ln>
+            <a:noFill/>
+          </a:ln>
+        </p:spPr>
+        <p:style>
+          <a:lnRef idx="2">
+            <a:schemeClr val="accent1">
+              <a:shade val="15000"/>
+            </a:schemeClr>
+          </a:lnRef>
+          <a:fillRef idx="1">
+            <a:schemeClr val="accent1"/>
+          </a:fillRef>
+          <a:effectRef idx="0">
+            <a:schemeClr val="accent1"/>
+          </a:effectRef>
+          <a:fontRef idx="minor">
+            <a:schemeClr val="lt1"/>
+          </a:fontRef>
+        </p:style>
+        <p:txBody>
+          <a:bodyPr rtlCol="0" anchor="ctr"/>
+          <a:lstStyle/>
+          <a:p>
+            <a:pPr algn="ctr"/>
+            <a:endParaRPr lang="de-DE" sz="1200" dirty="0">
+              <a:solidFill>
+                <a:schemeClr val="tx1"/>
+              </a:solidFill>
+              <a:latin typeface="CMU Serif" panose="02000603000000000000" pitchFamily="2" charset="0"/>
+              <a:ea typeface="CMU Serif" panose="02000603000000000000" pitchFamily="2" charset="0"/>
+              <a:cs typeface="CMU Serif" panose="02000603000000000000" pitchFamily="2" charset="0"/>
+            </a:endParaRPr>
+          </a:p>
+        </p:txBody>
+      </p:sp>
+      <p:cxnSp>
+        <p:nvCxnSpPr>
+          <p:cNvPr id="2" name="Gerader Verbinder 1">
+            <a:extLst>
+              <a:ext uri="{FF2B5EF4-FFF2-40B4-BE49-F238E27FC236}">
+                <a16:creationId xmlns:a16="http://schemas.microsoft.com/office/drawing/2014/main" id="{21085E54-A76B-DE47-9A00-BD29CC84FE6C}"/>
+              </a:ext>
+            </a:extLst>
+          </p:cNvPr>
+          <p:cNvCxnSpPr>
+            <a:cxnSpLocks/>
+          </p:cNvCxnSpPr>
+          <p:nvPr/>
+        </p:nvCxnSpPr>
+        <p:spPr>
+          <a:xfrm flipH="1">
+            <a:off x="1507467" y="1208011"/>
+            <a:ext cx="1221446" cy="0"/>
+          </a:xfrm>
+          <a:prstGeom prst="line">
+            <a:avLst/>
+          </a:prstGeom>
+          <a:ln cap="rnd">
+            <a:solidFill>
+              <a:schemeClr val="tx1">
+                <a:lumMod val="75000"/>
+                <a:lumOff val="25000"/>
+              </a:schemeClr>
+            </a:solidFill>
+            <a:round/>
+          </a:ln>
+        </p:spPr>
+        <p:style>
+          <a:lnRef idx="2">
+            <a:schemeClr val="accent1"/>
+          </a:lnRef>
+          <a:fillRef idx="0">
+            <a:schemeClr val="accent1"/>
+          </a:fillRef>
+          <a:effectRef idx="1">
+            <a:schemeClr val="accent1"/>
+          </a:effectRef>
+          <a:fontRef idx="minor">
+            <a:schemeClr val="tx1"/>
+          </a:fontRef>
+        </p:style>
+      </p:cxnSp>
+      <p:cxnSp>
+        <p:nvCxnSpPr>
+          <p:cNvPr id="5" name="Gerader Verbinder 4">
+            <a:extLst>
+              <a:ext uri="{FF2B5EF4-FFF2-40B4-BE49-F238E27FC236}">
+                <a16:creationId xmlns:a16="http://schemas.microsoft.com/office/drawing/2014/main" id="{560FEE65-C4EC-3868-65F2-E6C0E67E3F91}"/>
+              </a:ext>
+            </a:extLst>
+          </p:cNvPr>
+          <p:cNvCxnSpPr>
+            <a:cxnSpLocks/>
+          </p:cNvCxnSpPr>
+          <p:nvPr/>
+        </p:nvCxnSpPr>
+        <p:spPr>
+          <a:xfrm flipH="1">
+            <a:off x="1507467" y="1431848"/>
+            <a:ext cx="1221446" cy="0"/>
+          </a:xfrm>
+          <a:prstGeom prst="line">
+            <a:avLst/>
+          </a:prstGeom>
+          <a:ln cap="rnd">
+            <a:solidFill>
+              <a:schemeClr val="tx1">
+                <a:lumMod val="75000"/>
+                <a:lumOff val="25000"/>
+              </a:schemeClr>
+            </a:solidFill>
+            <a:round/>
+          </a:ln>
+        </p:spPr>
+        <p:style>
+          <a:lnRef idx="2">
+            <a:schemeClr val="accent1"/>
+          </a:lnRef>
+          <a:fillRef idx="0">
+            <a:schemeClr val="accent1"/>
+          </a:fillRef>
+          <a:effectRef idx="1">
+            <a:schemeClr val="accent1"/>
+          </a:effectRef>
+          <a:fontRef idx="minor">
+            <a:schemeClr val="tx1"/>
+          </a:fontRef>
+        </p:style>
+      </p:cxnSp>
+      <p:cxnSp>
+        <p:nvCxnSpPr>
+          <p:cNvPr id="6" name="Gerader Verbinder 5">
+            <a:extLst>
+              <a:ext uri="{FF2B5EF4-FFF2-40B4-BE49-F238E27FC236}">
+                <a16:creationId xmlns:a16="http://schemas.microsoft.com/office/drawing/2014/main" id="{AE09A201-DC15-4F0D-904E-6F4C54237FD6}"/>
+              </a:ext>
+            </a:extLst>
+          </p:cNvPr>
+          <p:cNvCxnSpPr>
+            <a:cxnSpLocks/>
+          </p:cNvCxnSpPr>
+          <p:nvPr/>
+        </p:nvCxnSpPr>
+        <p:spPr>
+          <a:xfrm flipV="1">
+            <a:off x="1507467" y="1431848"/>
+            <a:ext cx="0" cy="265984"/>
+          </a:xfrm>
+          <a:prstGeom prst="line">
+            <a:avLst/>
+          </a:prstGeom>
+          <a:ln cap="rnd">
+            <a:solidFill>
+              <a:schemeClr val="tx1">
+                <a:lumMod val="75000"/>
+                <a:lumOff val="25000"/>
+              </a:schemeClr>
+            </a:solidFill>
+            <a:round/>
+          </a:ln>
+        </p:spPr>
+        <p:style>
+          <a:lnRef idx="2">
+            <a:schemeClr val="accent1"/>
+          </a:lnRef>
+          <a:fillRef idx="0">
+            <a:schemeClr val="accent1"/>
+          </a:fillRef>
+          <a:effectRef idx="1">
+            <a:schemeClr val="accent1"/>
+          </a:effectRef>
+          <a:fontRef idx="minor">
+            <a:schemeClr val="tx1"/>
+          </a:fontRef>
+        </p:style>
+      </p:cxnSp>
+      <p:cxnSp>
+        <p:nvCxnSpPr>
+          <p:cNvPr id="8" name="Gerader Verbinder 7">
+            <a:extLst>
+              <a:ext uri="{FF2B5EF4-FFF2-40B4-BE49-F238E27FC236}">
+                <a16:creationId xmlns:a16="http://schemas.microsoft.com/office/drawing/2014/main" id="{26B32410-EC54-C50D-7489-71D208EC3893}"/>
+              </a:ext>
+            </a:extLst>
+          </p:cNvPr>
+          <p:cNvCxnSpPr>
+            <a:cxnSpLocks/>
+          </p:cNvCxnSpPr>
+          <p:nvPr/>
+        </p:nvCxnSpPr>
+        <p:spPr>
+          <a:xfrm flipV="1">
+            <a:off x="1507467" y="942027"/>
+            <a:ext cx="0" cy="265984"/>
+          </a:xfrm>
+          <a:prstGeom prst="line">
+            <a:avLst/>
+          </a:prstGeom>
+          <a:ln cap="rnd">
+            <a:solidFill>
+              <a:schemeClr val="tx1">
+                <a:lumMod val="75000"/>
+                <a:lumOff val="25000"/>
+              </a:schemeClr>
+            </a:solidFill>
+            <a:round/>
+          </a:ln>
+        </p:spPr>
+        <p:style>
+          <a:lnRef idx="2">
+            <a:schemeClr val="accent1"/>
+          </a:lnRef>
+          <a:fillRef idx="0">
+            <a:schemeClr val="accent1"/>
+          </a:fillRef>
+          <a:effectRef idx="1">
+            <a:schemeClr val="accent1"/>
+          </a:effectRef>
+          <a:fontRef idx="minor">
+            <a:schemeClr val="tx1"/>
+          </a:fontRef>
+        </p:style>
+      </p:cxnSp>
+      <p:cxnSp>
+        <p:nvCxnSpPr>
+          <p:cNvPr id="19" name="Gerader Verbinder 18">
+            <a:extLst>
+              <a:ext uri="{FF2B5EF4-FFF2-40B4-BE49-F238E27FC236}">
+                <a16:creationId xmlns:a16="http://schemas.microsoft.com/office/drawing/2014/main" id="{54003ACE-89C9-4454-A87E-5B1D483F75AD}"/>
+              </a:ext>
+            </a:extLst>
+          </p:cNvPr>
+          <p:cNvCxnSpPr>
+            <a:cxnSpLocks/>
+          </p:cNvCxnSpPr>
+          <p:nvPr/>
+        </p:nvCxnSpPr>
+        <p:spPr>
+          <a:xfrm flipH="1">
+            <a:off x="1425654" y="1325168"/>
+            <a:ext cx="1377315" cy="0"/>
+          </a:xfrm>
+          <a:prstGeom prst="line">
+            <a:avLst/>
+          </a:prstGeom>
+          <a:ln w="6350" cap="rnd">
+            <a:solidFill>
+              <a:schemeClr val="tx1">
+                <a:lumMod val="75000"/>
+                <a:lumOff val="25000"/>
+              </a:schemeClr>
+            </a:solidFill>
+            <a:prstDash val="lgDashDot"/>
+            <a:round/>
+          </a:ln>
+        </p:spPr>
+        <p:style>
+          <a:lnRef idx="2">
+            <a:schemeClr val="accent1"/>
+          </a:lnRef>
+          <a:fillRef idx="0">
+            <a:schemeClr val="accent1"/>
+          </a:fillRef>
+          <a:effectRef idx="1">
+            <a:schemeClr val="accent1"/>
+          </a:effectRef>
+          <a:fontRef idx="minor">
+            <a:schemeClr val="tx1"/>
+          </a:fontRef>
+        </p:style>
+      </p:cxnSp>
+      <p:cxnSp>
+        <p:nvCxnSpPr>
+          <p:cNvPr id="21" name="Gerade Verbindung mit Pfeil 20">
+            <a:extLst>
+              <a:ext uri="{FF2B5EF4-FFF2-40B4-BE49-F238E27FC236}">
+                <a16:creationId xmlns:a16="http://schemas.microsoft.com/office/drawing/2014/main" id="{30CE71C5-A8E2-9305-6446-7E9861BBE785}"/>
+              </a:ext>
+            </a:extLst>
+          </p:cNvPr>
+          <p:cNvCxnSpPr>
+            <a:cxnSpLocks/>
+          </p:cNvCxnSpPr>
+          <p:nvPr/>
+        </p:nvCxnSpPr>
+        <p:spPr>
+          <a:xfrm>
+            <a:off x="1848808" y="1325168"/>
+            <a:ext cx="280982" cy="0"/>
+          </a:xfrm>
+          <a:prstGeom prst="straightConnector1">
+            <a:avLst/>
+          </a:prstGeom>
+          <a:ln w="19050" cap="rnd">
+            <a:solidFill>
+              <a:srgbClr val="0070C0"/>
+            </a:solidFill>
+            <a:round/>
+            <a:headEnd type="none"/>
+            <a:tailEnd type="triangle" w="med" len="med"/>
+          </a:ln>
+        </p:spPr>
+        <p:style>
+          <a:lnRef idx="2">
+            <a:schemeClr val="accent1"/>
+          </a:lnRef>
+          <a:fillRef idx="0">
+            <a:schemeClr val="accent1"/>
+          </a:fillRef>
+          <a:effectRef idx="1">
+            <a:schemeClr val="accent1"/>
+          </a:effectRef>
+          <a:fontRef idx="minor">
+            <a:schemeClr val="tx1"/>
+          </a:fontRef>
+        </p:style>
+      </p:cxnSp>
+      <p:grpSp>
+        <p:nvGrpSpPr>
+          <p:cNvPr id="30" name="Gruppieren 29">
+            <a:extLst>
+              <a:ext uri="{FF2B5EF4-FFF2-40B4-BE49-F238E27FC236}">
+                <a16:creationId xmlns:a16="http://schemas.microsoft.com/office/drawing/2014/main" id="{3EFA459E-9844-EF55-93CD-CBDBDD322760}"/>
+              </a:ext>
+            </a:extLst>
+          </p:cNvPr>
+          <p:cNvGrpSpPr/>
+          <p:nvPr/>
+        </p:nvGrpSpPr>
+        <p:grpSpPr>
+          <a:xfrm>
+            <a:off x="1683229" y="1517950"/>
+            <a:ext cx="358140" cy="306467"/>
+            <a:chOff x="1844040" y="1040959"/>
+            <a:chExt cx="358140" cy="306467"/>
+          </a:xfrm>
+        </p:grpSpPr>
+        <p:sp>
+          <p:nvSpPr>
+            <p:cNvPr id="22" name="Textfeld 21">
+              <a:extLst>
+                <a:ext uri="{FF2B5EF4-FFF2-40B4-BE49-F238E27FC236}">
+                  <a16:creationId xmlns:a16="http://schemas.microsoft.com/office/drawing/2014/main" id="{AD63A089-924F-8779-1A5B-626DC8D1220D}"/>
+                </a:ext>
+              </a:extLst>
+            </p:cNvPr>
+            <p:cNvSpPr txBox="1"/>
+            <p:nvPr/>
+          </p:nvSpPr>
+          <p:spPr>
+            <a:xfrm>
+              <a:off x="1844040" y="1040959"/>
+              <a:ext cx="358140" cy="306467"/>
+            </a:xfrm>
+            <a:prstGeom prst="roundRect">
+              <a:avLst>
+                <a:gd name="adj" fmla="val 22469"/>
+              </a:avLst>
+            </a:prstGeom>
+            <a:noFill/>
+          </p:spPr>
+          <p:txBody>
+            <a:bodyPr wrap="square" rtlCol="0" anchor="ctr">
+              <a:spAutoFit/>
+            </a:bodyPr>
+            <a:lstStyle/>
+            <a:p>
+              <a:pPr algn="ctr"/>
+              <a:r>
+                <a:rPr lang="de-DE" sz="1200" i="1" dirty="0" err="1">
+                  <a:solidFill>
+                    <a:srgbClr val="0070C0"/>
+                  </a:solidFill>
+                  <a:latin typeface="CMU Serif" panose="02000603000000000000" pitchFamily="2" charset="0"/>
+                  <a:ea typeface="CMU Serif" panose="02000603000000000000" pitchFamily="2" charset="0"/>
+                  <a:cs typeface="CMU Serif" panose="02000603000000000000" pitchFamily="2" charset="0"/>
+                </a:rPr>
+                <a:t>u</a:t>
+              </a:r>
+              <a:r>
+                <a:rPr lang="de-DE" sz="1200" i="1" baseline="-25000" dirty="0" err="1">
+                  <a:solidFill>
+                    <a:srgbClr val="0070C0"/>
+                  </a:solidFill>
+                  <a:latin typeface="Latin Modern Math" panose="02000503000000000000" pitchFamily="50" charset="0"/>
+                  <a:ea typeface="Latin Modern Math" panose="02000503000000000000" pitchFamily="50" charset="0"/>
+                  <a:cs typeface="CMU Serif" panose="02000603000000000000" pitchFamily="2" charset="0"/>
+                </a:rPr>
+                <a:t>ν</a:t>
+              </a:r>
+              <a:endParaRPr lang="de-DE" sz="1200" i="1" baseline="-25000" dirty="0">
+                <a:solidFill>
+                  <a:srgbClr val="0070C0"/>
+                </a:solidFill>
+                <a:latin typeface="Latin Modern Math" panose="02000503000000000000" pitchFamily="50" charset="0"/>
+                <a:ea typeface="Latin Modern Math" panose="02000503000000000000" pitchFamily="50" charset="0"/>
+                <a:cs typeface="CMU Serif" panose="02000603000000000000" pitchFamily="2" charset="0"/>
+              </a:endParaRPr>
+            </a:p>
+          </p:txBody>
+        </p:sp>
+        <p:cxnSp>
+          <p:nvCxnSpPr>
+            <p:cNvPr id="27" name="Gerade Verbindung mit Pfeil 26">
+              <a:extLst>
+                <a:ext uri="{FF2B5EF4-FFF2-40B4-BE49-F238E27FC236}">
+                  <a16:creationId xmlns:a16="http://schemas.microsoft.com/office/drawing/2014/main" id="{E4758D03-4B80-E811-7473-64E0982C5565}"/>
+                </a:ext>
+              </a:extLst>
+            </p:cNvPr>
+            <p:cNvCxnSpPr>
+              <a:cxnSpLocks/>
+            </p:cNvCxnSpPr>
+            <p:nvPr/>
+          </p:nvCxnSpPr>
+          <p:spPr>
+            <a:xfrm>
+              <a:off x="1986603" y="1145144"/>
+              <a:ext cx="50477" cy="0"/>
+            </a:xfrm>
+            <a:prstGeom prst="straightConnector1">
+              <a:avLst/>
+            </a:prstGeom>
+            <a:ln w="3175" cap="rnd">
+              <a:solidFill>
+                <a:srgbClr val="0070C0"/>
+              </a:solidFill>
+              <a:round/>
+              <a:headEnd type="none"/>
+              <a:tailEnd type="none" w="sm" len="med"/>
+            </a:ln>
+          </p:spPr>
+          <p:style>
+            <a:lnRef idx="2">
+              <a:schemeClr val="accent1"/>
+            </a:lnRef>
+            <a:fillRef idx="0">
+              <a:schemeClr val="accent1"/>
+            </a:fillRef>
+            <a:effectRef idx="1">
+              <a:schemeClr val="accent1"/>
+            </a:effectRef>
+            <a:fontRef idx="minor">
+              <a:schemeClr val="tx1"/>
+            </a:fontRef>
+          </p:style>
+        </p:cxnSp>
+      </p:grpSp>
+      <p:sp>
+        <p:nvSpPr>
+          <p:cNvPr id="31" name="Rechteck 30">
+            <a:extLst>
+              <a:ext uri="{FF2B5EF4-FFF2-40B4-BE49-F238E27FC236}">
+                <a16:creationId xmlns:a16="http://schemas.microsoft.com/office/drawing/2014/main" id="{4D89790C-906B-846B-59EE-09C24754E2E2}"/>
+              </a:ext>
+            </a:extLst>
+          </p:cNvPr>
+          <p:cNvSpPr/>
+          <p:nvPr/>
+        </p:nvSpPr>
+        <p:spPr>
+          <a:xfrm>
+            <a:off x="1506856" y="2454527"/>
+            <a:ext cx="110490" cy="201930"/>
+          </a:xfrm>
+          <a:prstGeom prst="rect">
+            <a:avLst/>
+          </a:prstGeom>
+          <a:solidFill>
+            <a:schemeClr val="bg1">
+              <a:lumMod val="75000"/>
+            </a:schemeClr>
+          </a:solidFill>
+          <a:ln>
+            <a:noFill/>
+          </a:ln>
+        </p:spPr>
+        <p:style>
+          <a:lnRef idx="2">
+            <a:schemeClr val="accent1">
+              <a:shade val="15000"/>
+            </a:schemeClr>
+          </a:lnRef>
+          <a:fillRef idx="1">
+            <a:schemeClr val="accent1"/>
+          </a:fillRef>
+          <a:effectRef idx="0">
+            <a:schemeClr val="accent1"/>
+          </a:effectRef>
+          <a:fontRef idx="minor">
+            <a:schemeClr val="lt1"/>
+          </a:fontRef>
+        </p:style>
+        <p:txBody>
+          <a:bodyPr rtlCol="0" anchor="ctr"/>
+          <a:lstStyle/>
+          <a:p>
+            <a:pPr algn="ctr"/>
+            <a:endParaRPr lang="de-DE" sz="1200" dirty="0">
+              <a:solidFill>
+                <a:schemeClr val="tx1"/>
+              </a:solidFill>
+              <a:latin typeface="CMU Serif" panose="02000603000000000000" pitchFamily="2" charset="0"/>
+              <a:ea typeface="CMU Serif" panose="02000603000000000000" pitchFamily="2" charset="0"/>
+              <a:cs typeface="CMU Serif" panose="02000603000000000000" pitchFamily="2" charset="0"/>
+            </a:endParaRPr>
+          </a:p>
+        </p:txBody>
+      </p:sp>
+      <p:sp>
+        <p:nvSpPr>
+          <p:cNvPr id="32" name="Rechteck 31">
+            <a:extLst>
+              <a:ext uri="{FF2B5EF4-FFF2-40B4-BE49-F238E27FC236}">
+                <a16:creationId xmlns:a16="http://schemas.microsoft.com/office/drawing/2014/main" id="{2358A122-876A-A83C-AB22-4D11FCC414A2}"/>
+              </a:ext>
+            </a:extLst>
+          </p:cNvPr>
+          <p:cNvSpPr/>
+          <p:nvPr/>
+        </p:nvSpPr>
+        <p:spPr>
+          <a:xfrm>
+            <a:off x="1507160" y="2379518"/>
+            <a:ext cx="1229679" cy="112991"/>
+          </a:xfrm>
+          <a:prstGeom prst="rect">
+            <a:avLst/>
+          </a:prstGeom>
+          <a:solidFill>
+            <a:schemeClr val="bg1">
+              <a:lumMod val="75000"/>
+            </a:schemeClr>
+          </a:solidFill>
+          <a:ln>
+            <a:noFill/>
+          </a:ln>
+        </p:spPr>
+        <p:style>
+          <a:lnRef idx="2">
+            <a:schemeClr val="accent1">
+              <a:shade val="15000"/>
+            </a:schemeClr>
+          </a:lnRef>
+          <a:fillRef idx="1">
+            <a:schemeClr val="accent1"/>
+          </a:fillRef>
+          <a:effectRef idx="0">
+            <a:schemeClr val="accent1"/>
+          </a:effectRef>
+          <a:fontRef idx="minor">
+            <a:schemeClr val="lt1"/>
+          </a:fontRef>
+        </p:style>
+        <p:txBody>
+          <a:bodyPr rtlCol="0" anchor="ctr"/>
+          <a:lstStyle/>
+          <a:p>
+            <a:pPr algn="ctr"/>
+            <a:endParaRPr lang="de-DE" sz="1200" dirty="0">
+              <a:solidFill>
+                <a:schemeClr val="tx1"/>
+              </a:solidFill>
+              <a:latin typeface="CMU Serif" panose="02000603000000000000" pitchFamily="2" charset="0"/>
+              <a:ea typeface="CMU Serif" panose="02000603000000000000" pitchFamily="2" charset="0"/>
+              <a:cs typeface="CMU Serif" panose="02000603000000000000" pitchFamily="2" charset="0"/>
+            </a:endParaRPr>
+          </a:p>
+        </p:txBody>
+      </p:sp>
+      <p:sp>
+        <p:nvSpPr>
+          <p:cNvPr id="33" name="Rechteck 32">
+            <a:extLst>
+              <a:ext uri="{FF2B5EF4-FFF2-40B4-BE49-F238E27FC236}">
+                <a16:creationId xmlns:a16="http://schemas.microsoft.com/office/drawing/2014/main" id="{F3E1572A-AEDA-4803-49AC-CA6BE2EE1911}"/>
+              </a:ext>
+            </a:extLst>
+          </p:cNvPr>
+          <p:cNvSpPr/>
+          <p:nvPr/>
+        </p:nvSpPr>
+        <p:spPr>
+          <a:xfrm>
+            <a:off x="1506856" y="1881357"/>
+            <a:ext cx="110490" cy="199317"/>
+          </a:xfrm>
+          <a:prstGeom prst="rect">
+            <a:avLst/>
+          </a:prstGeom>
+          <a:solidFill>
+            <a:schemeClr val="bg1">
+              <a:lumMod val="75000"/>
+            </a:schemeClr>
+          </a:solidFill>
+          <a:ln>
+            <a:noFill/>
+          </a:ln>
+        </p:spPr>
+        <p:style>
+          <a:lnRef idx="2">
+            <a:schemeClr val="accent1">
+              <a:shade val="15000"/>
+            </a:schemeClr>
+          </a:lnRef>
+          <a:fillRef idx="1">
+            <a:schemeClr val="accent1"/>
+          </a:fillRef>
+          <a:effectRef idx="0">
+            <a:schemeClr val="accent1"/>
+          </a:effectRef>
+          <a:fontRef idx="minor">
+            <a:schemeClr val="lt1"/>
+          </a:fontRef>
+        </p:style>
+        <p:txBody>
+          <a:bodyPr rtlCol="0" anchor="ctr"/>
+          <a:lstStyle/>
+          <a:p>
+            <a:pPr algn="ctr"/>
+            <a:endParaRPr lang="de-DE" sz="1200" dirty="0">
+              <a:solidFill>
+                <a:schemeClr val="tx1"/>
+              </a:solidFill>
+              <a:latin typeface="CMU Serif" panose="02000603000000000000" pitchFamily="2" charset="0"/>
+              <a:ea typeface="CMU Serif" panose="02000603000000000000" pitchFamily="2" charset="0"/>
+              <a:cs typeface="CMU Serif" panose="02000603000000000000" pitchFamily="2" charset="0"/>
+            </a:endParaRPr>
+          </a:p>
+        </p:txBody>
+      </p:sp>
+      <p:sp>
+        <p:nvSpPr>
+          <p:cNvPr id="34" name="Rechteck 33">
+            <a:extLst>
+              <a:ext uri="{FF2B5EF4-FFF2-40B4-BE49-F238E27FC236}">
+                <a16:creationId xmlns:a16="http://schemas.microsoft.com/office/drawing/2014/main" id="{2A7E7B11-8F34-FAF1-9B44-FAEC0ABF186B}"/>
+              </a:ext>
+            </a:extLst>
+          </p:cNvPr>
+          <p:cNvSpPr/>
+          <p:nvPr/>
+        </p:nvSpPr>
+        <p:spPr>
+          <a:xfrm>
+            <a:off x="1506855" y="2043047"/>
+            <a:ext cx="1229679" cy="112991"/>
+          </a:xfrm>
+          <a:prstGeom prst="rect">
+            <a:avLst/>
+          </a:prstGeom>
+          <a:solidFill>
+            <a:schemeClr val="bg1">
+              <a:lumMod val="75000"/>
+            </a:schemeClr>
+          </a:solidFill>
+          <a:ln>
+            <a:noFill/>
+          </a:ln>
+        </p:spPr>
+        <p:style>
+          <a:lnRef idx="2">
+            <a:schemeClr val="accent1">
+              <a:shade val="15000"/>
+            </a:schemeClr>
+          </a:lnRef>
+          <a:fillRef idx="1">
+            <a:schemeClr val="accent1"/>
+          </a:fillRef>
+          <a:effectRef idx="0">
+            <a:schemeClr val="accent1"/>
+          </a:effectRef>
+          <a:fontRef idx="minor">
+            <a:schemeClr val="lt1"/>
+          </a:fontRef>
+        </p:style>
+        <p:txBody>
+          <a:bodyPr rtlCol="0" anchor="ctr"/>
+          <a:lstStyle/>
+          <a:p>
+            <a:pPr algn="ctr"/>
+            <a:endParaRPr lang="de-DE" sz="1200" dirty="0">
+              <a:solidFill>
+                <a:schemeClr val="tx1"/>
+              </a:solidFill>
+              <a:latin typeface="CMU Serif" panose="02000603000000000000" pitchFamily="2" charset="0"/>
+              <a:ea typeface="CMU Serif" panose="02000603000000000000" pitchFamily="2" charset="0"/>
+              <a:cs typeface="CMU Serif" panose="02000603000000000000" pitchFamily="2" charset="0"/>
+            </a:endParaRPr>
+          </a:p>
+        </p:txBody>
+      </p:sp>
+      <p:cxnSp>
+        <p:nvCxnSpPr>
+          <p:cNvPr id="35" name="Gerader Verbinder 34">
+            <a:extLst>
+              <a:ext uri="{FF2B5EF4-FFF2-40B4-BE49-F238E27FC236}">
+                <a16:creationId xmlns:a16="http://schemas.microsoft.com/office/drawing/2014/main" id="{7FC7EDF0-A1E3-4BCE-FB98-AA91F7385287}"/>
+              </a:ext>
+            </a:extLst>
+          </p:cNvPr>
+          <p:cNvCxnSpPr>
+            <a:cxnSpLocks/>
+          </p:cNvCxnSpPr>
+          <p:nvPr/>
+        </p:nvCxnSpPr>
+        <p:spPr>
+          <a:xfrm flipH="1">
+            <a:off x="1286589" y="2155682"/>
+            <a:ext cx="1442324" cy="0"/>
+          </a:xfrm>
+          <a:prstGeom prst="line">
+            <a:avLst/>
+          </a:prstGeom>
+          <a:ln cap="rnd">
+            <a:solidFill>
+              <a:schemeClr val="tx1">
+                <a:lumMod val="75000"/>
+                <a:lumOff val="25000"/>
+              </a:schemeClr>
+            </a:solidFill>
+            <a:round/>
+          </a:ln>
+        </p:spPr>
+        <p:style>
+          <a:lnRef idx="2">
+            <a:schemeClr val="accent1"/>
+          </a:lnRef>
+          <a:fillRef idx="0">
+            <a:schemeClr val="accent1"/>
+          </a:fillRef>
+          <a:effectRef idx="1">
+            <a:schemeClr val="accent1"/>
+          </a:effectRef>
+          <a:fontRef idx="minor">
+            <a:schemeClr val="tx1"/>
+          </a:fontRef>
+        </p:style>
+      </p:cxnSp>
+      <p:cxnSp>
+        <p:nvCxnSpPr>
+          <p:cNvPr id="36" name="Gerader Verbinder 35">
+            <a:extLst>
+              <a:ext uri="{FF2B5EF4-FFF2-40B4-BE49-F238E27FC236}">
+                <a16:creationId xmlns:a16="http://schemas.microsoft.com/office/drawing/2014/main" id="{76A6C30D-C7DA-9241-B08B-BD947E75A222}"/>
+              </a:ext>
+            </a:extLst>
+          </p:cNvPr>
+          <p:cNvCxnSpPr>
+            <a:cxnSpLocks/>
+          </p:cNvCxnSpPr>
+          <p:nvPr/>
+        </p:nvCxnSpPr>
+        <p:spPr>
+          <a:xfrm flipH="1">
+            <a:off x="1286589" y="2379519"/>
+            <a:ext cx="1442324" cy="0"/>
+          </a:xfrm>
+          <a:prstGeom prst="line">
+            <a:avLst/>
+          </a:prstGeom>
+          <a:ln cap="rnd">
+            <a:solidFill>
+              <a:schemeClr val="tx1">
+                <a:lumMod val="75000"/>
+                <a:lumOff val="25000"/>
+              </a:schemeClr>
+            </a:solidFill>
+            <a:round/>
+          </a:ln>
+        </p:spPr>
+        <p:style>
+          <a:lnRef idx="2">
+            <a:schemeClr val="accent1"/>
+          </a:lnRef>
+          <a:fillRef idx="0">
+            <a:schemeClr val="accent1"/>
+          </a:fillRef>
+          <a:effectRef idx="1">
+            <a:schemeClr val="accent1"/>
+          </a:effectRef>
+          <a:fontRef idx="minor">
+            <a:schemeClr val="tx1"/>
+          </a:fontRef>
+        </p:style>
+      </p:cxnSp>
+      <p:cxnSp>
+        <p:nvCxnSpPr>
+          <p:cNvPr id="37" name="Gerader Verbinder 36">
+            <a:extLst>
+              <a:ext uri="{FF2B5EF4-FFF2-40B4-BE49-F238E27FC236}">
+                <a16:creationId xmlns:a16="http://schemas.microsoft.com/office/drawing/2014/main" id="{4E642497-5455-940D-B11D-1C56A13A3F98}"/>
+              </a:ext>
+            </a:extLst>
+          </p:cNvPr>
+          <p:cNvCxnSpPr>
+            <a:cxnSpLocks/>
+          </p:cNvCxnSpPr>
+          <p:nvPr/>
+        </p:nvCxnSpPr>
+        <p:spPr>
+          <a:xfrm flipV="1">
+            <a:off x="1507467" y="2379519"/>
+            <a:ext cx="0" cy="265984"/>
+          </a:xfrm>
+          <a:prstGeom prst="line">
+            <a:avLst/>
+          </a:prstGeom>
+          <a:ln cap="rnd">
+            <a:solidFill>
+              <a:schemeClr val="tx1">
+                <a:lumMod val="75000"/>
+                <a:lumOff val="25000"/>
+              </a:schemeClr>
+            </a:solidFill>
+            <a:round/>
+          </a:ln>
+        </p:spPr>
+        <p:style>
+          <a:lnRef idx="2">
+            <a:schemeClr val="accent1"/>
+          </a:lnRef>
+          <a:fillRef idx="0">
+            <a:schemeClr val="accent1"/>
+          </a:fillRef>
+          <a:effectRef idx="1">
+            <a:schemeClr val="accent1"/>
+          </a:effectRef>
+          <a:fontRef idx="minor">
+            <a:schemeClr val="tx1"/>
+          </a:fontRef>
+        </p:style>
+      </p:cxnSp>
+      <p:cxnSp>
+        <p:nvCxnSpPr>
+          <p:cNvPr id="38" name="Gerader Verbinder 37">
+            <a:extLst>
+              <a:ext uri="{FF2B5EF4-FFF2-40B4-BE49-F238E27FC236}">
+                <a16:creationId xmlns:a16="http://schemas.microsoft.com/office/drawing/2014/main" id="{0EBBACC5-D9EF-56B9-D615-DA2088076256}"/>
+              </a:ext>
+            </a:extLst>
+          </p:cNvPr>
+          <p:cNvCxnSpPr>
+            <a:cxnSpLocks/>
+          </p:cNvCxnSpPr>
+          <p:nvPr/>
+        </p:nvCxnSpPr>
+        <p:spPr>
+          <a:xfrm flipV="1">
+            <a:off x="1507467" y="1889698"/>
+            <a:ext cx="0" cy="265984"/>
+          </a:xfrm>
+          <a:prstGeom prst="line">
+            <a:avLst/>
+          </a:prstGeom>
+          <a:ln cap="rnd">
+            <a:solidFill>
+              <a:schemeClr val="tx1">
+                <a:lumMod val="75000"/>
+                <a:lumOff val="25000"/>
+              </a:schemeClr>
+            </a:solidFill>
+            <a:round/>
+          </a:ln>
+        </p:spPr>
+        <p:style>
+          <a:lnRef idx="2">
+            <a:schemeClr val="accent1"/>
+          </a:lnRef>
+          <a:fillRef idx="0">
+            <a:schemeClr val="accent1"/>
+          </a:fillRef>
+          <a:effectRef idx="1">
+            <a:schemeClr val="accent1"/>
+          </a:effectRef>
+          <a:fontRef idx="minor">
+            <a:schemeClr val="tx1"/>
+          </a:fontRef>
+        </p:style>
+      </p:cxnSp>
+      <p:cxnSp>
+        <p:nvCxnSpPr>
+          <p:cNvPr id="39" name="Gerader Verbinder 38">
+            <a:extLst>
+              <a:ext uri="{FF2B5EF4-FFF2-40B4-BE49-F238E27FC236}">
+                <a16:creationId xmlns:a16="http://schemas.microsoft.com/office/drawing/2014/main" id="{8848973A-E868-DA30-B509-89E771CA5F7A}"/>
+              </a:ext>
+            </a:extLst>
+          </p:cNvPr>
+          <p:cNvCxnSpPr>
+            <a:cxnSpLocks/>
+          </p:cNvCxnSpPr>
+          <p:nvPr/>
+        </p:nvCxnSpPr>
+        <p:spPr>
+          <a:xfrm flipH="1">
+            <a:off x="1225629" y="2272839"/>
+            <a:ext cx="1579245" cy="0"/>
+          </a:xfrm>
+          <a:prstGeom prst="line">
+            <a:avLst/>
+          </a:prstGeom>
+          <a:ln w="6350" cap="rnd">
+            <a:solidFill>
+              <a:schemeClr val="tx1">
+                <a:lumMod val="75000"/>
+                <a:lumOff val="25000"/>
+              </a:schemeClr>
+            </a:solidFill>
+            <a:prstDash val="lgDashDot"/>
+            <a:round/>
+          </a:ln>
+        </p:spPr>
+        <p:style>
+          <a:lnRef idx="2">
+            <a:schemeClr val="accent1"/>
+          </a:lnRef>
+          <a:fillRef idx="0">
+            <a:schemeClr val="accent1"/>
+          </a:fillRef>
+          <a:effectRef idx="1">
+            <a:schemeClr val="accent1"/>
+          </a:effectRef>
+          <a:fontRef idx="minor">
+            <a:schemeClr val="tx1"/>
+          </a:fontRef>
+        </p:style>
+      </p:cxnSp>
+      <p:cxnSp>
+        <p:nvCxnSpPr>
+          <p:cNvPr id="40" name="Gerade Verbindung mit Pfeil 39">
+            <a:extLst>
+              <a:ext uri="{FF2B5EF4-FFF2-40B4-BE49-F238E27FC236}">
+                <a16:creationId xmlns:a16="http://schemas.microsoft.com/office/drawing/2014/main" id="{37E1BA3B-2E2C-C9C7-0C39-0D85E6715FD4}"/>
+              </a:ext>
+            </a:extLst>
+          </p:cNvPr>
+          <p:cNvCxnSpPr>
+            <a:cxnSpLocks/>
+          </p:cNvCxnSpPr>
+          <p:nvPr/>
+        </p:nvCxnSpPr>
+        <p:spPr>
+          <a:xfrm>
+            <a:off x="1848808" y="2272839"/>
+            <a:ext cx="280982" cy="0"/>
+          </a:xfrm>
+          <a:prstGeom prst="straightConnector1">
+            <a:avLst/>
+          </a:prstGeom>
+          <a:ln w="19050" cap="rnd">
+            <a:solidFill>
+              <a:srgbClr val="0070C0"/>
+            </a:solidFill>
+            <a:round/>
+            <a:headEnd type="none"/>
+            <a:tailEnd type="triangle" w="med" len="med"/>
+          </a:ln>
+        </p:spPr>
+        <p:style>
+          <a:lnRef idx="2">
+            <a:schemeClr val="accent1"/>
+          </a:lnRef>
+          <a:fillRef idx="0">
+            <a:schemeClr val="accent1"/>
+          </a:fillRef>
+          <a:effectRef idx="1">
+            <a:schemeClr val="accent1"/>
+          </a:effectRef>
+          <a:fontRef idx="minor">
+            <a:schemeClr val="tx1"/>
+          </a:fontRef>
+        </p:style>
+      </p:cxnSp>
+      <p:grpSp>
+        <p:nvGrpSpPr>
+          <p:cNvPr id="41" name="Gruppieren 40">
+            <a:extLst>
+              <a:ext uri="{FF2B5EF4-FFF2-40B4-BE49-F238E27FC236}">
+                <a16:creationId xmlns:a16="http://schemas.microsoft.com/office/drawing/2014/main" id="{49C6C32A-04F6-E23C-077F-A8A2EAB0049D}"/>
+              </a:ext>
+            </a:extLst>
+          </p:cNvPr>
+          <p:cNvGrpSpPr/>
+          <p:nvPr/>
+        </p:nvGrpSpPr>
+        <p:grpSpPr>
+          <a:xfrm>
+            <a:off x="1683229" y="2462049"/>
+            <a:ext cx="358140" cy="306467"/>
+            <a:chOff x="1844040" y="1040959"/>
+            <a:chExt cx="358140" cy="306467"/>
+          </a:xfrm>
+        </p:grpSpPr>
+        <p:sp>
+          <p:nvSpPr>
+            <p:cNvPr id="42" name="Textfeld 41">
+              <a:extLst>
+                <a:ext uri="{FF2B5EF4-FFF2-40B4-BE49-F238E27FC236}">
+                  <a16:creationId xmlns:a16="http://schemas.microsoft.com/office/drawing/2014/main" id="{A65D745B-7FD3-994E-1178-EC7C7D324AD5}"/>
+                </a:ext>
+              </a:extLst>
+            </p:cNvPr>
+            <p:cNvSpPr txBox="1"/>
+            <p:nvPr/>
+          </p:nvSpPr>
+          <p:spPr>
+            <a:xfrm>
+              <a:off x="1844040" y="1040959"/>
+              <a:ext cx="358140" cy="306467"/>
+            </a:xfrm>
+            <a:prstGeom prst="roundRect">
+              <a:avLst>
+                <a:gd name="adj" fmla="val 22469"/>
+              </a:avLst>
+            </a:prstGeom>
+            <a:noFill/>
+          </p:spPr>
+          <p:txBody>
+            <a:bodyPr wrap="square" rtlCol="0" anchor="ctr">
+              <a:spAutoFit/>
+            </a:bodyPr>
+            <a:lstStyle/>
+            <a:p>
+              <a:pPr algn="ctr"/>
+              <a:r>
+                <a:rPr lang="de-DE" sz="1200" i="1" dirty="0" err="1">
+                  <a:solidFill>
+                    <a:srgbClr val="0070C0"/>
+                  </a:solidFill>
+                  <a:latin typeface="CMU Serif" panose="02000603000000000000" pitchFamily="2" charset="0"/>
+                  <a:ea typeface="CMU Serif" panose="02000603000000000000" pitchFamily="2" charset="0"/>
+                  <a:cs typeface="CMU Serif" panose="02000603000000000000" pitchFamily="2" charset="0"/>
+                </a:rPr>
+                <a:t>u</a:t>
+              </a:r>
+              <a:r>
+                <a:rPr lang="de-DE" sz="1200" i="1" baseline="-25000" dirty="0" err="1">
+                  <a:solidFill>
+                    <a:srgbClr val="0070C0"/>
+                  </a:solidFill>
+                  <a:latin typeface="Latin Modern Math" panose="02000503000000000000" pitchFamily="50" charset="0"/>
+                  <a:ea typeface="Latin Modern Math" panose="02000503000000000000" pitchFamily="50" charset="0"/>
+                  <a:cs typeface="CMU Serif" panose="02000603000000000000" pitchFamily="2" charset="0"/>
+                </a:rPr>
+                <a:t>ν</a:t>
+              </a:r>
+              <a:endParaRPr lang="de-DE" sz="1200" i="1" baseline="-25000" dirty="0">
+                <a:solidFill>
+                  <a:srgbClr val="0070C0"/>
+                </a:solidFill>
+                <a:latin typeface="Latin Modern Math" panose="02000503000000000000" pitchFamily="50" charset="0"/>
+                <a:ea typeface="Latin Modern Math" panose="02000503000000000000" pitchFamily="50" charset="0"/>
+                <a:cs typeface="CMU Serif" panose="02000603000000000000" pitchFamily="2" charset="0"/>
+              </a:endParaRPr>
+            </a:p>
+          </p:txBody>
+        </p:sp>
+        <p:cxnSp>
+          <p:nvCxnSpPr>
+            <p:cNvPr id="43" name="Gerade Verbindung mit Pfeil 42">
+              <a:extLst>
+                <a:ext uri="{FF2B5EF4-FFF2-40B4-BE49-F238E27FC236}">
+                  <a16:creationId xmlns:a16="http://schemas.microsoft.com/office/drawing/2014/main" id="{DF94ADCE-0F80-DF8B-57B9-6C38DEBBE18E}"/>
+                </a:ext>
+              </a:extLst>
+            </p:cNvPr>
+            <p:cNvCxnSpPr>
+              <a:cxnSpLocks/>
+            </p:cNvCxnSpPr>
+            <p:nvPr/>
+          </p:nvCxnSpPr>
+          <p:spPr>
+            <a:xfrm>
+              <a:off x="1986603" y="1145144"/>
+              <a:ext cx="50477" cy="0"/>
+            </a:xfrm>
+            <a:prstGeom prst="straightConnector1">
+              <a:avLst/>
+            </a:prstGeom>
+            <a:ln w="3175" cap="rnd">
+              <a:solidFill>
+                <a:srgbClr val="0070C0"/>
+              </a:solidFill>
+              <a:round/>
+              <a:headEnd type="none"/>
+              <a:tailEnd type="none" w="sm" len="med"/>
+            </a:ln>
+          </p:spPr>
+          <p:style>
+            <a:lnRef idx="2">
+              <a:schemeClr val="accent1"/>
+            </a:lnRef>
+            <a:fillRef idx="0">
+              <a:schemeClr val="accent1"/>
+            </a:fillRef>
+            <a:effectRef idx="1">
+              <a:schemeClr val="accent1"/>
+            </a:effectRef>
+            <a:fontRef idx="minor">
+              <a:schemeClr val="tx1"/>
+            </a:fontRef>
+          </p:style>
+        </p:cxnSp>
+      </p:grpSp>
+      <p:sp>
+        <p:nvSpPr>
+          <p:cNvPr id="48" name="Textfeld 47">
+            <a:extLst>
+              <a:ext uri="{FF2B5EF4-FFF2-40B4-BE49-F238E27FC236}">
+                <a16:creationId xmlns:a16="http://schemas.microsoft.com/office/drawing/2014/main" id="{47CF3BDA-28DA-D25F-27E7-4BFEE47602C5}"/>
+              </a:ext>
+            </a:extLst>
+          </p:cNvPr>
+          <p:cNvSpPr txBox="1"/>
+          <p:nvPr/>
+        </p:nvSpPr>
+        <p:spPr>
+          <a:xfrm>
+            <a:off x="818293" y="1166576"/>
+            <a:ext cx="423466" cy="317183"/>
+          </a:xfrm>
+          <a:prstGeom prst="roundRect">
+            <a:avLst>
+              <a:gd name="adj" fmla="val 22469"/>
+            </a:avLst>
+          </a:prstGeom>
+          <a:noFill/>
+        </p:spPr>
+        <p:txBody>
+          <a:bodyPr wrap="square" rtlCol="0" anchor="ctr">
+            <a:spAutoFit/>
+          </a:bodyPr>
+          <a:lstStyle/>
+          <a:p>
+            <a:pPr algn="ctr"/>
+            <a:r>
+              <a:rPr lang="de-DE" sz="1200" dirty="0">
+                <a:latin typeface="CMU Serif" panose="02000603000000000000" pitchFamily="2" charset="0"/>
+                <a:ea typeface="CMU Serif" panose="02000603000000000000" pitchFamily="2" charset="0"/>
+                <a:cs typeface="CMU Serif" panose="02000603000000000000" pitchFamily="2" charset="0"/>
+              </a:rPr>
+              <a:t>a)</a:t>
+            </a:r>
+            <a:endParaRPr lang="de-DE" sz="1200" i="1" baseline="-25000" dirty="0">
+              <a:latin typeface="Latin Modern Math" panose="02000503000000000000" pitchFamily="50" charset="0"/>
+              <a:ea typeface="Latin Modern Math" panose="02000503000000000000" pitchFamily="50" charset="0"/>
+              <a:cs typeface="CMU Serif" panose="02000603000000000000" pitchFamily="2" charset="0"/>
+            </a:endParaRPr>
+          </a:p>
+        </p:txBody>
+      </p:sp>
+      <p:sp>
+        <p:nvSpPr>
+          <p:cNvPr id="50" name="Textfeld 49">
+            <a:extLst>
+              <a:ext uri="{FF2B5EF4-FFF2-40B4-BE49-F238E27FC236}">
+                <a16:creationId xmlns:a16="http://schemas.microsoft.com/office/drawing/2014/main" id="{4D799618-EFF8-0A68-E989-84344A92B8E7}"/>
+              </a:ext>
+            </a:extLst>
+          </p:cNvPr>
+          <p:cNvSpPr txBox="1"/>
+          <p:nvPr/>
+        </p:nvSpPr>
+        <p:spPr>
+          <a:xfrm>
+            <a:off x="818293" y="2119149"/>
+            <a:ext cx="423466" cy="317183"/>
+          </a:xfrm>
+          <a:prstGeom prst="roundRect">
+            <a:avLst>
+              <a:gd name="adj" fmla="val 22469"/>
+            </a:avLst>
+          </a:prstGeom>
+          <a:noFill/>
+        </p:spPr>
+        <p:txBody>
+          <a:bodyPr wrap="square" rtlCol="0" anchor="ctr">
+            <a:spAutoFit/>
+          </a:bodyPr>
+          <a:lstStyle/>
+          <a:p>
+            <a:pPr algn="ctr"/>
+            <a:r>
+              <a:rPr lang="de-DE" sz="1200" dirty="0">
+                <a:latin typeface="CMU Serif" panose="02000603000000000000" pitchFamily="2" charset="0"/>
+                <a:ea typeface="CMU Serif" panose="02000603000000000000" pitchFamily="2" charset="0"/>
+                <a:cs typeface="CMU Serif" panose="02000603000000000000" pitchFamily="2" charset="0"/>
+              </a:rPr>
+              <a:t>b)</a:t>
+            </a:r>
+            <a:endParaRPr lang="de-DE" sz="1200" i="1" baseline="-25000" dirty="0">
+              <a:latin typeface="Latin Modern Math" panose="02000503000000000000" pitchFamily="50" charset="0"/>
+              <a:ea typeface="Latin Modern Math" panose="02000503000000000000" pitchFamily="50" charset="0"/>
+              <a:cs typeface="CMU Serif" panose="02000603000000000000" pitchFamily="2" charset="0"/>
+            </a:endParaRPr>
+          </a:p>
+        </p:txBody>
+      </p:sp>
+      <p:cxnSp>
+        <p:nvCxnSpPr>
+          <p:cNvPr id="57" name="Gerade Verbindung mit Pfeil 56">
+            <a:extLst>
+              <a:ext uri="{FF2B5EF4-FFF2-40B4-BE49-F238E27FC236}">
+                <a16:creationId xmlns:a16="http://schemas.microsoft.com/office/drawing/2014/main" id="{99AD5BF6-3470-4027-837C-3A739180A6A1}"/>
+              </a:ext>
+            </a:extLst>
+          </p:cNvPr>
+          <p:cNvCxnSpPr>
+            <a:cxnSpLocks/>
+          </p:cNvCxnSpPr>
+          <p:nvPr/>
+        </p:nvCxnSpPr>
+        <p:spPr>
+          <a:xfrm flipV="1">
+            <a:off x="1911429" y="2272839"/>
+            <a:ext cx="77870" cy="281525"/>
+          </a:xfrm>
+          <a:prstGeom prst="straightConnector1">
+            <a:avLst/>
+          </a:prstGeom>
+          <a:ln w="6350" cap="rnd">
+            <a:solidFill>
+              <a:srgbClr val="0070C0"/>
+            </a:solidFill>
+            <a:round/>
+            <a:headEnd type="none"/>
+            <a:tailEnd type="none" w="med" len="med"/>
+          </a:ln>
+        </p:spPr>
+        <p:style>
+          <a:lnRef idx="2">
+            <a:schemeClr val="accent1"/>
+          </a:lnRef>
+          <a:fillRef idx="0">
+            <a:schemeClr val="accent1"/>
+          </a:fillRef>
+          <a:effectRef idx="1">
+            <a:schemeClr val="accent1"/>
+          </a:effectRef>
+          <a:fontRef idx="minor">
+            <a:schemeClr val="tx1"/>
+          </a:fontRef>
+        </p:style>
+      </p:cxnSp>
+      <p:cxnSp>
+        <p:nvCxnSpPr>
+          <p:cNvPr id="60" name="Gerade Verbindung mit Pfeil 59">
+            <a:extLst>
+              <a:ext uri="{FF2B5EF4-FFF2-40B4-BE49-F238E27FC236}">
+                <a16:creationId xmlns:a16="http://schemas.microsoft.com/office/drawing/2014/main" id="{F1423DC1-2C7C-8F6F-5AA6-363466AA3FD1}"/>
+              </a:ext>
+            </a:extLst>
+          </p:cNvPr>
+          <p:cNvCxnSpPr>
+            <a:cxnSpLocks/>
+          </p:cNvCxnSpPr>
+          <p:nvPr/>
+        </p:nvCxnSpPr>
+        <p:spPr>
+          <a:xfrm flipV="1">
+            <a:off x="1913414" y="1325506"/>
+            <a:ext cx="77870" cy="281525"/>
+          </a:xfrm>
+          <a:prstGeom prst="straightConnector1">
+            <a:avLst/>
+          </a:prstGeom>
+          <a:ln w="6350" cap="rnd">
+            <a:solidFill>
+              <a:srgbClr val="0070C0"/>
+            </a:solidFill>
+            <a:round/>
+            <a:headEnd type="none"/>
+            <a:tailEnd type="none" w="med" len="med"/>
+          </a:ln>
+        </p:spPr>
+        <p:style>
+          <a:lnRef idx="2">
+            <a:schemeClr val="accent1"/>
+          </a:lnRef>
+          <a:fillRef idx="0">
+            <a:schemeClr val="accent1"/>
+          </a:fillRef>
+          <a:effectRef idx="1">
+            <a:schemeClr val="accent1"/>
+          </a:effectRef>
+          <a:fontRef idx="minor">
+            <a:schemeClr val="tx1"/>
+          </a:fontRef>
+        </p:style>
+      </p:cxnSp>
     </p:spTree>
     <p:extLst>
       <p:ext uri="{BB962C8B-B14F-4D97-AF65-F5344CB8AC3E}">
         <p14:creationId xmlns:p14="http://schemas.microsoft.com/office/powerpoint/2010/main" val="3411843301"/>
+      </p:ext>
+    </p:extLst>
+  </p:cSld>
+  <p:clrMapOvr>
+    <a:masterClrMapping/>
+  </p:clrMapOvr>
+</p:sld>
+</file>
+
+<file path=ppt/slides/slide14.xml><?xml version="1.0" encoding="utf-8"?>
+<p:sld xmlns:a="http://schemas.openxmlformats.org/drawingml/2006/main" xmlns:r="http://schemas.openxmlformats.org/officeDocument/2006/relationships" xmlns:p="http://schemas.openxmlformats.org/presentationml/2006/main">
+  <p:cSld>
+    <p:spTree>
+      <p:nvGrpSpPr>
+        <p:cNvPr id="1" name=""/>
+        <p:cNvGrpSpPr/>
+        <p:nvPr/>
+      </p:nvGrpSpPr>
+      <p:grpSpPr>
+        <a:xfrm>
+          <a:off x="0" y="0"/>
+          <a:ext cx="0" cy="0"/>
+          <a:chOff x="0" y="0"/>
+          <a:chExt cx="0" cy="0"/>
+        </a:xfrm>
+      </p:grpSpPr>
+      <p:grpSp>
+        <p:nvGrpSpPr>
+          <p:cNvPr id="19" name="Gruppieren 18">
+            <a:extLst>
+              <a:ext uri="{FF2B5EF4-FFF2-40B4-BE49-F238E27FC236}">
+                <a16:creationId xmlns:a16="http://schemas.microsoft.com/office/drawing/2014/main" id="{708520DE-AF35-D13A-CDBB-0BE7470DE7B9}"/>
+              </a:ext>
+            </a:extLst>
+          </p:cNvPr>
+          <p:cNvGrpSpPr/>
+          <p:nvPr/>
+        </p:nvGrpSpPr>
+        <p:grpSpPr>
+          <a:xfrm rot="10800000">
+            <a:off x="1185233" y="1462324"/>
+            <a:ext cx="1229984" cy="775100"/>
+            <a:chOff x="1506855" y="933686"/>
+            <a:chExt cx="1229984" cy="775100"/>
+          </a:xfrm>
+        </p:grpSpPr>
+        <p:sp>
+          <p:nvSpPr>
+            <p:cNvPr id="4" name="Rechteck 3">
+              <a:extLst>
+                <a:ext uri="{FF2B5EF4-FFF2-40B4-BE49-F238E27FC236}">
+                  <a16:creationId xmlns:a16="http://schemas.microsoft.com/office/drawing/2014/main" id="{B3ED69FF-47A9-30EA-A82F-C193C9ED7AD5}"/>
+                </a:ext>
+              </a:extLst>
+            </p:cNvPr>
+            <p:cNvSpPr/>
+            <p:nvPr/>
+          </p:nvSpPr>
+          <p:spPr>
+            <a:xfrm>
+              <a:off x="1506856" y="1506856"/>
+              <a:ext cx="110490" cy="201930"/>
+            </a:xfrm>
+            <a:prstGeom prst="rect">
+              <a:avLst/>
+            </a:prstGeom>
+            <a:solidFill>
+              <a:schemeClr val="bg1">
+                <a:lumMod val="75000"/>
+              </a:schemeClr>
+            </a:solidFill>
+            <a:ln>
+              <a:noFill/>
+            </a:ln>
+          </p:spPr>
+          <p:style>
+            <a:lnRef idx="2">
+              <a:schemeClr val="accent1">
+                <a:shade val="15000"/>
+              </a:schemeClr>
+            </a:lnRef>
+            <a:fillRef idx="1">
+              <a:schemeClr val="accent1"/>
+            </a:fillRef>
+            <a:effectRef idx="0">
+              <a:schemeClr val="accent1"/>
+            </a:effectRef>
+            <a:fontRef idx="minor">
+              <a:schemeClr val="lt1"/>
+            </a:fontRef>
+          </p:style>
+          <p:txBody>
+            <a:bodyPr rtlCol="0" anchor="ctr"/>
+            <a:lstStyle/>
+            <a:p>
+              <a:pPr algn="ctr"/>
+              <a:endParaRPr lang="de-DE" sz="1200" dirty="0">
+                <a:solidFill>
+                  <a:schemeClr val="tx1"/>
+                </a:solidFill>
+                <a:latin typeface="CMU Serif" panose="02000603000000000000" pitchFamily="2" charset="0"/>
+                <a:ea typeface="CMU Serif" panose="02000603000000000000" pitchFamily="2" charset="0"/>
+                <a:cs typeface="CMU Serif" panose="02000603000000000000" pitchFamily="2" charset="0"/>
+              </a:endParaRPr>
+            </a:p>
+          </p:txBody>
+        </p:sp>
+        <p:sp>
+          <p:nvSpPr>
+            <p:cNvPr id="5" name="Rechteck 4">
+              <a:extLst>
+                <a:ext uri="{FF2B5EF4-FFF2-40B4-BE49-F238E27FC236}">
+                  <a16:creationId xmlns:a16="http://schemas.microsoft.com/office/drawing/2014/main" id="{146B535C-1B6D-3B9E-CF66-1B41C5D2A14E}"/>
+                </a:ext>
+              </a:extLst>
+            </p:cNvPr>
+            <p:cNvSpPr/>
+            <p:nvPr/>
+          </p:nvSpPr>
+          <p:spPr>
+            <a:xfrm>
+              <a:off x="1507160" y="1431847"/>
+              <a:ext cx="1229679" cy="112991"/>
+            </a:xfrm>
+            <a:prstGeom prst="rect">
+              <a:avLst/>
+            </a:prstGeom>
+            <a:solidFill>
+              <a:schemeClr val="bg1">
+                <a:lumMod val="75000"/>
+              </a:schemeClr>
+            </a:solidFill>
+            <a:ln>
+              <a:noFill/>
+            </a:ln>
+          </p:spPr>
+          <p:style>
+            <a:lnRef idx="2">
+              <a:schemeClr val="accent1">
+                <a:shade val="15000"/>
+              </a:schemeClr>
+            </a:lnRef>
+            <a:fillRef idx="1">
+              <a:schemeClr val="accent1"/>
+            </a:fillRef>
+            <a:effectRef idx="0">
+              <a:schemeClr val="accent1"/>
+            </a:effectRef>
+            <a:fontRef idx="minor">
+              <a:schemeClr val="lt1"/>
+            </a:fontRef>
+          </p:style>
+          <p:txBody>
+            <a:bodyPr rtlCol="0" anchor="ctr"/>
+            <a:lstStyle/>
+            <a:p>
+              <a:pPr algn="ctr"/>
+              <a:endParaRPr lang="de-DE" sz="1200" dirty="0">
+                <a:solidFill>
+                  <a:schemeClr val="tx1"/>
+                </a:solidFill>
+                <a:latin typeface="CMU Serif" panose="02000603000000000000" pitchFamily="2" charset="0"/>
+                <a:ea typeface="CMU Serif" panose="02000603000000000000" pitchFamily="2" charset="0"/>
+                <a:cs typeface="CMU Serif" panose="02000603000000000000" pitchFamily="2" charset="0"/>
+              </a:endParaRPr>
+            </a:p>
+          </p:txBody>
+        </p:sp>
+        <p:sp>
+          <p:nvSpPr>
+            <p:cNvPr id="6" name="Rechteck 5">
+              <a:extLst>
+                <a:ext uri="{FF2B5EF4-FFF2-40B4-BE49-F238E27FC236}">
+                  <a16:creationId xmlns:a16="http://schemas.microsoft.com/office/drawing/2014/main" id="{00005C7F-7185-6C29-E015-322ABB472284}"/>
+                </a:ext>
+              </a:extLst>
+            </p:cNvPr>
+            <p:cNvSpPr/>
+            <p:nvPr/>
+          </p:nvSpPr>
+          <p:spPr>
+            <a:xfrm>
+              <a:off x="1506856" y="933686"/>
+              <a:ext cx="110490" cy="199317"/>
+            </a:xfrm>
+            <a:prstGeom prst="rect">
+              <a:avLst/>
+            </a:prstGeom>
+            <a:solidFill>
+              <a:schemeClr val="bg1">
+                <a:lumMod val="75000"/>
+              </a:schemeClr>
+            </a:solidFill>
+            <a:ln>
+              <a:noFill/>
+            </a:ln>
+          </p:spPr>
+          <p:style>
+            <a:lnRef idx="2">
+              <a:schemeClr val="accent1">
+                <a:shade val="15000"/>
+              </a:schemeClr>
+            </a:lnRef>
+            <a:fillRef idx="1">
+              <a:schemeClr val="accent1"/>
+            </a:fillRef>
+            <a:effectRef idx="0">
+              <a:schemeClr val="accent1"/>
+            </a:effectRef>
+            <a:fontRef idx="minor">
+              <a:schemeClr val="lt1"/>
+            </a:fontRef>
+          </p:style>
+          <p:txBody>
+            <a:bodyPr rtlCol="0" anchor="ctr"/>
+            <a:lstStyle/>
+            <a:p>
+              <a:pPr algn="ctr"/>
+              <a:endParaRPr lang="de-DE" sz="1200" dirty="0">
+                <a:solidFill>
+                  <a:schemeClr val="tx1"/>
+                </a:solidFill>
+                <a:latin typeface="CMU Serif" panose="02000603000000000000" pitchFamily="2" charset="0"/>
+                <a:ea typeface="CMU Serif" panose="02000603000000000000" pitchFamily="2" charset="0"/>
+                <a:cs typeface="CMU Serif" panose="02000603000000000000" pitchFamily="2" charset="0"/>
+              </a:endParaRPr>
+            </a:p>
+          </p:txBody>
+        </p:sp>
+        <p:sp>
+          <p:nvSpPr>
+            <p:cNvPr id="7" name="Rechteck 6">
+              <a:extLst>
+                <a:ext uri="{FF2B5EF4-FFF2-40B4-BE49-F238E27FC236}">
+                  <a16:creationId xmlns:a16="http://schemas.microsoft.com/office/drawing/2014/main" id="{DF4C3646-2B81-2868-CCCB-51E15D5C68F7}"/>
+                </a:ext>
+              </a:extLst>
+            </p:cNvPr>
+            <p:cNvSpPr/>
+            <p:nvPr/>
+          </p:nvSpPr>
+          <p:spPr>
+            <a:xfrm>
+              <a:off x="1506855" y="1095376"/>
+              <a:ext cx="1229679" cy="112991"/>
+            </a:xfrm>
+            <a:prstGeom prst="rect">
+              <a:avLst/>
+            </a:prstGeom>
+            <a:solidFill>
+              <a:schemeClr val="bg1">
+                <a:lumMod val="75000"/>
+              </a:schemeClr>
+            </a:solidFill>
+            <a:ln>
+              <a:noFill/>
+            </a:ln>
+          </p:spPr>
+          <p:style>
+            <a:lnRef idx="2">
+              <a:schemeClr val="accent1">
+                <a:shade val="15000"/>
+              </a:schemeClr>
+            </a:lnRef>
+            <a:fillRef idx="1">
+              <a:schemeClr val="accent1"/>
+            </a:fillRef>
+            <a:effectRef idx="0">
+              <a:schemeClr val="accent1"/>
+            </a:effectRef>
+            <a:fontRef idx="minor">
+              <a:schemeClr val="lt1"/>
+            </a:fontRef>
+          </p:style>
+          <p:txBody>
+            <a:bodyPr rtlCol="0" anchor="ctr"/>
+            <a:lstStyle/>
+            <a:p>
+              <a:pPr algn="ctr"/>
+              <a:endParaRPr lang="de-DE" sz="1200" dirty="0">
+                <a:solidFill>
+                  <a:schemeClr val="tx1"/>
+                </a:solidFill>
+                <a:latin typeface="CMU Serif" panose="02000603000000000000" pitchFamily="2" charset="0"/>
+                <a:ea typeface="CMU Serif" panose="02000603000000000000" pitchFamily="2" charset="0"/>
+                <a:cs typeface="CMU Serif" panose="02000603000000000000" pitchFamily="2" charset="0"/>
+              </a:endParaRPr>
+            </a:p>
+          </p:txBody>
+        </p:sp>
+        <p:cxnSp>
+          <p:nvCxnSpPr>
+            <p:cNvPr id="8" name="Gerader Verbinder 7">
+              <a:extLst>
+                <a:ext uri="{FF2B5EF4-FFF2-40B4-BE49-F238E27FC236}">
+                  <a16:creationId xmlns:a16="http://schemas.microsoft.com/office/drawing/2014/main" id="{D1C96D87-321B-6F0A-5512-77984F246263}"/>
+                </a:ext>
+              </a:extLst>
+            </p:cNvPr>
+            <p:cNvCxnSpPr>
+              <a:cxnSpLocks/>
+            </p:cNvCxnSpPr>
+            <p:nvPr/>
+          </p:nvCxnSpPr>
+          <p:spPr>
+            <a:xfrm flipH="1">
+              <a:off x="1507467" y="1208011"/>
+              <a:ext cx="1221446" cy="0"/>
+            </a:xfrm>
+            <a:prstGeom prst="line">
+              <a:avLst/>
+            </a:prstGeom>
+            <a:ln cap="rnd">
+              <a:solidFill>
+                <a:schemeClr val="tx1">
+                  <a:lumMod val="75000"/>
+                  <a:lumOff val="25000"/>
+                </a:schemeClr>
+              </a:solidFill>
+              <a:round/>
+            </a:ln>
+          </p:spPr>
+          <p:style>
+            <a:lnRef idx="2">
+              <a:schemeClr val="accent1"/>
+            </a:lnRef>
+            <a:fillRef idx="0">
+              <a:schemeClr val="accent1"/>
+            </a:fillRef>
+            <a:effectRef idx="1">
+              <a:schemeClr val="accent1"/>
+            </a:effectRef>
+            <a:fontRef idx="minor">
+              <a:schemeClr val="tx1"/>
+            </a:fontRef>
+          </p:style>
+        </p:cxnSp>
+        <p:cxnSp>
+          <p:nvCxnSpPr>
+            <p:cNvPr id="9" name="Gerader Verbinder 8">
+              <a:extLst>
+                <a:ext uri="{FF2B5EF4-FFF2-40B4-BE49-F238E27FC236}">
+                  <a16:creationId xmlns:a16="http://schemas.microsoft.com/office/drawing/2014/main" id="{A752523C-8D5D-3831-74CB-ECDE237DD8EA}"/>
+                </a:ext>
+              </a:extLst>
+            </p:cNvPr>
+            <p:cNvCxnSpPr>
+              <a:cxnSpLocks/>
+            </p:cNvCxnSpPr>
+            <p:nvPr/>
+          </p:nvCxnSpPr>
+          <p:spPr>
+            <a:xfrm flipH="1">
+              <a:off x="1507467" y="1431848"/>
+              <a:ext cx="1221446" cy="0"/>
+            </a:xfrm>
+            <a:prstGeom prst="line">
+              <a:avLst/>
+            </a:prstGeom>
+            <a:ln cap="rnd">
+              <a:solidFill>
+                <a:schemeClr val="tx1">
+                  <a:lumMod val="75000"/>
+                  <a:lumOff val="25000"/>
+                </a:schemeClr>
+              </a:solidFill>
+              <a:round/>
+            </a:ln>
+          </p:spPr>
+          <p:style>
+            <a:lnRef idx="2">
+              <a:schemeClr val="accent1"/>
+            </a:lnRef>
+            <a:fillRef idx="0">
+              <a:schemeClr val="accent1"/>
+            </a:fillRef>
+            <a:effectRef idx="1">
+              <a:schemeClr val="accent1"/>
+            </a:effectRef>
+            <a:fontRef idx="minor">
+              <a:schemeClr val="tx1"/>
+            </a:fontRef>
+          </p:style>
+        </p:cxnSp>
+        <p:cxnSp>
+          <p:nvCxnSpPr>
+            <p:cNvPr id="10" name="Gerader Verbinder 9">
+              <a:extLst>
+                <a:ext uri="{FF2B5EF4-FFF2-40B4-BE49-F238E27FC236}">
+                  <a16:creationId xmlns:a16="http://schemas.microsoft.com/office/drawing/2014/main" id="{47285617-9CE9-CC59-E1A1-D869A0D91EFD}"/>
+                </a:ext>
+              </a:extLst>
+            </p:cNvPr>
+            <p:cNvCxnSpPr>
+              <a:cxnSpLocks/>
+            </p:cNvCxnSpPr>
+            <p:nvPr/>
+          </p:nvCxnSpPr>
+          <p:spPr>
+            <a:xfrm flipV="1">
+              <a:off x="1507467" y="1431848"/>
+              <a:ext cx="0" cy="265984"/>
+            </a:xfrm>
+            <a:prstGeom prst="line">
+              <a:avLst/>
+            </a:prstGeom>
+            <a:ln cap="rnd">
+              <a:solidFill>
+                <a:schemeClr val="tx1">
+                  <a:lumMod val="75000"/>
+                  <a:lumOff val="25000"/>
+                </a:schemeClr>
+              </a:solidFill>
+              <a:round/>
+            </a:ln>
+          </p:spPr>
+          <p:style>
+            <a:lnRef idx="2">
+              <a:schemeClr val="accent1"/>
+            </a:lnRef>
+            <a:fillRef idx="0">
+              <a:schemeClr val="accent1"/>
+            </a:fillRef>
+            <a:effectRef idx="1">
+              <a:schemeClr val="accent1"/>
+            </a:effectRef>
+            <a:fontRef idx="minor">
+              <a:schemeClr val="tx1"/>
+            </a:fontRef>
+          </p:style>
+        </p:cxnSp>
+        <p:cxnSp>
+          <p:nvCxnSpPr>
+            <p:cNvPr id="11" name="Gerader Verbinder 10">
+              <a:extLst>
+                <a:ext uri="{FF2B5EF4-FFF2-40B4-BE49-F238E27FC236}">
+                  <a16:creationId xmlns:a16="http://schemas.microsoft.com/office/drawing/2014/main" id="{F822A7A8-D520-82FC-73F6-03FF5476B978}"/>
+                </a:ext>
+              </a:extLst>
+            </p:cNvPr>
+            <p:cNvCxnSpPr>
+              <a:cxnSpLocks/>
+            </p:cNvCxnSpPr>
+            <p:nvPr/>
+          </p:nvCxnSpPr>
+          <p:spPr>
+            <a:xfrm flipV="1">
+              <a:off x="1507467" y="942027"/>
+              <a:ext cx="0" cy="265984"/>
+            </a:xfrm>
+            <a:prstGeom prst="line">
+              <a:avLst/>
+            </a:prstGeom>
+            <a:ln cap="rnd">
+              <a:solidFill>
+                <a:schemeClr val="tx1">
+                  <a:lumMod val="75000"/>
+                  <a:lumOff val="25000"/>
+                </a:schemeClr>
+              </a:solidFill>
+              <a:round/>
+            </a:ln>
+          </p:spPr>
+          <p:style>
+            <a:lnRef idx="2">
+              <a:schemeClr val="accent1"/>
+            </a:lnRef>
+            <a:fillRef idx="0">
+              <a:schemeClr val="accent1"/>
+            </a:fillRef>
+            <a:effectRef idx="1">
+              <a:schemeClr val="accent1"/>
+            </a:effectRef>
+            <a:fontRef idx="minor">
+              <a:schemeClr val="tx1"/>
+            </a:fontRef>
+          </p:style>
+        </p:cxnSp>
+      </p:grpSp>
+      <p:cxnSp>
+        <p:nvCxnSpPr>
+          <p:cNvPr id="12" name="Gerader Verbinder 11">
+            <a:extLst>
+              <a:ext uri="{FF2B5EF4-FFF2-40B4-BE49-F238E27FC236}">
+                <a16:creationId xmlns:a16="http://schemas.microsoft.com/office/drawing/2014/main" id="{BD5C2685-D437-D195-9766-8DE781FA1A95}"/>
+              </a:ext>
+            </a:extLst>
+          </p:cNvPr>
+          <p:cNvCxnSpPr>
+            <a:cxnSpLocks/>
+          </p:cNvCxnSpPr>
+          <p:nvPr/>
+        </p:nvCxnSpPr>
+        <p:spPr>
+          <a:xfrm flipH="1">
+            <a:off x="1104032" y="1853806"/>
+            <a:ext cx="1377315" cy="0"/>
+          </a:xfrm>
+          <a:prstGeom prst="line">
+            <a:avLst/>
+          </a:prstGeom>
+          <a:ln w="6350" cap="rnd">
+            <a:solidFill>
+              <a:schemeClr val="tx1">
+                <a:lumMod val="75000"/>
+                <a:lumOff val="25000"/>
+              </a:schemeClr>
+            </a:solidFill>
+            <a:prstDash val="lgDashDot"/>
+            <a:round/>
+          </a:ln>
+        </p:spPr>
+        <p:style>
+          <a:lnRef idx="2">
+            <a:schemeClr val="accent1"/>
+          </a:lnRef>
+          <a:fillRef idx="0">
+            <a:schemeClr val="accent1"/>
+          </a:fillRef>
+          <a:effectRef idx="1">
+            <a:schemeClr val="accent1"/>
+          </a:effectRef>
+          <a:fontRef idx="minor">
+            <a:schemeClr val="tx1"/>
+          </a:fontRef>
+        </p:style>
+      </p:cxnSp>
+      <p:cxnSp>
+        <p:nvCxnSpPr>
+          <p:cNvPr id="13" name="Gerade Verbindung mit Pfeil 12">
+            <a:extLst>
+              <a:ext uri="{FF2B5EF4-FFF2-40B4-BE49-F238E27FC236}">
+                <a16:creationId xmlns:a16="http://schemas.microsoft.com/office/drawing/2014/main" id="{1E67608E-EE8F-BADB-8991-8B8B166229DD}"/>
+              </a:ext>
+            </a:extLst>
+          </p:cNvPr>
+          <p:cNvCxnSpPr>
+            <a:cxnSpLocks/>
+          </p:cNvCxnSpPr>
+          <p:nvPr/>
+        </p:nvCxnSpPr>
+        <p:spPr>
+          <a:xfrm>
+            <a:off x="1527186" y="1853806"/>
+            <a:ext cx="280982" cy="0"/>
+          </a:xfrm>
+          <a:prstGeom prst="straightConnector1">
+            <a:avLst/>
+          </a:prstGeom>
+          <a:ln w="19050" cap="rnd">
+            <a:solidFill>
+              <a:srgbClr val="0070C0"/>
+            </a:solidFill>
+            <a:round/>
+            <a:headEnd type="none"/>
+            <a:tailEnd type="triangle" w="med" len="med"/>
+          </a:ln>
+        </p:spPr>
+        <p:style>
+          <a:lnRef idx="2">
+            <a:schemeClr val="accent1"/>
+          </a:lnRef>
+          <a:fillRef idx="0">
+            <a:schemeClr val="accent1"/>
+          </a:fillRef>
+          <a:effectRef idx="1">
+            <a:schemeClr val="accent1"/>
+          </a:effectRef>
+          <a:fontRef idx="minor">
+            <a:schemeClr val="tx1"/>
+          </a:fontRef>
+        </p:style>
+      </p:cxnSp>
+      <p:grpSp>
+        <p:nvGrpSpPr>
+          <p:cNvPr id="14" name="Gruppieren 13">
+            <a:extLst>
+              <a:ext uri="{FF2B5EF4-FFF2-40B4-BE49-F238E27FC236}">
+                <a16:creationId xmlns:a16="http://schemas.microsoft.com/office/drawing/2014/main" id="{95586576-0C78-6C78-340C-B4C2B6191697}"/>
+              </a:ext>
+            </a:extLst>
+          </p:cNvPr>
+          <p:cNvGrpSpPr/>
+          <p:nvPr/>
+        </p:nvGrpSpPr>
+        <p:grpSpPr>
+          <a:xfrm>
+            <a:off x="1361607" y="2046588"/>
+            <a:ext cx="358140" cy="306467"/>
+            <a:chOff x="1844040" y="1040959"/>
+            <a:chExt cx="358140" cy="306467"/>
+          </a:xfrm>
+        </p:grpSpPr>
+        <p:sp>
+          <p:nvSpPr>
+            <p:cNvPr id="15" name="Textfeld 14">
+              <a:extLst>
+                <a:ext uri="{FF2B5EF4-FFF2-40B4-BE49-F238E27FC236}">
+                  <a16:creationId xmlns:a16="http://schemas.microsoft.com/office/drawing/2014/main" id="{19863AC7-B846-7C58-15EB-5AA72A9B9709}"/>
+                </a:ext>
+              </a:extLst>
+            </p:cNvPr>
+            <p:cNvSpPr txBox="1"/>
+            <p:nvPr/>
+          </p:nvSpPr>
+          <p:spPr>
+            <a:xfrm>
+              <a:off x="1844040" y="1040959"/>
+              <a:ext cx="358140" cy="306467"/>
+            </a:xfrm>
+            <a:prstGeom prst="roundRect">
+              <a:avLst>
+                <a:gd name="adj" fmla="val 22469"/>
+              </a:avLst>
+            </a:prstGeom>
+            <a:noFill/>
+          </p:spPr>
+          <p:txBody>
+            <a:bodyPr wrap="square" rtlCol="0" anchor="ctr">
+              <a:spAutoFit/>
+            </a:bodyPr>
+            <a:lstStyle/>
+            <a:p>
+              <a:pPr algn="ctr"/>
+              <a:r>
+                <a:rPr lang="de-DE" sz="1200" i="1" dirty="0" err="1">
+                  <a:solidFill>
+                    <a:srgbClr val="0070C0"/>
+                  </a:solidFill>
+                  <a:latin typeface="CMU Serif" panose="02000603000000000000" pitchFamily="2" charset="0"/>
+                  <a:ea typeface="CMU Serif" panose="02000603000000000000" pitchFamily="2" charset="0"/>
+                  <a:cs typeface="CMU Serif" panose="02000603000000000000" pitchFamily="2" charset="0"/>
+                </a:rPr>
+                <a:t>u</a:t>
+              </a:r>
+              <a:r>
+                <a:rPr lang="de-DE" sz="1200" i="1" baseline="-25000" dirty="0" err="1">
+                  <a:solidFill>
+                    <a:srgbClr val="0070C0"/>
+                  </a:solidFill>
+                  <a:latin typeface="Latin Modern Math" panose="02000503000000000000" pitchFamily="50" charset="0"/>
+                  <a:ea typeface="Latin Modern Math" panose="02000503000000000000" pitchFamily="50" charset="0"/>
+                  <a:cs typeface="CMU Serif" panose="02000603000000000000" pitchFamily="2" charset="0"/>
+                </a:rPr>
+                <a:t>ν</a:t>
+              </a:r>
+              <a:endParaRPr lang="de-DE" sz="1200" i="1" baseline="-25000" dirty="0">
+                <a:solidFill>
+                  <a:srgbClr val="0070C0"/>
+                </a:solidFill>
+                <a:latin typeface="Latin Modern Math" panose="02000503000000000000" pitchFamily="50" charset="0"/>
+                <a:ea typeface="Latin Modern Math" panose="02000503000000000000" pitchFamily="50" charset="0"/>
+                <a:cs typeface="CMU Serif" panose="02000603000000000000" pitchFamily="2" charset="0"/>
+              </a:endParaRPr>
+            </a:p>
+          </p:txBody>
+        </p:sp>
+        <p:cxnSp>
+          <p:nvCxnSpPr>
+            <p:cNvPr id="16" name="Gerade Verbindung mit Pfeil 15">
+              <a:extLst>
+                <a:ext uri="{FF2B5EF4-FFF2-40B4-BE49-F238E27FC236}">
+                  <a16:creationId xmlns:a16="http://schemas.microsoft.com/office/drawing/2014/main" id="{7A57D2B5-9CE0-448C-383B-ECE2F76F4BFC}"/>
+                </a:ext>
+              </a:extLst>
+            </p:cNvPr>
+            <p:cNvCxnSpPr>
+              <a:cxnSpLocks/>
+            </p:cNvCxnSpPr>
+            <p:nvPr/>
+          </p:nvCxnSpPr>
+          <p:spPr>
+            <a:xfrm>
+              <a:off x="1986603" y="1145144"/>
+              <a:ext cx="50477" cy="0"/>
+            </a:xfrm>
+            <a:prstGeom prst="straightConnector1">
+              <a:avLst/>
+            </a:prstGeom>
+            <a:ln w="3175" cap="rnd">
+              <a:solidFill>
+                <a:srgbClr val="0070C0"/>
+              </a:solidFill>
+              <a:round/>
+              <a:headEnd type="none"/>
+              <a:tailEnd type="none" w="sm" len="med"/>
+            </a:ln>
+          </p:spPr>
+          <p:style>
+            <a:lnRef idx="2">
+              <a:schemeClr val="accent1"/>
+            </a:lnRef>
+            <a:fillRef idx="0">
+              <a:schemeClr val="accent1"/>
+            </a:fillRef>
+            <a:effectRef idx="1">
+              <a:schemeClr val="accent1"/>
+            </a:effectRef>
+            <a:fontRef idx="minor">
+              <a:schemeClr val="tx1"/>
+            </a:fontRef>
+          </p:style>
+        </p:cxnSp>
+      </p:grpSp>
+      <p:cxnSp>
+        <p:nvCxnSpPr>
+          <p:cNvPr id="18" name="Gerade Verbindung mit Pfeil 17">
+            <a:extLst>
+              <a:ext uri="{FF2B5EF4-FFF2-40B4-BE49-F238E27FC236}">
+                <a16:creationId xmlns:a16="http://schemas.microsoft.com/office/drawing/2014/main" id="{B4773D11-6518-9203-BCD5-8E82218822CA}"/>
+              </a:ext>
+            </a:extLst>
+          </p:cNvPr>
+          <p:cNvCxnSpPr>
+            <a:cxnSpLocks/>
+          </p:cNvCxnSpPr>
+          <p:nvPr/>
+        </p:nvCxnSpPr>
+        <p:spPr>
+          <a:xfrm flipV="1">
+            <a:off x="1591792" y="1854144"/>
+            <a:ext cx="77870" cy="281525"/>
+          </a:xfrm>
+          <a:prstGeom prst="straightConnector1">
+            <a:avLst/>
+          </a:prstGeom>
+          <a:ln w="6350" cap="rnd">
+            <a:solidFill>
+              <a:srgbClr val="0070C0"/>
+            </a:solidFill>
+            <a:round/>
+            <a:headEnd type="none"/>
+            <a:tailEnd type="none" w="med" len="med"/>
+          </a:ln>
+        </p:spPr>
+        <p:style>
+          <a:lnRef idx="2">
+            <a:schemeClr val="accent1"/>
+          </a:lnRef>
+          <a:fillRef idx="0">
+            <a:schemeClr val="accent1"/>
+          </a:fillRef>
+          <a:effectRef idx="1">
+            <a:schemeClr val="accent1"/>
+          </a:effectRef>
+          <a:fontRef idx="minor">
+            <a:schemeClr val="tx1"/>
+          </a:fontRef>
+        </p:style>
+      </p:cxnSp>
+    </p:spTree>
+    <p:extLst>
+      <p:ext uri="{BB962C8B-B14F-4D97-AF65-F5344CB8AC3E}">
+        <p14:creationId xmlns:p14="http://schemas.microsoft.com/office/powerpoint/2010/main" val="788328369"/>
       </p:ext>
     </p:extLst>
   </p:cSld>

</xml_diff>